<commit_message>
Add ogstun IP configurations to 5G_Core_Network/options.yaml, added support for 6-digit PLMNs, improved documentation
</commit_message>
<xml_diff>
--- a/RAN_Intelligent_Controllers/research/Diagrams.pptx
+++ b/RAN_Intelligent_Controllers/research/Diagrams.pptx
@@ -263,7 +263,7 @@
           <a:p>
             <a:fld id="{2D1DF383-F48D-4C35-882C-8A26F25E24F6}" type="datetimeFigureOut">
               <a:rPr lang="en-US" smtClean="0"/>
-              <a:t>3/26/2025</a:t>
+              <a:t>3/27/2025</a:t>
             </a:fld>
             <a:endParaRPr lang="en-US"/>
           </a:p>
@@ -461,7 +461,7 @@
           <a:p>
             <a:fld id="{2D1DF383-F48D-4C35-882C-8A26F25E24F6}" type="datetimeFigureOut">
               <a:rPr lang="en-US" smtClean="0"/>
-              <a:t>3/26/2025</a:t>
+              <a:t>3/27/2025</a:t>
             </a:fld>
             <a:endParaRPr lang="en-US"/>
           </a:p>
@@ -669,7 +669,7 @@
           <a:p>
             <a:fld id="{2D1DF383-F48D-4C35-882C-8A26F25E24F6}" type="datetimeFigureOut">
               <a:rPr lang="en-US" smtClean="0"/>
-              <a:t>3/26/2025</a:t>
+              <a:t>3/27/2025</a:t>
             </a:fld>
             <a:endParaRPr lang="en-US"/>
           </a:p>
@@ -867,7 +867,7 @@
           <a:p>
             <a:fld id="{2D1DF383-F48D-4C35-882C-8A26F25E24F6}" type="datetimeFigureOut">
               <a:rPr lang="en-US" smtClean="0"/>
-              <a:t>3/26/2025</a:t>
+              <a:t>3/27/2025</a:t>
             </a:fld>
             <a:endParaRPr lang="en-US"/>
           </a:p>
@@ -1142,7 +1142,7 @@
           <a:p>
             <a:fld id="{2D1DF383-F48D-4C35-882C-8A26F25E24F6}" type="datetimeFigureOut">
               <a:rPr lang="en-US" smtClean="0"/>
-              <a:t>3/26/2025</a:t>
+              <a:t>3/27/2025</a:t>
             </a:fld>
             <a:endParaRPr lang="en-US"/>
           </a:p>
@@ -1407,7 +1407,7 @@
           <a:p>
             <a:fld id="{2D1DF383-F48D-4C35-882C-8A26F25E24F6}" type="datetimeFigureOut">
               <a:rPr lang="en-US" smtClean="0"/>
-              <a:t>3/26/2025</a:t>
+              <a:t>3/27/2025</a:t>
             </a:fld>
             <a:endParaRPr lang="en-US"/>
           </a:p>
@@ -1819,7 +1819,7 @@
           <a:p>
             <a:fld id="{2D1DF383-F48D-4C35-882C-8A26F25E24F6}" type="datetimeFigureOut">
               <a:rPr lang="en-US" smtClean="0"/>
-              <a:t>3/26/2025</a:t>
+              <a:t>3/27/2025</a:t>
             </a:fld>
             <a:endParaRPr lang="en-US"/>
           </a:p>
@@ -1960,7 +1960,7 @@
           <a:p>
             <a:fld id="{2D1DF383-F48D-4C35-882C-8A26F25E24F6}" type="datetimeFigureOut">
               <a:rPr lang="en-US" smtClean="0"/>
-              <a:t>3/26/2025</a:t>
+              <a:t>3/27/2025</a:t>
             </a:fld>
             <a:endParaRPr lang="en-US"/>
           </a:p>
@@ -2073,7 +2073,7 @@
           <a:p>
             <a:fld id="{2D1DF383-F48D-4C35-882C-8A26F25E24F6}" type="datetimeFigureOut">
               <a:rPr lang="en-US" smtClean="0"/>
-              <a:t>3/26/2025</a:t>
+              <a:t>3/27/2025</a:t>
             </a:fld>
             <a:endParaRPr lang="en-US"/>
           </a:p>
@@ -2384,7 +2384,7 @@
           <a:p>
             <a:fld id="{2D1DF383-F48D-4C35-882C-8A26F25E24F6}" type="datetimeFigureOut">
               <a:rPr lang="en-US" smtClean="0"/>
-              <a:t>3/26/2025</a:t>
+              <a:t>3/27/2025</a:t>
             </a:fld>
             <a:endParaRPr lang="en-US"/>
           </a:p>
@@ -2672,7 +2672,7 @@
           <a:p>
             <a:fld id="{2D1DF383-F48D-4C35-882C-8A26F25E24F6}" type="datetimeFigureOut">
               <a:rPr lang="en-US" smtClean="0"/>
-              <a:t>3/26/2025</a:t>
+              <a:t>3/27/2025</a:t>
             </a:fld>
             <a:endParaRPr lang="en-US"/>
           </a:p>
@@ -2913,7 +2913,7 @@
           <a:p>
             <a:fld id="{2D1DF383-F48D-4C35-882C-8A26F25E24F6}" type="datetimeFigureOut">
               <a:rPr lang="en-US" smtClean="0"/>
-              <a:t>3/26/2025</a:t>
+              <a:t>3/27/2025</a:t>
             </a:fld>
             <a:endParaRPr lang="en-US"/>
           </a:p>
@@ -12055,7 +12055,7 @@
             </a:prstGeom>
             <a:ln w="12700">
               <a:solidFill>
-                <a:srgbClr val="FF0000"/>
+                <a:srgbClr val="C40E00"/>
               </a:solidFill>
               <a:prstDash val="sysDot"/>
             </a:ln>
@@ -14839,7 +14839,7 @@
               </a:prstGeom>
               <a:ln w="12700">
                 <a:solidFill>
-                  <a:srgbClr val="FF0000"/>
+                  <a:srgbClr val="C40E00"/>
                 </a:solidFill>
                 <a:prstDash val="sysDot"/>
               </a:ln>
@@ -15070,7 +15070,7 @@
               </a:prstGeom>
               <a:ln w="12700">
                 <a:solidFill>
-                  <a:srgbClr val="FF0000"/>
+                  <a:srgbClr val="FF7B61"/>
                 </a:solidFill>
                 <a:prstDash val="sysDot"/>
               </a:ln>
@@ -16079,7 +16079,7 @@
                 </a:prstGeom>
                 <a:ln w="12700">
                   <a:solidFill>
-                    <a:srgbClr val="FF0000"/>
+                    <a:srgbClr val="FF7B61"/>
                   </a:solidFill>
                   <a:prstDash val="sysDot"/>
                 </a:ln>

</xml_diff>

<commit_message>
Update testbed with latest dashboard and patches
</commit_message>
<xml_diff>
--- a/RAN_Intelligent_Controllers/research/Diagrams.pptx
+++ b/RAN_Intelligent_Controllers/research/Diagrams.pptx
@@ -263,7 +263,7 @@
           <a:p>
             <a:fld id="{2D1DF383-F48D-4C35-882C-8A26F25E24F6}" type="datetimeFigureOut">
               <a:rPr lang="en-US" smtClean="0"/>
-              <a:t>4/3/2025</a:t>
+              <a:t>4/29/2025</a:t>
             </a:fld>
             <a:endParaRPr lang="en-US"/>
           </a:p>
@@ -461,7 +461,7 @@
           <a:p>
             <a:fld id="{2D1DF383-F48D-4C35-882C-8A26F25E24F6}" type="datetimeFigureOut">
               <a:rPr lang="en-US" smtClean="0"/>
-              <a:t>4/3/2025</a:t>
+              <a:t>4/29/2025</a:t>
             </a:fld>
             <a:endParaRPr lang="en-US"/>
           </a:p>
@@ -669,7 +669,7 @@
           <a:p>
             <a:fld id="{2D1DF383-F48D-4C35-882C-8A26F25E24F6}" type="datetimeFigureOut">
               <a:rPr lang="en-US" smtClean="0"/>
-              <a:t>4/3/2025</a:t>
+              <a:t>4/29/2025</a:t>
             </a:fld>
             <a:endParaRPr lang="en-US"/>
           </a:p>
@@ -867,7 +867,7 @@
           <a:p>
             <a:fld id="{2D1DF383-F48D-4C35-882C-8A26F25E24F6}" type="datetimeFigureOut">
               <a:rPr lang="en-US" smtClean="0"/>
-              <a:t>4/3/2025</a:t>
+              <a:t>4/29/2025</a:t>
             </a:fld>
             <a:endParaRPr lang="en-US"/>
           </a:p>
@@ -1142,7 +1142,7 @@
           <a:p>
             <a:fld id="{2D1DF383-F48D-4C35-882C-8A26F25E24F6}" type="datetimeFigureOut">
               <a:rPr lang="en-US" smtClean="0"/>
-              <a:t>4/3/2025</a:t>
+              <a:t>4/29/2025</a:t>
             </a:fld>
             <a:endParaRPr lang="en-US"/>
           </a:p>
@@ -1407,7 +1407,7 @@
           <a:p>
             <a:fld id="{2D1DF383-F48D-4C35-882C-8A26F25E24F6}" type="datetimeFigureOut">
               <a:rPr lang="en-US" smtClean="0"/>
-              <a:t>4/3/2025</a:t>
+              <a:t>4/29/2025</a:t>
             </a:fld>
             <a:endParaRPr lang="en-US"/>
           </a:p>
@@ -1819,7 +1819,7 @@
           <a:p>
             <a:fld id="{2D1DF383-F48D-4C35-882C-8A26F25E24F6}" type="datetimeFigureOut">
               <a:rPr lang="en-US" smtClean="0"/>
-              <a:t>4/3/2025</a:t>
+              <a:t>4/29/2025</a:t>
             </a:fld>
             <a:endParaRPr lang="en-US"/>
           </a:p>
@@ -1960,7 +1960,7 @@
           <a:p>
             <a:fld id="{2D1DF383-F48D-4C35-882C-8A26F25E24F6}" type="datetimeFigureOut">
               <a:rPr lang="en-US" smtClean="0"/>
-              <a:t>4/3/2025</a:t>
+              <a:t>4/29/2025</a:t>
             </a:fld>
             <a:endParaRPr lang="en-US"/>
           </a:p>
@@ -2073,7 +2073,7 @@
           <a:p>
             <a:fld id="{2D1DF383-F48D-4C35-882C-8A26F25E24F6}" type="datetimeFigureOut">
               <a:rPr lang="en-US" smtClean="0"/>
-              <a:t>4/3/2025</a:t>
+              <a:t>4/29/2025</a:t>
             </a:fld>
             <a:endParaRPr lang="en-US"/>
           </a:p>
@@ -2384,7 +2384,7 @@
           <a:p>
             <a:fld id="{2D1DF383-F48D-4C35-882C-8A26F25E24F6}" type="datetimeFigureOut">
               <a:rPr lang="en-US" smtClean="0"/>
-              <a:t>4/3/2025</a:t>
+              <a:t>4/29/2025</a:t>
             </a:fld>
             <a:endParaRPr lang="en-US"/>
           </a:p>
@@ -2672,7 +2672,7 @@
           <a:p>
             <a:fld id="{2D1DF383-F48D-4C35-882C-8A26F25E24F6}" type="datetimeFigureOut">
               <a:rPr lang="en-US" smtClean="0"/>
-              <a:t>4/3/2025</a:t>
+              <a:t>4/29/2025</a:t>
             </a:fld>
             <a:endParaRPr lang="en-US"/>
           </a:p>
@@ -2913,7 +2913,7 @@
           <a:p>
             <a:fld id="{2D1DF383-F48D-4C35-882C-8A26F25E24F6}" type="datetimeFigureOut">
               <a:rPr lang="en-US" smtClean="0"/>
-              <a:t>4/3/2025</a:t>
+              <a:t>4/29/2025</a:t>
             </a:fld>
             <a:endParaRPr lang="en-US"/>
           </a:p>
@@ -6002,7 +6002,7 @@
                     <a:latin typeface="Times New Roman" panose="02020603050405020304" pitchFamily="18" charset="0"/>
                     <a:cs typeface="Times New Roman" panose="02020603050405020304" pitchFamily="18" charset="0"/>
                   </a:rPr>
-                  <a:t>Policy</a:t>
+                  <a:t>A1 Policy</a:t>
                 </a:r>
                 <a:endParaRPr lang="en-US" sz="1200" i="1" dirty="0">
                   <a:latin typeface="Times New Roman" panose="02020603050405020304" pitchFamily="18" charset="0"/>
@@ -6026,7 +6026,7 @@
             <p:spPr>
               <a:xfrm>
                 <a:off x="6407418" y="3202655"/>
-                <a:ext cx="621711" cy="461665"/>
+                <a:ext cx="2184599" cy="461665"/>
               </a:xfrm>
               <a:prstGeom prst="rect">
                 <a:avLst/>
@@ -6047,17 +6047,10 @@
                     <a:latin typeface="Times New Roman" panose="02020603050405020304" pitchFamily="18" charset="0"/>
                     <a:cs typeface="Times New Roman" panose="02020603050405020304" pitchFamily="18" charset="0"/>
                   </a:rPr>
-                  <a:t>RC</a:t>
+                  <a:t>Key Performance Measurement</a:t>
                 </a:r>
-                <a:br>
-                  <a:rPr lang="en-US" sz="1200" i="1" dirty="0">
-                    <a:solidFill>
-                      <a:schemeClr val="tx1"/>
-                    </a:solidFill>
-                    <a:latin typeface="Times New Roman" panose="02020603050405020304" pitchFamily="18" charset="0"/>
-                    <a:cs typeface="Times New Roman" panose="02020603050405020304" pitchFamily="18" charset="0"/>
-                  </a:rPr>
-                </a:br>
+              </a:p>
+              <a:p>
                 <a:r>
                   <a:rPr lang="en-US" sz="1200" i="1" dirty="0">
                     <a:solidFill>
@@ -6066,7 +6059,7 @@
                     <a:latin typeface="Times New Roman" panose="02020603050405020304" pitchFamily="18" charset="0"/>
                     <a:cs typeface="Times New Roman" panose="02020603050405020304" pitchFamily="18" charset="0"/>
                   </a:rPr>
-                  <a:t>KPM</a:t>
+                  <a:t>RAN Control</a:t>
                 </a:r>
                 <a:endParaRPr lang="en-US" sz="1200" i="1" dirty="0">
                   <a:latin typeface="Times New Roman" panose="02020603050405020304" pitchFamily="18" charset="0"/>
@@ -6196,7 +6189,7 @@
                       <a:latin typeface="Times New Roman" panose="02020603050405020304" pitchFamily="18" charset="0"/>
                       <a:cs typeface="Times New Roman" panose="02020603050405020304" pitchFamily="18" charset="0"/>
                     </a:rPr>
-                    <a:t>KPI Monitor</a:t>
+                    <a:t>KPM Monitor</a:t>
                   </a:r>
                   <a:endParaRPr lang="en-US" sz="1400" dirty="0">
                     <a:latin typeface="Times New Roman" panose="02020603050405020304" pitchFamily="18" charset="0"/>
@@ -10362,7 +10355,7 @@
             <p:spPr>
               <a:xfrm>
                 <a:off x="6407418" y="3202655"/>
-                <a:ext cx="621711" cy="461665"/>
+                <a:ext cx="2184599" cy="461665"/>
               </a:xfrm>
               <a:prstGeom prst="rect">
                 <a:avLst/>
@@ -10383,17 +10376,10 @@
                     <a:latin typeface="Times New Roman" panose="02020603050405020304" pitchFamily="18" charset="0"/>
                     <a:cs typeface="Times New Roman" panose="02020603050405020304" pitchFamily="18" charset="0"/>
                   </a:rPr>
-                  <a:t>RC</a:t>
+                  <a:t>Key Performance Measurement</a:t>
                 </a:r>
-                <a:br>
-                  <a:rPr lang="en-US" sz="1200" i="1" dirty="0">
-                    <a:solidFill>
-                      <a:schemeClr val="bg1"/>
-                    </a:solidFill>
-                    <a:latin typeface="Times New Roman" panose="02020603050405020304" pitchFamily="18" charset="0"/>
-                    <a:cs typeface="Times New Roman" panose="02020603050405020304" pitchFamily="18" charset="0"/>
-                  </a:rPr>
-                </a:br>
+              </a:p>
+              <a:p>
                 <a:r>
                   <a:rPr lang="en-US" sz="1200" i="1" dirty="0">
                     <a:solidFill>
@@ -10402,7 +10388,7 @@
                     <a:latin typeface="Times New Roman" panose="02020603050405020304" pitchFamily="18" charset="0"/>
                     <a:cs typeface="Times New Roman" panose="02020603050405020304" pitchFamily="18" charset="0"/>
                   </a:rPr>
-                  <a:t>KPM</a:t>
+                  <a:t>RAN Control</a:t>
                 </a:r>
               </a:p>
             </p:txBody>
@@ -10530,7 +10516,7 @@
                       <a:latin typeface="Times New Roman" panose="02020603050405020304" pitchFamily="18" charset="0"/>
                       <a:cs typeface="Times New Roman" panose="02020603050405020304" pitchFamily="18" charset="0"/>
                     </a:rPr>
-                    <a:t>KPI Monitor</a:t>
+                    <a:t>KPM Monitor</a:t>
                   </a:r>
                 </a:p>
               </p:txBody>
@@ -11953,10 +11939,10 @@
       </p:grpSpPr>
       <p:grpSp>
         <p:nvGrpSpPr>
-          <p:cNvPr id="15" name="Group 14">
+          <p:cNvPr id="268" name="Group 267">
             <a:extLst>
               <a:ext uri="{FF2B5EF4-FFF2-40B4-BE49-F238E27FC236}">
-                <a16:creationId xmlns:a16="http://schemas.microsoft.com/office/drawing/2014/main" id="{5277176F-FC8F-52B9-D803-65D9E27547F1}"/>
+                <a16:creationId xmlns:a16="http://schemas.microsoft.com/office/drawing/2014/main" id="{8F3BE6CA-7DE7-0289-6F16-C0A8B58E71BF}"/>
               </a:ext>
             </a:extLst>
           </p:cNvPr>
@@ -12041,14 +12027,14 @@
             </p:cNvPr>
             <p:cNvCxnSpPr>
               <a:cxnSpLocks/>
-              <a:endCxn id="137" idx="1"/>
+              <a:endCxn id="237" idx="1"/>
             </p:cNvCxnSpPr>
             <p:nvPr/>
           </p:nvCxnSpPr>
           <p:spPr>
             <a:xfrm>
               <a:off x="5943801" y="3107001"/>
-              <a:ext cx="554158" cy="139732"/>
+              <a:ext cx="554157" cy="139349"/>
             </a:xfrm>
             <a:prstGeom prst="line">
               <a:avLst/>
@@ -12090,9 +12076,9 @@
           <p:grpSpPr>
             <a:xfrm>
               <a:off x="6498724" y="2172257"/>
-              <a:ext cx="2302213" cy="647296"/>
+              <a:ext cx="2302213" cy="609196"/>
               <a:chOff x="7063677" y="4951549"/>
-              <a:chExt cx="2302213" cy="647296"/>
+              <a:chExt cx="2302213" cy="609196"/>
             </a:xfrm>
           </p:grpSpPr>
           <p:grpSp>
@@ -12240,7 +12226,7 @@
             </p:nvSpPr>
             <p:spPr>
               <a:xfrm>
-                <a:off x="7126641" y="5291068"/>
+                <a:off x="7126641" y="5252968"/>
                 <a:ext cx="2239249" cy="307777"/>
               </a:xfrm>
               <a:prstGeom prst="rect">
@@ -12512,15 +12498,15 @@
             </p:cNvPr>
             <p:cNvCxnSpPr>
               <a:cxnSpLocks/>
-              <a:stCxn id="137" idx="3"/>
+              <a:stCxn id="237" idx="3"/>
               <a:endCxn id="315" idx="1"/>
             </p:cNvCxnSpPr>
             <p:nvPr/>
           </p:nvCxnSpPr>
           <p:spPr>
             <a:xfrm>
-              <a:off x="8737209" y="3246733"/>
-              <a:ext cx="639701" cy="277076"/>
+              <a:off x="8737207" y="3246350"/>
+              <a:ext cx="639703" cy="290794"/>
             </a:xfrm>
             <a:prstGeom prst="line">
               <a:avLst/>
@@ -12529,6 +12515,7 @@
               <a:solidFill>
                 <a:schemeClr val="tx1"/>
               </a:solidFill>
+              <a:prstDash val="sysDot"/>
             </a:ln>
           </p:spPr>
           <p:style>
@@ -12647,14 +12634,14 @@
             </p:cNvPr>
             <p:cNvCxnSpPr>
               <a:cxnSpLocks/>
-              <a:endCxn id="137" idx="1"/>
+              <a:endCxn id="237" idx="1"/>
             </p:cNvCxnSpPr>
             <p:nvPr/>
           </p:nvCxnSpPr>
           <p:spPr>
             <a:xfrm>
               <a:off x="5943801" y="2493651"/>
-              <a:ext cx="554158" cy="753082"/>
+              <a:ext cx="554157" cy="752699"/>
             </a:xfrm>
             <a:prstGeom prst="line">
               <a:avLst/>
@@ -12691,14 +12678,14 @@
             </p:cNvPr>
             <p:cNvCxnSpPr>
               <a:cxnSpLocks/>
-              <a:endCxn id="139" idx="1"/>
+              <a:endCxn id="236" idx="1"/>
             </p:cNvCxnSpPr>
             <p:nvPr/>
           </p:nvCxnSpPr>
           <p:spPr>
             <a:xfrm>
               <a:off x="5943801" y="3107001"/>
-              <a:ext cx="554158" cy="442679"/>
+              <a:ext cx="554157" cy="438375"/>
             </a:xfrm>
             <a:prstGeom prst="line">
               <a:avLst/>
@@ -12736,14 +12723,14 @@
             <p:cNvCxnSpPr>
               <a:cxnSpLocks/>
               <a:stCxn id="277" idx="3"/>
-              <a:endCxn id="137" idx="1"/>
+              <a:endCxn id="237" idx="1"/>
             </p:cNvCxnSpPr>
             <p:nvPr/>
           </p:nvCxnSpPr>
           <p:spPr>
             <a:xfrm flipV="1">
-              <a:off x="5817331" y="3246733"/>
-              <a:ext cx="680628" cy="312286"/>
+              <a:off x="5817331" y="3246350"/>
+              <a:ext cx="680627" cy="312669"/>
             </a:xfrm>
             <a:prstGeom prst="line">
               <a:avLst/>
@@ -12780,14 +12767,14 @@
             </p:cNvPr>
             <p:cNvCxnSpPr>
               <a:cxnSpLocks/>
-              <a:endCxn id="139" idx="1"/>
+              <a:endCxn id="236" idx="1"/>
             </p:cNvCxnSpPr>
             <p:nvPr/>
           </p:nvCxnSpPr>
           <p:spPr>
             <a:xfrm>
               <a:off x="5943801" y="2493651"/>
-              <a:ext cx="554158" cy="1056029"/>
+              <a:ext cx="554157" cy="1051725"/>
             </a:xfrm>
             <a:prstGeom prst="line">
               <a:avLst/>
@@ -14045,380 +14032,6 @@
         </p:grpSp>
         <p:grpSp>
           <p:nvGrpSpPr>
-            <p:cNvPr id="294" name="Group 293">
-              <a:extLst>
-                <a:ext uri="{FF2B5EF4-FFF2-40B4-BE49-F238E27FC236}">
-                  <a16:creationId xmlns:a16="http://schemas.microsoft.com/office/drawing/2014/main" id="{7F0217C1-27AC-0AE9-0AB2-B6739AA10A59}"/>
-                </a:ext>
-              </a:extLst>
-            </p:cNvPr>
-            <p:cNvGrpSpPr/>
-            <p:nvPr/>
-          </p:nvGrpSpPr>
-          <p:grpSpPr>
-            <a:xfrm>
-              <a:off x="6497959" y="3084878"/>
-              <a:ext cx="2239250" cy="930533"/>
-              <a:chOff x="6696060" y="5146289"/>
-              <a:chExt cx="2239250" cy="930533"/>
-            </a:xfrm>
-          </p:grpSpPr>
-          <p:grpSp>
-            <p:nvGrpSpPr>
-              <p:cNvPr id="282" name="Group 281">
-                <a:extLst>
-                  <a:ext uri="{FF2B5EF4-FFF2-40B4-BE49-F238E27FC236}">
-                    <a16:creationId xmlns:a16="http://schemas.microsoft.com/office/drawing/2014/main" id="{10760A10-5230-083D-FCAE-497AD888B029}"/>
-                  </a:ext>
-                </a:extLst>
-              </p:cNvPr>
-              <p:cNvGrpSpPr/>
-              <p:nvPr/>
-            </p:nvGrpSpPr>
-            <p:grpSpPr>
-              <a:xfrm>
-                <a:off x="6696060" y="5146289"/>
-                <a:ext cx="2239250" cy="618690"/>
-                <a:chOff x="6808092" y="5153909"/>
-                <a:chExt cx="2239250" cy="618690"/>
-              </a:xfrm>
-            </p:grpSpPr>
-            <p:grpSp>
-              <p:nvGrpSpPr>
-                <p:cNvPr id="136" name="Group 135">
-                  <a:extLst>
-                    <a:ext uri="{FF2B5EF4-FFF2-40B4-BE49-F238E27FC236}">
-                      <a16:creationId xmlns:a16="http://schemas.microsoft.com/office/drawing/2014/main" id="{841B9809-A189-561B-4300-1452E248F236}"/>
-                    </a:ext>
-                  </a:extLst>
-                </p:cNvPr>
-                <p:cNvGrpSpPr/>
-                <p:nvPr/>
-              </p:nvGrpSpPr>
-              <p:grpSpPr>
-                <a:xfrm>
-                  <a:off x="6808092" y="5153909"/>
-                  <a:ext cx="2239249" cy="618690"/>
-                  <a:chOff x="4021891" y="2194877"/>
-                  <a:chExt cx="2239249" cy="618690"/>
-                </a:xfrm>
-              </p:grpSpPr>
-              <p:sp>
-                <p:nvSpPr>
-                  <p:cNvPr id="141" name="Rectangle: Rounded Corners 140">
-                    <a:extLst>
-                      <a:ext uri="{FF2B5EF4-FFF2-40B4-BE49-F238E27FC236}">
-                        <a16:creationId xmlns:a16="http://schemas.microsoft.com/office/drawing/2014/main" id="{3F2A5807-4769-53A4-4C75-D528398D2568}"/>
-                      </a:ext>
-                    </a:extLst>
-                  </p:cNvPr>
-                  <p:cNvSpPr/>
-                  <p:nvPr/>
-                </p:nvSpPr>
-                <p:spPr>
-                  <a:xfrm>
-                    <a:off x="4021891" y="2194877"/>
-                    <a:ext cx="2239249" cy="618689"/>
-                  </a:xfrm>
-                  <a:prstGeom prst="roundRect">
-                    <a:avLst>
-                      <a:gd name="adj" fmla="val 12974"/>
-                    </a:avLst>
-                  </a:prstGeom>
-                  <a:solidFill>
-                    <a:schemeClr val="bg1">
-                      <a:lumMod val="85000"/>
-                    </a:schemeClr>
-                  </a:solidFill>
-                  <a:ln w="28575">
-                    <a:noFill/>
-                  </a:ln>
-                </p:spPr>
-                <p:style>
-                  <a:lnRef idx="2">
-                    <a:schemeClr val="accent1">
-                      <a:shade val="15000"/>
-                    </a:schemeClr>
-                  </a:lnRef>
-                  <a:fillRef idx="1">
-                    <a:schemeClr val="accent1"/>
-                  </a:fillRef>
-                  <a:effectRef idx="0">
-                    <a:schemeClr val="accent1"/>
-                  </a:effectRef>
-                  <a:fontRef idx="minor">
-                    <a:schemeClr val="lt1"/>
-                  </a:fontRef>
-                </p:style>
-                <p:txBody>
-                  <a:bodyPr rtlCol="0" anchor="ctr"/>
-                  <a:lstStyle/>
-                  <a:p>
-                    <a:pPr algn="ctr"/>
-                    <a:endParaRPr lang="en-US" dirty="0">
-                      <a:latin typeface="Times New Roman" panose="02020603050405020304" pitchFamily="18" charset="0"/>
-                      <a:cs typeface="Times New Roman" panose="02020603050405020304" pitchFamily="18" charset="0"/>
-                    </a:endParaRPr>
-                  </a:p>
-                </p:txBody>
-              </p:sp>
-              <p:sp>
-                <p:nvSpPr>
-                  <p:cNvPr id="142" name="Rectangle: Top Corners Rounded 141">
-                    <a:extLst>
-                      <a:ext uri="{FF2B5EF4-FFF2-40B4-BE49-F238E27FC236}">
-                        <a16:creationId xmlns:a16="http://schemas.microsoft.com/office/drawing/2014/main" id="{BFBE2C83-3F94-BEC1-509A-666E953B5AE3}"/>
-                      </a:ext>
-                    </a:extLst>
-                  </p:cNvPr>
-                  <p:cNvSpPr/>
-                  <p:nvPr/>
-                </p:nvSpPr>
-                <p:spPr>
-                  <a:xfrm flipV="1">
-                    <a:off x="4022672" y="2504431"/>
-                    <a:ext cx="2238468" cy="307778"/>
-                  </a:xfrm>
-                  <a:prstGeom prst="round2SameRect">
-                    <a:avLst>
-                      <a:gd name="adj1" fmla="val 28674"/>
-                      <a:gd name="adj2" fmla="val 0"/>
-                    </a:avLst>
-                  </a:prstGeom>
-                  <a:solidFill>
-                    <a:schemeClr val="bg1">
-                      <a:lumMod val="95000"/>
-                    </a:schemeClr>
-                  </a:solidFill>
-                  <a:ln>
-                    <a:noFill/>
-                  </a:ln>
-                </p:spPr>
-                <p:style>
-                  <a:lnRef idx="2">
-                    <a:schemeClr val="accent1">
-                      <a:shade val="15000"/>
-                    </a:schemeClr>
-                  </a:lnRef>
-                  <a:fillRef idx="1">
-                    <a:schemeClr val="accent1"/>
-                  </a:fillRef>
-                  <a:effectRef idx="0">
-                    <a:schemeClr val="accent1"/>
-                  </a:effectRef>
-                  <a:fontRef idx="minor">
-                    <a:schemeClr val="lt1"/>
-                  </a:fontRef>
-                </p:style>
-                <p:txBody>
-                  <a:bodyPr rtlCol="0" anchor="ctr"/>
-                  <a:lstStyle/>
-                  <a:p>
-                    <a:pPr algn="ctr"/>
-                    <a:endParaRPr lang="en-US"/>
-                  </a:p>
-                </p:txBody>
-              </p:sp>
-              <p:sp>
-                <p:nvSpPr>
-                  <p:cNvPr id="143" name="Rectangle: Rounded Corners 142">
-                    <a:extLst>
-                      <a:ext uri="{FF2B5EF4-FFF2-40B4-BE49-F238E27FC236}">
-                        <a16:creationId xmlns:a16="http://schemas.microsoft.com/office/drawing/2014/main" id="{BE57BFF5-2C67-F628-A5CE-99608F010250}"/>
-                      </a:ext>
-                    </a:extLst>
-                  </p:cNvPr>
-                  <p:cNvSpPr/>
-                  <p:nvPr/>
-                </p:nvSpPr>
-                <p:spPr>
-                  <a:xfrm>
-                    <a:off x="4021891" y="2194878"/>
-                    <a:ext cx="2239249" cy="618689"/>
-                  </a:xfrm>
-                  <a:prstGeom prst="roundRect">
-                    <a:avLst>
-                      <a:gd name="adj" fmla="val 12974"/>
-                    </a:avLst>
-                  </a:prstGeom>
-                  <a:noFill/>
-                  <a:ln w="12700">
-                    <a:solidFill>
-                      <a:schemeClr val="tx1"/>
-                    </a:solidFill>
-                  </a:ln>
-                </p:spPr>
-                <p:style>
-                  <a:lnRef idx="2">
-                    <a:schemeClr val="accent1">
-                      <a:shade val="15000"/>
-                    </a:schemeClr>
-                  </a:lnRef>
-                  <a:fillRef idx="1">
-                    <a:schemeClr val="accent1"/>
-                  </a:fillRef>
-                  <a:effectRef idx="0">
-                    <a:schemeClr val="accent1"/>
-                  </a:effectRef>
-                  <a:fontRef idx="minor">
-                    <a:schemeClr val="lt1"/>
-                  </a:fontRef>
-                </p:style>
-                <p:txBody>
-                  <a:bodyPr rtlCol="0" anchor="ctr"/>
-                  <a:lstStyle/>
-                  <a:p>
-                    <a:pPr algn="ctr"/>
-                    <a:endParaRPr lang="en-US" dirty="0">
-                      <a:latin typeface="Times New Roman" panose="02020603050405020304" pitchFamily="18" charset="0"/>
-                      <a:cs typeface="Times New Roman" panose="02020603050405020304" pitchFamily="18" charset="0"/>
-                    </a:endParaRPr>
-                  </a:p>
-                </p:txBody>
-              </p:sp>
-            </p:grpSp>
-            <p:sp>
-              <p:nvSpPr>
-                <p:cNvPr id="137" name="TextBox 136">
-                  <a:extLst>
-                    <a:ext uri="{FF2B5EF4-FFF2-40B4-BE49-F238E27FC236}">
-                      <a16:creationId xmlns:a16="http://schemas.microsoft.com/office/drawing/2014/main" id="{8E4086BF-90AE-16D0-B4BD-62589545315F}"/>
-                    </a:ext>
-                  </a:extLst>
-                </p:cNvPr>
-                <p:cNvSpPr txBox="1"/>
-                <p:nvPr/>
-              </p:nvSpPr>
-              <p:spPr>
-                <a:xfrm>
-                  <a:off x="6808092" y="5161875"/>
-                  <a:ext cx="2239250" cy="307777"/>
-                </a:xfrm>
-                <a:prstGeom prst="rect">
-                  <a:avLst/>
-                </a:prstGeom>
-                <a:noFill/>
-              </p:spPr>
-              <p:txBody>
-                <a:bodyPr wrap="square">
-                  <a:spAutoFit/>
-                </a:bodyPr>
-                <a:lstStyle/>
-                <a:p>
-                  <a:pPr algn="ctr"/>
-                  <a:r>
-                    <a:rPr lang="en-US" sz="1400" dirty="0">
-                      <a:solidFill>
-                        <a:schemeClr val="tx1"/>
-                      </a:solidFill>
-                      <a:latin typeface="Times New Roman" panose="02020603050405020304" pitchFamily="18" charset="0"/>
-                      <a:cs typeface="Times New Roman" panose="02020603050405020304" pitchFamily="18" charset="0"/>
-                    </a:rPr>
-                    <a:t>O-RAN SC : Near-RT RIC</a:t>
-                  </a:r>
-                  <a:endParaRPr lang="en-US" sz="1400" dirty="0">
-                    <a:latin typeface="Times New Roman" panose="02020603050405020304" pitchFamily="18" charset="0"/>
-                    <a:cs typeface="Times New Roman" panose="02020603050405020304" pitchFamily="18" charset="0"/>
-                  </a:endParaRPr>
-                </a:p>
-              </p:txBody>
-            </p:sp>
-            <p:sp>
-              <p:nvSpPr>
-                <p:cNvPr id="139" name="TextBox 138">
-                  <a:extLst>
-                    <a:ext uri="{FF2B5EF4-FFF2-40B4-BE49-F238E27FC236}">
-                      <a16:creationId xmlns:a16="http://schemas.microsoft.com/office/drawing/2014/main" id="{EBFB5C70-1560-E4FD-6B36-6B68117B7EA6}"/>
-                    </a:ext>
-                  </a:extLst>
-                </p:cNvPr>
-                <p:cNvSpPr txBox="1"/>
-                <p:nvPr/>
-              </p:nvSpPr>
-              <p:spPr>
-                <a:xfrm>
-                  <a:off x="6808092" y="5464822"/>
-                  <a:ext cx="2239250" cy="307777"/>
-                </a:xfrm>
-                <a:prstGeom prst="rect">
-                  <a:avLst/>
-                </a:prstGeom>
-                <a:noFill/>
-              </p:spPr>
-              <p:txBody>
-                <a:bodyPr wrap="square">
-                  <a:spAutoFit/>
-                </a:bodyPr>
-                <a:lstStyle/>
-                <a:p>
-                  <a:pPr algn="ctr"/>
-                  <a:r>
-                    <a:rPr lang="en-US" sz="1400" dirty="0">
-                      <a:solidFill>
-                        <a:schemeClr val="tx1"/>
-                      </a:solidFill>
-                      <a:latin typeface="Times New Roman" panose="02020603050405020304" pitchFamily="18" charset="0"/>
-                      <a:cs typeface="Times New Roman" panose="02020603050405020304" pitchFamily="18" charset="0"/>
-                    </a:rPr>
-                    <a:t>Mosaic5G : FlexRIC</a:t>
-                  </a:r>
-                  <a:endParaRPr lang="en-US" sz="1400" dirty="0">
-                    <a:latin typeface="Times New Roman" panose="02020603050405020304" pitchFamily="18" charset="0"/>
-                    <a:cs typeface="Times New Roman" panose="02020603050405020304" pitchFamily="18" charset="0"/>
-                  </a:endParaRPr>
-                </a:p>
-              </p:txBody>
-            </p:sp>
-          </p:grpSp>
-          <p:sp>
-            <p:nvSpPr>
-              <p:cNvPr id="283" name="TextBox 282">
-                <a:extLst>
-                  <a:ext uri="{FF2B5EF4-FFF2-40B4-BE49-F238E27FC236}">
-                    <a16:creationId xmlns:a16="http://schemas.microsoft.com/office/drawing/2014/main" id="{86324A6E-ABC2-1C25-09F7-5897B7BD58DD}"/>
-                  </a:ext>
-                </a:extLst>
-              </p:cNvPr>
-              <p:cNvSpPr txBox="1"/>
-              <p:nvPr/>
-            </p:nvSpPr>
-            <p:spPr>
-              <a:xfrm>
-                <a:off x="6696060" y="5769045"/>
-                <a:ext cx="2239249" cy="307777"/>
-              </a:xfrm>
-              <a:prstGeom prst="rect">
-                <a:avLst/>
-              </a:prstGeom>
-              <a:noFill/>
-            </p:spPr>
-            <p:txBody>
-              <a:bodyPr wrap="square">
-                <a:spAutoFit/>
-              </a:bodyPr>
-              <a:lstStyle/>
-              <a:p>
-                <a:pPr algn="ctr"/>
-                <a:r>
-                  <a:rPr lang="en-US" sz="1400" b="1" dirty="0">
-                    <a:solidFill>
-                      <a:schemeClr val="tx1"/>
-                    </a:solidFill>
-                    <a:latin typeface="Times New Roman" panose="02020603050405020304" pitchFamily="18" charset="0"/>
-                    <a:cs typeface="Times New Roman" panose="02020603050405020304" pitchFamily="18" charset="0"/>
-                  </a:rPr>
-                  <a:t>Near-RT RIC</a:t>
-                </a:r>
-                <a:endParaRPr lang="en-US" sz="1400" b="1" dirty="0">
-                  <a:latin typeface="Times New Roman" panose="02020603050405020304" pitchFamily="18" charset="0"/>
-                  <a:cs typeface="Times New Roman" panose="02020603050405020304" pitchFamily="18" charset="0"/>
-                </a:endParaRPr>
-              </a:p>
-            </p:txBody>
-          </p:sp>
-        </p:grpSp>
-        <p:grpSp>
-          <p:nvGrpSpPr>
             <p:cNvPr id="335" name="Group 334">
               <a:extLst>
                 <a:ext uri="{FF2B5EF4-FFF2-40B4-BE49-F238E27FC236}">
@@ -14515,7 +14128,7 @@
             </p:nvSpPr>
             <p:spPr>
               <a:xfrm>
-                <a:off x="9110915" y="4522182"/>
+                <a:off x="9110915" y="4535517"/>
                 <a:ext cx="2238468" cy="307777"/>
               </a:xfrm>
               <a:prstGeom prst="rect">
@@ -14906,6 +14519,440 @@
             </a:fontRef>
           </p:style>
         </p:cxnSp>
+        <p:grpSp>
+          <p:nvGrpSpPr>
+            <p:cNvPr id="233" name="Group 232">
+              <a:extLst>
+                <a:ext uri="{FF2B5EF4-FFF2-40B4-BE49-F238E27FC236}">
+                  <a16:creationId xmlns:a16="http://schemas.microsoft.com/office/drawing/2014/main" id="{00ED7F0F-60DC-1536-A747-6184C3BCA9BE}"/>
+                </a:ext>
+              </a:extLst>
+            </p:cNvPr>
+            <p:cNvGrpSpPr/>
+            <p:nvPr/>
+          </p:nvGrpSpPr>
+          <p:grpSpPr>
+            <a:xfrm>
+              <a:off x="6497958" y="2781548"/>
+              <a:ext cx="2239249" cy="1233863"/>
+              <a:chOff x="1028392" y="2318655"/>
+              <a:chExt cx="2239249" cy="1233863"/>
+            </a:xfrm>
+          </p:grpSpPr>
+          <p:sp>
+            <p:nvSpPr>
+              <p:cNvPr id="234" name="TextBox 233">
+                <a:extLst>
+                  <a:ext uri="{FF2B5EF4-FFF2-40B4-BE49-F238E27FC236}">
+                    <a16:creationId xmlns:a16="http://schemas.microsoft.com/office/drawing/2014/main" id="{1D447C6C-DBB4-1E2B-28C0-122262FFC526}"/>
+                  </a:ext>
+                </a:extLst>
+              </p:cNvPr>
+              <p:cNvSpPr txBox="1"/>
+              <p:nvPr/>
+            </p:nvSpPr>
+            <p:spPr>
+              <a:xfrm>
+                <a:off x="1028392" y="3244741"/>
+                <a:ext cx="2239249" cy="307777"/>
+              </a:xfrm>
+              <a:prstGeom prst="rect">
+                <a:avLst/>
+              </a:prstGeom>
+              <a:noFill/>
+            </p:spPr>
+            <p:txBody>
+              <a:bodyPr wrap="square">
+                <a:spAutoFit/>
+              </a:bodyPr>
+              <a:lstStyle/>
+              <a:p>
+                <a:pPr algn="ctr"/>
+                <a:r>
+                  <a:rPr lang="en-US" sz="1400" b="1" dirty="0">
+                    <a:solidFill>
+                      <a:schemeClr val="tx1"/>
+                    </a:solidFill>
+                    <a:latin typeface="Times New Roman" panose="02020603050405020304" pitchFamily="18" charset="0"/>
+                    <a:cs typeface="Times New Roman" panose="02020603050405020304" pitchFamily="18" charset="0"/>
+                  </a:rPr>
+                  <a:t>Near-RT RIC</a:t>
+                </a:r>
+                <a:endParaRPr lang="en-US" sz="1400" b="1" dirty="0">
+                  <a:latin typeface="Times New Roman" panose="02020603050405020304" pitchFamily="18" charset="0"/>
+                  <a:cs typeface="Times New Roman" panose="02020603050405020304" pitchFamily="18" charset="0"/>
+                </a:endParaRPr>
+              </a:p>
+            </p:txBody>
+          </p:sp>
+          <p:grpSp>
+            <p:nvGrpSpPr>
+              <p:cNvPr id="235" name="Group 234">
+                <a:extLst>
+                  <a:ext uri="{FF2B5EF4-FFF2-40B4-BE49-F238E27FC236}">
+                    <a16:creationId xmlns:a16="http://schemas.microsoft.com/office/drawing/2014/main" id="{D43FEA2F-F6B1-5C6E-588B-A05B26190774}"/>
+                  </a:ext>
+                </a:extLst>
+              </p:cNvPr>
+              <p:cNvGrpSpPr/>
+              <p:nvPr/>
+            </p:nvGrpSpPr>
+            <p:grpSpPr>
+              <a:xfrm>
+                <a:off x="1028392" y="2318655"/>
+                <a:ext cx="2239249" cy="923272"/>
+                <a:chOff x="1590040" y="5303322"/>
+                <a:chExt cx="2374765" cy="923272"/>
+              </a:xfrm>
+            </p:grpSpPr>
+            <p:sp>
+              <p:nvSpPr>
+                <p:cNvPr id="239" name="Rectangle: Rounded Corners 238">
+                  <a:extLst>
+                    <a:ext uri="{FF2B5EF4-FFF2-40B4-BE49-F238E27FC236}">
+                      <a16:creationId xmlns:a16="http://schemas.microsoft.com/office/drawing/2014/main" id="{A4D60007-5474-BEA2-4BFA-9BC486259CA7}"/>
+                    </a:ext>
+                  </a:extLst>
+                </p:cNvPr>
+                <p:cNvSpPr/>
+                <p:nvPr/>
+              </p:nvSpPr>
+              <p:spPr>
+                <a:xfrm>
+                  <a:off x="1590040" y="5303322"/>
+                  <a:ext cx="2374765" cy="923272"/>
+                </a:xfrm>
+                <a:prstGeom prst="roundRect">
+                  <a:avLst>
+                    <a:gd name="adj" fmla="val 9466"/>
+                  </a:avLst>
+                </a:prstGeom>
+                <a:solidFill>
+                  <a:schemeClr val="bg1">
+                    <a:lumMod val="85000"/>
+                  </a:schemeClr>
+                </a:solidFill>
+                <a:ln w="28575">
+                  <a:noFill/>
+                </a:ln>
+              </p:spPr>
+              <p:style>
+                <a:lnRef idx="2">
+                  <a:schemeClr val="accent1">
+                    <a:shade val="15000"/>
+                  </a:schemeClr>
+                </a:lnRef>
+                <a:fillRef idx="1">
+                  <a:schemeClr val="accent1"/>
+                </a:fillRef>
+                <a:effectRef idx="0">
+                  <a:schemeClr val="accent1"/>
+                </a:effectRef>
+                <a:fontRef idx="minor">
+                  <a:schemeClr val="lt1"/>
+                </a:fontRef>
+              </p:style>
+              <p:txBody>
+                <a:bodyPr rtlCol="0" anchor="ctr"/>
+                <a:lstStyle/>
+                <a:p>
+                  <a:pPr algn="ctr"/>
+                  <a:endParaRPr lang="en-US" dirty="0">
+                    <a:latin typeface="Times New Roman" panose="02020603050405020304" pitchFamily="18" charset="0"/>
+                    <a:cs typeface="Times New Roman" panose="02020603050405020304" pitchFamily="18" charset="0"/>
+                  </a:endParaRPr>
+                </a:p>
+              </p:txBody>
+            </p:sp>
+            <p:sp>
+              <p:nvSpPr>
+                <p:cNvPr id="240" name="Rectangle 239">
+                  <a:extLst>
+                    <a:ext uri="{FF2B5EF4-FFF2-40B4-BE49-F238E27FC236}">
+                      <a16:creationId xmlns:a16="http://schemas.microsoft.com/office/drawing/2014/main" id="{664D770F-BF79-4EE6-E4F3-5C75388C93E3}"/>
+                    </a:ext>
+                  </a:extLst>
+                </p:cNvPr>
+                <p:cNvSpPr/>
+                <p:nvPr/>
+              </p:nvSpPr>
+              <p:spPr>
+                <a:xfrm>
+                  <a:off x="1590040" y="5603165"/>
+                  <a:ext cx="2374765" cy="323587"/>
+                </a:xfrm>
+                <a:prstGeom prst="rect">
+                  <a:avLst/>
+                </a:prstGeom>
+                <a:solidFill>
+                  <a:schemeClr val="bg1">
+                    <a:lumMod val="95000"/>
+                  </a:schemeClr>
+                </a:solidFill>
+                <a:ln>
+                  <a:noFill/>
+                </a:ln>
+              </p:spPr>
+              <p:style>
+                <a:lnRef idx="2">
+                  <a:schemeClr val="accent1">
+                    <a:shade val="15000"/>
+                  </a:schemeClr>
+                </a:lnRef>
+                <a:fillRef idx="1">
+                  <a:schemeClr val="accent1"/>
+                </a:fillRef>
+                <a:effectRef idx="0">
+                  <a:schemeClr val="accent1"/>
+                </a:effectRef>
+                <a:fontRef idx="minor">
+                  <a:schemeClr val="lt1"/>
+                </a:fontRef>
+              </p:style>
+              <p:txBody>
+                <a:bodyPr rtlCol="0" anchor="ctr"/>
+                <a:lstStyle/>
+                <a:p>
+                  <a:pPr algn="ctr"/>
+                  <a:endParaRPr lang="en-US"/>
+                </a:p>
+              </p:txBody>
+            </p:sp>
+            <p:sp>
+              <p:nvSpPr>
+                <p:cNvPr id="241" name="Rectangle: Rounded Corners 240">
+                  <a:extLst>
+                    <a:ext uri="{FF2B5EF4-FFF2-40B4-BE49-F238E27FC236}">
+                      <a16:creationId xmlns:a16="http://schemas.microsoft.com/office/drawing/2014/main" id="{A848D181-7B55-B5B1-5BAE-AF8A42EC5A00}"/>
+                    </a:ext>
+                  </a:extLst>
+                </p:cNvPr>
+                <p:cNvSpPr/>
+                <p:nvPr/>
+              </p:nvSpPr>
+              <p:spPr>
+                <a:xfrm>
+                  <a:off x="1590040" y="5303322"/>
+                  <a:ext cx="2374765" cy="923272"/>
+                </a:xfrm>
+                <a:prstGeom prst="roundRect">
+                  <a:avLst>
+                    <a:gd name="adj" fmla="val 9879"/>
+                  </a:avLst>
+                </a:prstGeom>
+                <a:noFill/>
+                <a:ln w="12700">
+                  <a:solidFill>
+                    <a:schemeClr val="tx1"/>
+                  </a:solidFill>
+                </a:ln>
+              </p:spPr>
+              <p:style>
+                <a:lnRef idx="2">
+                  <a:schemeClr val="accent1">
+                    <a:shade val="15000"/>
+                  </a:schemeClr>
+                </a:lnRef>
+                <a:fillRef idx="1">
+                  <a:schemeClr val="accent1"/>
+                </a:fillRef>
+                <a:effectRef idx="0">
+                  <a:schemeClr val="accent1"/>
+                </a:effectRef>
+                <a:fontRef idx="minor">
+                  <a:schemeClr val="lt1"/>
+                </a:fontRef>
+              </p:style>
+              <p:txBody>
+                <a:bodyPr rtlCol="0" anchor="ctr"/>
+                <a:lstStyle/>
+                <a:p>
+                  <a:pPr algn="ctr"/>
+                  <a:endParaRPr lang="en-US" dirty="0">
+                    <a:latin typeface="Times New Roman" panose="02020603050405020304" pitchFamily="18" charset="0"/>
+                    <a:cs typeface="Times New Roman" panose="02020603050405020304" pitchFamily="18" charset="0"/>
+                  </a:endParaRPr>
+                </a:p>
+              </p:txBody>
+            </p:sp>
+          </p:grpSp>
+          <p:sp>
+            <p:nvSpPr>
+              <p:cNvPr id="236" name="TextBox 235">
+                <a:extLst>
+                  <a:ext uri="{FF2B5EF4-FFF2-40B4-BE49-F238E27FC236}">
+                    <a16:creationId xmlns:a16="http://schemas.microsoft.com/office/drawing/2014/main" id="{A60306A6-CD1B-62E6-4CD0-FA864383631B}"/>
+                  </a:ext>
+                </a:extLst>
+              </p:cNvPr>
+              <p:cNvSpPr txBox="1"/>
+              <p:nvPr/>
+            </p:nvSpPr>
+            <p:spPr>
+              <a:xfrm>
+                <a:off x="1028392" y="2928594"/>
+                <a:ext cx="2239249" cy="307777"/>
+              </a:xfrm>
+              <a:prstGeom prst="rect">
+                <a:avLst/>
+              </a:prstGeom>
+              <a:noFill/>
+            </p:spPr>
+            <p:txBody>
+              <a:bodyPr wrap="square">
+                <a:spAutoFit/>
+              </a:bodyPr>
+              <a:lstStyle/>
+              <a:p>
+                <a:pPr algn="ctr"/>
+                <a:r>
+                  <a:rPr lang="en-US" sz="1400" dirty="0">
+                    <a:solidFill>
+                      <a:schemeClr val="tx1"/>
+                    </a:solidFill>
+                    <a:latin typeface="Times New Roman" panose="02020603050405020304" pitchFamily="18" charset="0"/>
+                    <a:cs typeface="Times New Roman" panose="02020603050405020304" pitchFamily="18" charset="0"/>
+                  </a:rPr>
+                  <a:t>Mosaic5G : FlexRIC</a:t>
+                </a:r>
+                <a:endParaRPr lang="en-US" sz="1400" dirty="0">
+                  <a:latin typeface="Times New Roman" panose="02020603050405020304" pitchFamily="18" charset="0"/>
+                  <a:cs typeface="Times New Roman" panose="02020603050405020304" pitchFamily="18" charset="0"/>
+                </a:endParaRPr>
+              </a:p>
+            </p:txBody>
+          </p:sp>
+          <p:sp>
+            <p:nvSpPr>
+              <p:cNvPr id="237" name="TextBox 236">
+                <a:extLst>
+                  <a:ext uri="{FF2B5EF4-FFF2-40B4-BE49-F238E27FC236}">
+                    <a16:creationId xmlns:a16="http://schemas.microsoft.com/office/drawing/2014/main" id="{B43BC923-2C5D-2AAE-BD1F-3637CD533B4A}"/>
+                  </a:ext>
+                </a:extLst>
+              </p:cNvPr>
+              <p:cNvSpPr txBox="1"/>
+              <p:nvPr/>
+            </p:nvSpPr>
+            <p:spPr>
+              <a:xfrm>
+                <a:off x="1028392" y="2629568"/>
+                <a:ext cx="2239249" cy="307777"/>
+              </a:xfrm>
+              <a:prstGeom prst="rect">
+                <a:avLst/>
+              </a:prstGeom>
+              <a:noFill/>
+            </p:spPr>
+            <p:txBody>
+              <a:bodyPr wrap="square">
+                <a:spAutoFit/>
+              </a:bodyPr>
+              <a:lstStyle/>
+              <a:p>
+                <a:pPr algn="ctr"/>
+                <a:r>
+                  <a:rPr lang="en-US" sz="1400" dirty="0">
+                    <a:solidFill>
+                      <a:schemeClr val="tx1"/>
+                    </a:solidFill>
+                    <a:latin typeface="Times New Roman" panose="02020603050405020304" pitchFamily="18" charset="0"/>
+                    <a:cs typeface="Times New Roman" panose="02020603050405020304" pitchFamily="18" charset="0"/>
+                  </a:rPr>
+                  <a:t>O-RAN SC : Near-RT RIC</a:t>
+                </a:r>
+                <a:endParaRPr lang="en-US" sz="1400" dirty="0">
+                  <a:latin typeface="Times New Roman" panose="02020603050405020304" pitchFamily="18" charset="0"/>
+                  <a:cs typeface="Times New Roman" panose="02020603050405020304" pitchFamily="18" charset="0"/>
+                </a:endParaRPr>
+              </a:p>
+            </p:txBody>
+          </p:sp>
+          <p:sp>
+            <p:nvSpPr>
+              <p:cNvPr id="238" name="TextBox 237">
+                <a:extLst>
+                  <a:ext uri="{FF2B5EF4-FFF2-40B4-BE49-F238E27FC236}">
+                    <a16:creationId xmlns:a16="http://schemas.microsoft.com/office/drawing/2014/main" id="{01F21BA0-7B22-2985-C4B7-BEC32317C4DA}"/>
+                  </a:ext>
+                </a:extLst>
+              </p:cNvPr>
+              <p:cNvSpPr txBox="1"/>
+              <p:nvPr/>
+            </p:nvSpPr>
+            <p:spPr>
+              <a:xfrm>
+                <a:off x="1028392" y="2330542"/>
+                <a:ext cx="2239249" cy="307777"/>
+              </a:xfrm>
+              <a:prstGeom prst="rect">
+                <a:avLst/>
+              </a:prstGeom>
+              <a:noFill/>
+            </p:spPr>
+            <p:txBody>
+              <a:bodyPr wrap="square">
+                <a:spAutoFit/>
+              </a:bodyPr>
+              <a:lstStyle/>
+              <a:p>
+                <a:pPr algn="ctr"/>
+                <a:r>
+                  <a:rPr lang="en-US" sz="1400" dirty="0">
+                    <a:latin typeface="Times New Roman" panose="02020603050405020304" pitchFamily="18" charset="0"/>
+                    <a:cs typeface="Times New Roman" panose="02020603050405020304" pitchFamily="18" charset="0"/>
+                  </a:rPr>
+                  <a:t>O-RAN SC : A1 Simulator</a:t>
+                </a:r>
+              </a:p>
+            </p:txBody>
+          </p:sp>
+        </p:grpSp>
+        <p:cxnSp>
+          <p:nvCxnSpPr>
+            <p:cNvPr id="255" name="Straight Connector 254">
+              <a:extLst>
+                <a:ext uri="{FF2B5EF4-FFF2-40B4-BE49-F238E27FC236}">
+                  <a16:creationId xmlns:a16="http://schemas.microsoft.com/office/drawing/2014/main" id="{91DD07F7-2F86-0E54-F54F-7BDC7A59D6BD}"/>
+                </a:ext>
+              </a:extLst>
+            </p:cNvPr>
+            <p:cNvCxnSpPr>
+              <a:cxnSpLocks/>
+              <a:stCxn id="238" idx="3"/>
+              <a:endCxn id="315" idx="1"/>
+            </p:cNvCxnSpPr>
+            <p:nvPr/>
+          </p:nvCxnSpPr>
+          <p:spPr>
+            <a:xfrm>
+              <a:off x="8737207" y="2947324"/>
+              <a:ext cx="639703" cy="589820"/>
+            </a:xfrm>
+            <a:prstGeom prst="line">
+              <a:avLst/>
+            </a:prstGeom>
+            <a:ln w="12700">
+              <a:solidFill>
+                <a:schemeClr val="tx1"/>
+              </a:solidFill>
+            </a:ln>
+          </p:spPr>
+          <p:style>
+            <a:lnRef idx="2">
+              <a:schemeClr val="accent1"/>
+            </a:lnRef>
+            <a:fillRef idx="0">
+              <a:schemeClr val="accent1"/>
+            </a:fillRef>
+            <a:effectRef idx="1">
+              <a:schemeClr val="accent1"/>
+            </a:effectRef>
+            <a:fontRef idx="minor">
+              <a:schemeClr val="tx1"/>
+            </a:fontRef>
+          </p:style>
+        </p:cxnSp>
       </p:grpSp>
     </p:spTree>
     <p:extLst>
@@ -14994,10 +15041,10 @@
       </p:sp>
       <p:grpSp>
         <p:nvGrpSpPr>
-          <p:cNvPr id="71" name="Group 70">
+          <p:cNvPr id="90" name="Group 89">
             <a:extLst>
               <a:ext uri="{FF2B5EF4-FFF2-40B4-BE49-F238E27FC236}">
-                <a16:creationId xmlns:a16="http://schemas.microsoft.com/office/drawing/2014/main" id="{985DB30F-01F0-302E-005C-3A0C3D22E960}"/>
+                <a16:creationId xmlns:a16="http://schemas.microsoft.com/office/drawing/2014/main" id="{E8E01907-679C-CCC9-D3A2-B1DF57432798}"/>
               </a:ext>
             </a:extLst>
           </p:cNvPr>
@@ -15082,7 +15129,6 @@
             </p:cNvPr>
             <p:cNvCxnSpPr>
               <a:cxnSpLocks/>
-              <a:endCxn id="35" idx="1"/>
             </p:cNvCxnSpPr>
             <p:nvPr/>
           </p:nvCxnSpPr>
@@ -15118,10 +15164,10 @@
         </p:cxnSp>
         <p:grpSp>
           <p:nvGrpSpPr>
-            <p:cNvPr id="9" name="Group 8">
+            <p:cNvPr id="67" name="Group 66">
               <a:extLst>
                 <a:ext uri="{FF2B5EF4-FFF2-40B4-BE49-F238E27FC236}">
-                  <a16:creationId xmlns:a16="http://schemas.microsoft.com/office/drawing/2014/main" id="{316BC739-B35F-85FE-983B-5189F671AA40}"/>
+                  <a16:creationId xmlns:a16="http://schemas.microsoft.com/office/drawing/2014/main" id="{94C82875-16D7-328F-D44F-2C1A08F28D46}"/>
                 </a:ext>
               </a:extLst>
             </p:cNvPr>
@@ -15131,145 +15177,79 @@
           <p:grpSpPr>
             <a:xfrm>
               <a:off x="6498724" y="2172257"/>
-              <a:ext cx="2302213" cy="647296"/>
-              <a:chOff x="7063677" y="4951549"/>
-              <a:chExt cx="2302213" cy="647296"/>
+              <a:ext cx="2239251" cy="333931"/>
+              <a:chOff x="7168594" y="4200673"/>
+              <a:chExt cx="2239251" cy="299842"/>
             </a:xfrm>
           </p:grpSpPr>
-          <p:grpSp>
-            <p:nvGrpSpPr>
-              <p:cNvPr id="67" name="Group 66">
+          <p:sp>
+            <p:nvSpPr>
+              <p:cNvPr id="69" name="Rectangle: Rounded Corners 68">
                 <a:extLst>
                   <a:ext uri="{FF2B5EF4-FFF2-40B4-BE49-F238E27FC236}">
-                    <a16:creationId xmlns:a16="http://schemas.microsoft.com/office/drawing/2014/main" id="{94C82875-16D7-328F-D44F-2C1A08F28D46}"/>
+                    <a16:creationId xmlns:a16="http://schemas.microsoft.com/office/drawing/2014/main" id="{E3E5506D-785E-C802-0B5C-83BCF4D57BC8}"/>
                   </a:ext>
                 </a:extLst>
               </p:cNvPr>
-              <p:cNvGrpSpPr/>
+              <p:cNvSpPr/>
               <p:nvPr/>
-            </p:nvGrpSpPr>
-            <p:grpSpPr>
+            </p:nvSpPr>
+            <p:spPr>
               <a:xfrm>
-                <a:off x="7063677" y="4951549"/>
-                <a:ext cx="2239251" cy="333931"/>
-                <a:chOff x="7168594" y="4200673"/>
-                <a:chExt cx="2239251" cy="299842"/>
+                <a:off x="7168596" y="4200673"/>
+                <a:ext cx="2239249" cy="299842"/>
               </a:xfrm>
-            </p:grpSpPr>
-            <p:sp>
-              <p:nvSpPr>
-                <p:cNvPr id="69" name="Rectangle: Rounded Corners 68">
-                  <a:extLst>
-                    <a:ext uri="{FF2B5EF4-FFF2-40B4-BE49-F238E27FC236}">
-                      <a16:creationId xmlns:a16="http://schemas.microsoft.com/office/drawing/2014/main" id="{E3E5506D-785E-C802-0B5C-83BCF4D57BC8}"/>
-                    </a:ext>
-                  </a:extLst>
-                </p:cNvPr>
-                <p:cNvSpPr/>
-                <p:nvPr/>
-              </p:nvSpPr>
-              <p:spPr>
-                <a:xfrm>
-                  <a:off x="7168596" y="4200673"/>
-                  <a:ext cx="2239249" cy="299842"/>
-                </a:xfrm>
-                <a:prstGeom prst="roundRect">
-                  <a:avLst>
-                    <a:gd name="adj" fmla="val 28947"/>
-                  </a:avLst>
-                </a:prstGeom>
+              <a:prstGeom prst="roundRect">
+                <a:avLst>
+                  <a:gd name="adj" fmla="val 28947"/>
+                </a:avLst>
+              </a:prstGeom>
+              <a:solidFill>
+                <a:srgbClr val="262626"/>
+              </a:solidFill>
+              <a:ln w="12700">
                 <a:solidFill>
-                  <a:srgbClr val="262626"/>
+                  <a:schemeClr val="bg1"/>
                 </a:solidFill>
-                <a:ln w="12700">
+              </a:ln>
+            </p:spPr>
+            <p:style>
+              <a:lnRef idx="2">
+                <a:schemeClr val="accent1">
+                  <a:shade val="15000"/>
+                </a:schemeClr>
+              </a:lnRef>
+              <a:fillRef idx="1">
+                <a:schemeClr val="accent1"/>
+              </a:fillRef>
+              <a:effectRef idx="0">
+                <a:schemeClr val="accent1"/>
+              </a:effectRef>
+              <a:fontRef idx="minor">
+                <a:schemeClr val="lt1"/>
+              </a:fontRef>
+            </p:style>
+            <p:txBody>
+              <a:bodyPr rtlCol="0" anchor="ctr"/>
+              <a:lstStyle/>
+              <a:p>
+                <a:pPr algn="ctr"/>
+                <a:endParaRPr lang="en-US" sz="1400" dirty="0">
                   <a:solidFill>
-                    <a:schemeClr val="bg1"/>
+                    <a:schemeClr val="tx1"/>
                   </a:solidFill>
-                </a:ln>
-              </p:spPr>
-              <p:style>
-                <a:lnRef idx="2">
-                  <a:schemeClr val="accent1">
-                    <a:shade val="15000"/>
-                  </a:schemeClr>
-                </a:lnRef>
-                <a:fillRef idx="1">
-                  <a:schemeClr val="accent1"/>
-                </a:fillRef>
-                <a:effectRef idx="0">
-                  <a:schemeClr val="accent1"/>
-                </a:effectRef>
-                <a:fontRef idx="minor">
-                  <a:schemeClr val="lt1"/>
-                </a:fontRef>
-              </p:style>
-              <p:txBody>
-                <a:bodyPr rtlCol="0" anchor="ctr"/>
-                <a:lstStyle/>
-                <a:p>
-                  <a:pPr algn="ctr"/>
-                  <a:endParaRPr lang="en-US" sz="1400" dirty="0">
-                    <a:solidFill>
-                      <a:schemeClr val="tx1"/>
-                    </a:solidFill>
-                    <a:latin typeface="Times New Roman" panose="02020603050405020304" pitchFamily="18" charset="0"/>
-                    <a:cs typeface="Times New Roman" panose="02020603050405020304" pitchFamily="18" charset="0"/>
-                  </a:endParaRPr>
-                </a:p>
-              </p:txBody>
-            </p:sp>
-            <p:sp>
-              <p:nvSpPr>
-                <p:cNvPr id="70" name="TextBox 69">
-                  <a:extLst>
-                    <a:ext uri="{FF2B5EF4-FFF2-40B4-BE49-F238E27FC236}">
-                      <a16:creationId xmlns:a16="http://schemas.microsoft.com/office/drawing/2014/main" id="{A6BD8DC3-F519-6540-99EC-9071E4B84D62}"/>
-                    </a:ext>
-                  </a:extLst>
-                </p:cNvPr>
-                <p:cNvSpPr txBox="1"/>
-                <p:nvPr/>
-              </p:nvSpPr>
-              <p:spPr>
-                <a:xfrm>
-                  <a:off x="7168594" y="4201157"/>
-                  <a:ext cx="2238468" cy="276358"/>
-                </a:xfrm>
-                <a:prstGeom prst="rect">
-                  <a:avLst/>
-                </a:prstGeom>
-                <a:noFill/>
-                <a:ln w="12700">
-                  <a:noFill/>
-                </a:ln>
-              </p:spPr>
-              <p:txBody>
-                <a:bodyPr wrap="square">
-                  <a:spAutoFit/>
-                </a:bodyPr>
-                <a:lstStyle/>
-                <a:p>
-                  <a:pPr algn="ctr"/>
-                  <a:r>
-                    <a:rPr lang="en-US" sz="1400" dirty="0">
-                      <a:solidFill>
-                        <a:schemeClr val="bg1"/>
-                      </a:solidFill>
-                      <a:latin typeface="Times New Roman" panose="02020603050405020304" pitchFamily="18" charset="0"/>
-                      <a:cs typeface="Times New Roman" panose="02020603050405020304" pitchFamily="18" charset="0"/>
-                    </a:rPr>
-                    <a:t>Open5GS</a:t>
-                  </a:r>
-                </a:p>
-              </p:txBody>
-            </p:sp>
-          </p:grpSp>
+                  <a:latin typeface="Times New Roman" panose="02020603050405020304" pitchFamily="18" charset="0"/>
+                  <a:cs typeface="Times New Roman" panose="02020603050405020304" pitchFamily="18" charset="0"/>
+                </a:endParaRPr>
+              </a:p>
+            </p:txBody>
+          </p:sp>
           <p:sp>
             <p:nvSpPr>
-              <p:cNvPr id="68" name="TextBox 67">
+              <p:cNvPr id="70" name="TextBox 69">
                 <a:extLst>
                   <a:ext uri="{FF2B5EF4-FFF2-40B4-BE49-F238E27FC236}">
-                    <a16:creationId xmlns:a16="http://schemas.microsoft.com/office/drawing/2014/main" id="{94615E0D-4553-284E-CE2D-CF14F759AE84}"/>
+                    <a16:creationId xmlns:a16="http://schemas.microsoft.com/office/drawing/2014/main" id="{A6BD8DC3-F519-6540-99EC-9071E4B84D62}"/>
                   </a:ext>
                 </a:extLst>
               </p:cNvPr>
@@ -15278,13 +15258,16 @@
             </p:nvSpPr>
             <p:spPr>
               <a:xfrm>
-                <a:off x="7126641" y="5291068"/>
-                <a:ext cx="2239249" cy="307777"/>
+                <a:off x="7168594" y="4201157"/>
+                <a:ext cx="2238468" cy="276358"/>
               </a:xfrm>
               <a:prstGeom prst="rect">
                 <a:avLst/>
               </a:prstGeom>
               <a:noFill/>
+              <a:ln w="12700">
+                <a:noFill/>
+              </a:ln>
             </p:spPr>
             <p:txBody>
               <a:bodyPr wrap="square">
@@ -15294,14 +15277,14 @@
               <a:p>
                 <a:pPr algn="ctr"/>
                 <a:r>
-                  <a:rPr lang="en-US" sz="1400" b="1" dirty="0">
+                  <a:rPr lang="en-US" sz="1400" dirty="0">
                     <a:solidFill>
                       <a:schemeClr val="bg1"/>
                     </a:solidFill>
                     <a:latin typeface="Times New Roman" panose="02020603050405020304" pitchFamily="18" charset="0"/>
                     <a:cs typeface="Times New Roman" panose="02020603050405020304" pitchFamily="18" charset="0"/>
                   </a:rPr>
-                  <a:t>5G Core Network</a:t>
+                  <a:t>Open5GS</a:t>
                 </a:r>
               </a:p>
             </p:txBody>
@@ -15546,15 +15529,15 @@
             </p:cNvPr>
             <p:cNvCxnSpPr>
               <a:cxnSpLocks/>
-              <a:stCxn id="35" idx="3"/>
+              <a:stCxn id="81" idx="3"/>
               <a:endCxn id="30" idx="1"/>
             </p:cNvCxnSpPr>
             <p:nvPr/>
           </p:nvCxnSpPr>
           <p:spPr>
             <a:xfrm>
-              <a:off x="8737209" y="3256258"/>
-              <a:ext cx="639701" cy="267551"/>
+              <a:off x="8737207" y="3246350"/>
+              <a:ext cx="639703" cy="290794"/>
             </a:xfrm>
             <a:prstGeom prst="line">
               <a:avLst/>
@@ -15563,6 +15546,7 @@
               <a:solidFill>
                 <a:schemeClr val="bg1"/>
               </a:solidFill>
+              <a:prstDash val="sysDot"/>
             </a:ln>
           </p:spPr>
           <p:style>
@@ -15681,7 +15665,6 @@
             </p:cNvPr>
             <p:cNvCxnSpPr>
               <a:cxnSpLocks/>
-              <a:endCxn id="35" idx="1"/>
             </p:cNvCxnSpPr>
             <p:nvPr/>
           </p:nvCxnSpPr>
@@ -15725,7 +15708,6 @@
             </p:cNvPr>
             <p:cNvCxnSpPr>
               <a:cxnSpLocks/>
-              <a:endCxn id="36" idx="1"/>
             </p:cNvCxnSpPr>
             <p:nvPr/>
           </p:nvCxnSpPr>
@@ -15770,7 +15752,6 @@
             <p:cNvCxnSpPr>
               <a:cxnSpLocks/>
               <a:stCxn id="57" idx="3"/>
-              <a:endCxn id="35" idx="1"/>
             </p:cNvCxnSpPr>
             <p:nvPr/>
           </p:nvCxnSpPr>
@@ -15814,7 +15795,6 @@
             </p:cNvPr>
             <p:cNvCxnSpPr>
               <a:cxnSpLocks/>
-              <a:endCxn id="36" idx="1"/>
             </p:cNvCxnSpPr>
             <p:nvPr/>
           </p:nvCxnSpPr>
@@ -17378,364 +17358,6 @@
         </p:grpSp>
         <p:grpSp>
           <p:nvGrpSpPr>
-            <p:cNvPr id="27" name="Group 26">
-              <a:extLst>
-                <a:ext uri="{FF2B5EF4-FFF2-40B4-BE49-F238E27FC236}">
-                  <a16:creationId xmlns:a16="http://schemas.microsoft.com/office/drawing/2014/main" id="{5726D8C5-614D-56A4-C7DA-2AE1FE738FC2}"/>
-                </a:ext>
-              </a:extLst>
-            </p:cNvPr>
-            <p:cNvGrpSpPr/>
-            <p:nvPr/>
-          </p:nvGrpSpPr>
-          <p:grpSpPr>
-            <a:xfrm>
-              <a:off x="6497959" y="3084878"/>
-              <a:ext cx="2239250" cy="930533"/>
-              <a:chOff x="6696060" y="5146289"/>
-              <a:chExt cx="2239250" cy="930533"/>
-            </a:xfrm>
-          </p:grpSpPr>
-          <p:grpSp>
-            <p:nvGrpSpPr>
-              <p:cNvPr id="32" name="Group 31">
-                <a:extLst>
-                  <a:ext uri="{FF2B5EF4-FFF2-40B4-BE49-F238E27FC236}">
-                    <a16:creationId xmlns:a16="http://schemas.microsoft.com/office/drawing/2014/main" id="{820554D9-5169-E86E-F3E1-6FD7B1FB0948}"/>
-                  </a:ext>
-                </a:extLst>
-              </p:cNvPr>
-              <p:cNvGrpSpPr/>
-              <p:nvPr/>
-            </p:nvGrpSpPr>
-            <p:grpSpPr>
-              <a:xfrm>
-                <a:off x="6696060" y="5146289"/>
-                <a:ext cx="2239250" cy="618690"/>
-                <a:chOff x="6808092" y="5153909"/>
-                <a:chExt cx="2239250" cy="618690"/>
-              </a:xfrm>
-            </p:grpSpPr>
-            <p:grpSp>
-              <p:nvGrpSpPr>
-                <p:cNvPr id="34" name="Group 33">
-                  <a:extLst>
-                    <a:ext uri="{FF2B5EF4-FFF2-40B4-BE49-F238E27FC236}">
-                      <a16:creationId xmlns:a16="http://schemas.microsoft.com/office/drawing/2014/main" id="{0E46935C-6F39-D19A-CFCF-D62A86034828}"/>
-                    </a:ext>
-                  </a:extLst>
-                </p:cNvPr>
-                <p:cNvGrpSpPr/>
-                <p:nvPr/>
-              </p:nvGrpSpPr>
-              <p:grpSpPr>
-                <a:xfrm>
-                  <a:off x="6808092" y="5153909"/>
-                  <a:ext cx="2239249" cy="618690"/>
-                  <a:chOff x="4021891" y="2194877"/>
-                  <a:chExt cx="2239249" cy="618690"/>
-                </a:xfrm>
-              </p:grpSpPr>
-              <p:sp>
-                <p:nvSpPr>
-                  <p:cNvPr id="37" name="Rectangle: Rounded Corners 36">
-                    <a:extLst>
-                      <a:ext uri="{FF2B5EF4-FFF2-40B4-BE49-F238E27FC236}">
-                        <a16:creationId xmlns:a16="http://schemas.microsoft.com/office/drawing/2014/main" id="{2B8A2F6C-2A67-260F-6F24-A4C6D93DEC79}"/>
-                      </a:ext>
-                    </a:extLst>
-                  </p:cNvPr>
-                  <p:cNvSpPr/>
-                  <p:nvPr/>
-                </p:nvSpPr>
-                <p:spPr>
-                  <a:xfrm>
-                    <a:off x="4021891" y="2194877"/>
-                    <a:ext cx="2239249" cy="618689"/>
-                  </a:xfrm>
-                  <a:prstGeom prst="roundRect">
-                    <a:avLst>
-                      <a:gd name="adj" fmla="val 12974"/>
-                    </a:avLst>
-                  </a:prstGeom>
-                  <a:solidFill>
-                    <a:srgbClr val="262626"/>
-                  </a:solidFill>
-                  <a:ln w="28575">
-                    <a:noFill/>
-                  </a:ln>
-                </p:spPr>
-                <p:style>
-                  <a:lnRef idx="2">
-                    <a:schemeClr val="accent1">
-                      <a:shade val="15000"/>
-                    </a:schemeClr>
-                  </a:lnRef>
-                  <a:fillRef idx="1">
-                    <a:schemeClr val="accent1"/>
-                  </a:fillRef>
-                  <a:effectRef idx="0">
-                    <a:schemeClr val="accent1"/>
-                  </a:effectRef>
-                  <a:fontRef idx="minor">
-                    <a:schemeClr val="lt1"/>
-                  </a:fontRef>
-                </p:style>
-                <p:txBody>
-                  <a:bodyPr rtlCol="0" anchor="ctr"/>
-                  <a:lstStyle/>
-                  <a:p>
-                    <a:pPr algn="ctr"/>
-                    <a:endParaRPr lang="en-US" dirty="0">
-                      <a:latin typeface="Times New Roman" panose="02020603050405020304" pitchFamily="18" charset="0"/>
-                      <a:cs typeface="Times New Roman" panose="02020603050405020304" pitchFamily="18" charset="0"/>
-                    </a:endParaRPr>
-                  </a:p>
-                </p:txBody>
-              </p:sp>
-              <p:sp>
-                <p:nvSpPr>
-                  <p:cNvPr id="38" name="Rectangle: Top Corners Rounded 37">
-                    <a:extLst>
-                      <a:ext uri="{FF2B5EF4-FFF2-40B4-BE49-F238E27FC236}">
-                        <a16:creationId xmlns:a16="http://schemas.microsoft.com/office/drawing/2014/main" id="{DF0159E4-F128-74A1-8A96-41E2DB712167}"/>
-                      </a:ext>
-                    </a:extLst>
-                  </p:cNvPr>
-                  <p:cNvSpPr/>
-                  <p:nvPr/>
-                </p:nvSpPr>
-                <p:spPr>
-                  <a:xfrm flipV="1">
-                    <a:off x="4022672" y="2504431"/>
-                    <a:ext cx="2238468" cy="307778"/>
-                  </a:xfrm>
-                  <a:prstGeom prst="round2SameRect">
-                    <a:avLst>
-                      <a:gd name="adj1" fmla="val 28674"/>
-                      <a:gd name="adj2" fmla="val 0"/>
-                    </a:avLst>
-                  </a:prstGeom>
-                  <a:solidFill>
-                    <a:srgbClr val="3A3A3A"/>
-                  </a:solidFill>
-                  <a:ln>
-                    <a:noFill/>
-                  </a:ln>
-                </p:spPr>
-                <p:style>
-                  <a:lnRef idx="2">
-                    <a:schemeClr val="accent1">
-                      <a:shade val="15000"/>
-                    </a:schemeClr>
-                  </a:lnRef>
-                  <a:fillRef idx="1">
-                    <a:schemeClr val="accent1"/>
-                  </a:fillRef>
-                  <a:effectRef idx="0">
-                    <a:schemeClr val="accent1"/>
-                  </a:effectRef>
-                  <a:fontRef idx="minor">
-                    <a:schemeClr val="lt1"/>
-                  </a:fontRef>
-                </p:style>
-                <p:txBody>
-                  <a:bodyPr rtlCol="0" anchor="ctr"/>
-                  <a:lstStyle/>
-                  <a:p>
-                    <a:pPr algn="ctr"/>
-                    <a:endParaRPr lang="en-US"/>
-                  </a:p>
-                </p:txBody>
-              </p:sp>
-              <p:sp>
-                <p:nvSpPr>
-                  <p:cNvPr id="39" name="Rectangle: Rounded Corners 38">
-                    <a:extLst>
-                      <a:ext uri="{FF2B5EF4-FFF2-40B4-BE49-F238E27FC236}">
-                        <a16:creationId xmlns:a16="http://schemas.microsoft.com/office/drawing/2014/main" id="{B5C5DF2A-4F80-58F0-7F14-9A6CAA7EA5E2}"/>
-                      </a:ext>
-                    </a:extLst>
-                  </p:cNvPr>
-                  <p:cNvSpPr/>
-                  <p:nvPr/>
-                </p:nvSpPr>
-                <p:spPr>
-                  <a:xfrm>
-                    <a:off x="4021891" y="2194878"/>
-                    <a:ext cx="2239249" cy="618689"/>
-                  </a:xfrm>
-                  <a:prstGeom prst="roundRect">
-                    <a:avLst>
-                      <a:gd name="adj" fmla="val 12974"/>
-                    </a:avLst>
-                  </a:prstGeom>
-                  <a:noFill/>
-                  <a:ln w="12700">
-                    <a:solidFill>
-                      <a:schemeClr val="bg1"/>
-                    </a:solidFill>
-                  </a:ln>
-                </p:spPr>
-                <p:style>
-                  <a:lnRef idx="2">
-                    <a:schemeClr val="accent1">
-                      <a:shade val="15000"/>
-                    </a:schemeClr>
-                  </a:lnRef>
-                  <a:fillRef idx="1">
-                    <a:schemeClr val="accent1"/>
-                  </a:fillRef>
-                  <a:effectRef idx="0">
-                    <a:schemeClr val="accent1"/>
-                  </a:effectRef>
-                  <a:fontRef idx="minor">
-                    <a:schemeClr val="lt1"/>
-                  </a:fontRef>
-                </p:style>
-                <p:txBody>
-                  <a:bodyPr rtlCol="0" anchor="ctr"/>
-                  <a:lstStyle/>
-                  <a:p>
-                    <a:pPr algn="ctr"/>
-                    <a:endParaRPr lang="en-US" dirty="0">
-                      <a:latin typeface="Times New Roman" panose="02020603050405020304" pitchFamily="18" charset="0"/>
-                      <a:cs typeface="Times New Roman" panose="02020603050405020304" pitchFamily="18" charset="0"/>
-                    </a:endParaRPr>
-                  </a:p>
-                </p:txBody>
-              </p:sp>
-            </p:grpSp>
-            <p:sp>
-              <p:nvSpPr>
-                <p:cNvPr id="35" name="TextBox 34">
-                  <a:extLst>
-                    <a:ext uri="{FF2B5EF4-FFF2-40B4-BE49-F238E27FC236}">
-                      <a16:creationId xmlns:a16="http://schemas.microsoft.com/office/drawing/2014/main" id="{3DB1D612-0DA6-DFDD-7974-3E9354FCC1D8}"/>
-                    </a:ext>
-                  </a:extLst>
-                </p:cNvPr>
-                <p:cNvSpPr txBox="1"/>
-                <p:nvPr/>
-              </p:nvSpPr>
-              <p:spPr>
-                <a:xfrm>
-                  <a:off x="6808092" y="5171400"/>
-                  <a:ext cx="2239250" cy="307777"/>
-                </a:xfrm>
-                <a:prstGeom prst="rect">
-                  <a:avLst/>
-                </a:prstGeom>
-                <a:noFill/>
-              </p:spPr>
-              <p:txBody>
-                <a:bodyPr wrap="square">
-                  <a:spAutoFit/>
-                </a:bodyPr>
-                <a:lstStyle/>
-                <a:p>
-                  <a:pPr algn="ctr"/>
-                  <a:r>
-                    <a:rPr lang="en-US" sz="1400" dirty="0">
-                      <a:solidFill>
-                        <a:schemeClr val="bg1"/>
-                      </a:solidFill>
-                      <a:latin typeface="Times New Roman" panose="02020603050405020304" pitchFamily="18" charset="0"/>
-                      <a:cs typeface="Times New Roman" panose="02020603050405020304" pitchFamily="18" charset="0"/>
-                    </a:rPr>
-                    <a:t>O-RAN SC : Near-RT RIC</a:t>
-                  </a:r>
-                </a:p>
-              </p:txBody>
-            </p:sp>
-            <p:sp>
-              <p:nvSpPr>
-                <p:cNvPr id="36" name="TextBox 35">
-                  <a:extLst>
-                    <a:ext uri="{FF2B5EF4-FFF2-40B4-BE49-F238E27FC236}">
-                      <a16:creationId xmlns:a16="http://schemas.microsoft.com/office/drawing/2014/main" id="{9F749793-5D51-05F0-271A-74342A22925C}"/>
-                    </a:ext>
-                  </a:extLst>
-                </p:cNvPr>
-                <p:cNvSpPr txBox="1"/>
-                <p:nvPr/>
-              </p:nvSpPr>
-              <p:spPr>
-                <a:xfrm>
-                  <a:off x="6808092" y="5464822"/>
-                  <a:ext cx="2239250" cy="307777"/>
-                </a:xfrm>
-                <a:prstGeom prst="rect">
-                  <a:avLst/>
-                </a:prstGeom>
-                <a:noFill/>
-              </p:spPr>
-              <p:txBody>
-                <a:bodyPr wrap="square">
-                  <a:spAutoFit/>
-                </a:bodyPr>
-                <a:lstStyle/>
-                <a:p>
-                  <a:pPr algn="ctr"/>
-                  <a:r>
-                    <a:rPr lang="en-US" sz="1400" dirty="0">
-                      <a:solidFill>
-                        <a:schemeClr val="bg1"/>
-                      </a:solidFill>
-                      <a:latin typeface="Times New Roman" panose="02020603050405020304" pitchFamily="18" charset="0"/>
-                      <a:cs typeface="Times New Roman" panose="02020603050405020304" pitchFamily="18" charset="0"/>
-                    </a:rPr>
-                    <a:t>Mosaic5G : FlexRIC</a:t>
-                  </a:r>
-                </a:p>
-              </p:txBody>
-            </p:sp>
-          </p:grpSp>
-          <p:sp>
-            <p:nvSpPr>
-              <p:cNvPr id="33" name="TextBox 32">
-                <a:extLst>
-                  <a:ext uri="{FF2B5EF4-FFF2-40B4-BE49-F238E27FC236}">
-                    <a16:creationId xmlns:a16="http://schemas.microsoft.com/office/drawing/2014/main" id="{26B54E29-6558-EF44-CA43-59C6ECE36CDF}"/>
-                  </a:ext>
-                </a:extLst>
-              </p:cNvPr>
-              <p:cNvSpPr txBox="1"/>
-              <p:nvPr/>
-            </p:nvSpPr>
-            <p:spPr>
-              <a:xfrm>
-                <a:off x="6696060" y="5769045"/>
-                <a:ext cx="2239249" cy="307777"/>
-              </a:xfrm>
-              <a:prstGeom prst="rect">
-                <a:avLst/>
-              </a:prstGeom>
-              <a:noFill/>
-            </p:spPr>
-            <p:txBody>
-              <a:bodyPr wrap="square">
-                <a:spAutoFit/>
-              </a:bodyPr>
-              <a:lstStyle/>
-              <a:p>
-                <a:pPr algn="ctr"/>
-                <a:r>
-                  <a:rPr lang="en-US" sz="1400" b="1" dirty="0">
-                    <a:solidFill>
-                      <a:schemeClr val="bg1"/>
-                    </a:solidFill>
-                    <a:latin typeface="Times New Roman" panose="02020603050405020304" pitchFamily="18" charset="0"/>
-                    <a:cs typeface="Times New Roman" panose="02020603050405020304" pitchFamily="18" charset="0"/>
-                  </a:rPr>
-                  <a:t>Near-RT RIC</a:t>
-                </a:r>
-              </a:p>
-            </p:txBody>
-          </p:sp>
-        </p:grpSp>
-        <p:grpSp>
-          <p:nvGrpSpPr>
             <p:cNvPr id="28" name="Group 27">
               <a:extLst>
                 <a:ext uri="{FF2B5EF4-FFF2-40B4-BE49-F238E27FC236}">
@@ -17830,7 +17452,7 @@
             </p:nvSpPr>
             <p:spPr>
               <a:xfrm>
-                <a:off x="9110915" y="4522182"/>
+                <a:off x="9110915" y="4535517"/>
                 <a:ext cx="2238468" cy="307777"/>
               </a:xfrm>
               <a:prstGeom prst="rect">
@@ -17947,6 +17569,469 @@
             </a:fontRef>
           </p:style>
         </p:cxnSp>
+        <p:grpSp>
+          <p:nvGrpSpPr>
+            <p:cNvPr id="77" name="Group 76">
+              <a:extLst>
+                <a:ext uri="{FF2B5EF4-FFF2-40B4-BE49-F238E27FC236}">
+                  <a16:creationId xmlns:a16="http://schemas.microsoft.com/office/drawing/2014/main" id="{4F0FF1D2-F883-D4BA-E0FF-D67304C298C7}"/>
+                </a:ext>
+              </a:extLst>
+            </p:cNvPr>
+            <p:cNvGrpSpPr/>
+            <p:nvPr/>
+          </p:nvGrpSpPr>
+          <p:grpSpPr>
+            <a:xfrm>
+              <a:off x="6496054" y="2781548"/>
+              <a:ext cx="2241153" cy="1233863"/>
+              <a:chOff x="1026488" y="2318655"/>
+              <a:chExt cx="2241153" cy="1233863"/>
+            </a:xfrm>
+          </p:grpSpPr>
+          <p:sp>
+            <p:nvSpPr>
+              <p:cNvPr id="78" name="TextBox 77">
+                <a:extLst>
+                  <a:ext uri="{FF2B5EF4-FFF2-40B4-BE49-F238E27FC236}">
+                    <a16:creationId xmlns:a16="http://schemas.microsoft.com/office/drawing/2014/main" id="{8692BA8C-8BFD-D4AF-1AAD-285177594A04}"/>
+                  </a:ext>
+                </a:extLst>
+              </p:cNvPr>
+              <p:cNvSpPr txBox="1"/>
+              <p:nvPr/>
+            </p:nvSpPr>
+            <p:spPr>
+              <a:xfrm>
+                <a:off x="1028392" y="3244741"/>
+                <a:ext cx="2239249" cy="307777"/>
+              </a:xfrm>
+              <a:prstGeom prst="rect">
+                <a:avLst/>
+              </a:prstGeom>
+              <a:noFill/>
+            </p:spPr>
+            <p:txBody>
+              <a:bodyPr wrap="square">
+                <a:spAutoFit/>
+              </a:bodyPr>
+              <a:lstStyle/>
+              <a:p>
+                <a:pPr algn="ctr"/>
+                <a:r>
+                  <a:rPr lang="en-US" sz="1400" b="1" dirty="0">
+                    <a:solidFill>
+                      <a:schemeClr val="bg1"/>
+                    </a:solidFill>
+                    <a:latin typeface="Times New Roman" panose="02020603050405020304" pitchFamily="18" charset="0"/>
+                    <a:cs typeface="Times New Roman" panose="02020603050405020304" pitchFamily="18" charset="0"/>
+                  </a:rPr>
+                  <a:t>Near-RT RIC</a:t>
+                </a:r>
+              </a:p>
+            </p:txBody>
+          </p:sp>
+          <p:grpSp>
+            <p:nvGrpSpPr>
+              <p:cNvPr id="79" name="Group 78">
+                <a:extLst>
+                  <a:ext uri="{FF2B5EF4-FFF2-40B4-BE49-F238E27FC236}">
+                    <a16:creationId xmlns:a16="http://schemas.microsoft.com/office/drawing/2014/main" id="{3DE97752-AB53-3ACA-903E-641E201E9234}"/>
+                  </a:ext>
+                </a:extLst>
+              </p:cNvPr>
+              <p:cNvGrpSpPr/>
+              <p:nvPr/>
+            </p:nvGrpSpPr>
+            <p:grpSpPr>
+              <a:xfrm>
+                <a:off x="1028392" y="2318655"/>
+                <a:ext cx="2239249" cy="923272"/>
+                <a:chOff x="1590040" y="5303322"/>
+                <a:chExt cx="2374765" cy="923272"/>
+              </a:xfrm>
+            </p:grpSpPr>
+            <p:sp>
+              <p:nvSpPr>
+                <p:cNvPr id="83" name="Rectangle: Rounded Corners 82">
+                  <a:extLst>
+                    <a:ext uri="{FF2B5EF4-FFF2-40B4-BE49-F238E27FC236}">
+                      <a16:creationId xmlns:a16="http://schemas.microsoft.com/office/drawing/2014/main" id="{71E07B19-72A9-960B-E632-3DF83E0D2A9A}"/>
+                    </a:ext>
+                  </a:extLst>
+                </p:cNvPr>
+                <p:cNvSpPr/>
+                <p:nvPr/>
+              </p:nvSpPr>
+              <p:spPr>
+                <a:xfrm>
+                  <a:off x="1590040" y="5303322"/>
+                  <a:ext cx="2374765" cy="923272"/>
+                </a:xfrm>
+                <a:prstGeom prst="roundRect">
+                  <a:avLst>
+                    <a:gd name="adj" fmla="val 9466"/>
+                  </a:avLst>
+                </a:prstGeom>
+                <a:solidFill>
+                  <a:srgbClr val="262626"/>
+                </a:solidFill>
+                <a:ln w="28575">
+                  <a:noFill/>
+                </a:ln>
+              </p:spPr>
+              <p:style>
+                <a:lnRef idx="2">
+                  <a:schemeClr val="accent1">
+                    <a:shade val="15000"/>
+                  </a:schemeClr>
+                </a:lnRef>
+                <a:fillRef idx="1">
+                  <a:schemeClr val="accent1"/>
+                </a:fillRef>
+                <a:effectRef idx="0">
+                  <a:schemeClr val="accent1"/>
+                </a:effectRef>
+                <a:fontRef idx="minor">
+                  <a:schemeClr val="lt1"/>
+                </a:fontRef>
+              </p:style>
+              <p:txBody>
+                <a:bodyPr rtlCol="0" anchor="ctr"/>
+                <a:lstStyle/>
+                <a:p>
+                  <a:pPr algn="ctr"/>
+                  <a:endParaRPr lang="en-US" dirty="0">
+                    <a:latin typeface="Times New Roman" panose="02020603050405020304" pitchFamily="18" charset="0"/>
+                    <a:cs typeface="Times New Roman" panose="02020603050405020304" pitchFamily="18" charset="0"/>
+                  </a:endParaRPr>
+                </a:p>
+              </p:txBody>
+            </p:sp>
+            <p:sp>
+              <p:nvSpPr>
+                <p:cNvPr id="84" name="Rectangle 83">
+                  <a:extLst>
+                    <a:ext uri="{FF2B5EF4-FFF2-40B4-BE49-F238E27FC236}">
+                      <a16:creationId xmlns:a16="http://schemas.microsoft.com/office/drawing/2014/main" id="{90FAC063-73E1-9FCD-9F9C-9F943B1D6B62}"/>
+                    </a:ext>
+                  </a:extLst>
+                </p:cNvPr>
+                <p:cNvSpPr/>
+                <p:nvPr/>
+              </p:nvSpPr>
+              <p:spPr>
+                <a:xfrm>
+                  <a:off x="1590040" y="5603165"/>
+                  <a:ext cx="2374765" cy="323587"/>
+                </a:xfrm>
+                <a:prstGeom prst="rect">
+                  <a:avLst/>
+                </a:prstGeom>
+                <a:solidFill>
+                  <a:srgbClr val="3A3A3A"/>
+                </a:solidFill>
+                <a:ln>
+                  <a:noFill/>
+                </a:ln>
+              </p:spPr>
+              <p:style>
+                <a:lnRef idx="2">
+                  <a:schemeClr val="accent1">
+                    <a:shade val="15000"/>
+                  </a:schemeClr>
+                </a:lnRef>
+                <a:fillRef idx="1">
+                  <a:schemeClr val="accent1"/>
+                </a:fillRef>
+                <a:effectRef idx="0">
+                  <a:schemeClr val="accent1"/>
+                </a:effectRef>
+                <a:fontRef idx="minor">
+                  <a:schemeClr val="lt1"/>
+                </a:fontRef>
+              </p:style>
+              <p:txBody>
+                <a:bodyPr rtlCol="0" anchor="ctr"/>
+                <a:lstStyle/>
+                <a:p>
+                  <a:pPr algn="ctr"/>
+                  <a:endParaRPr lang="en-US"/>
+                </a:p>
+              </p:txBody>
+            </p:sp>
+            <p:sp>
+              <p:nvSpPr>
+                <p:cNvPr id="85" name="Rectangle: Rounded Corners 84">
+                  <a:extLst>
+                    <a:ext uri="{FF2B5EF4-FFF2-40B4-BE49-F238E27FC236}">
+                      <a16:creationId xmlns:a16="http://schemas.microsoft.com/office/drawing/2014/main" id="{97D48B6F-4051-F261-5713-9BF4699D9936}"/>
+                    </a:ext>
+                  </a:extLst>
+                </p:cNvPr>
+                <p:cNvSpPr/>
+                <p:nvPr/>
+              </p:nvSpPr>
+              <p:spPr>
+                <a:xfrm>
+                  <a:off x="1590040" y="5303322"/>
+                  <a:ext cx="2374765" cy="923272"/>
+                </a:xfrm>
+                <a:prstGeom prst="roundRect">
+                  <a:avLst>
+                    <a:gd name="adj" fmla="val 9879"/>
+                  </a:avLst>
+                </a:prstGeom>
+                <a:noFill/>
+                <a:ln w="12700">
+                  <a:solidFill>
+                    <a:schemeClr val="bg1"/>
+                  </a:solidFill>
+                </a:ln>
+              </p:spPr>
+              <p:style>
+                <a:lnRef idx="2">
+                  <a:schemeClr val="accent1">
+                    <a:shade val="15000"/>
+                  </a:schemeClr>
+                </a:lnRef>
+                <a:fillRef idx="1">
+                  <a:schemeClr val="accent1"/>
+                </a:fillRef>
+                <a:effectRef idx="0">
+                  <a:schemeClr val="accent1"/>
+                </a:effectRef>
+                <a:fontRef idx="minor">
+                  <a:schemeClr val="lt1"/>
+                </a:fontRef>
+              </p:style>
+              <p:txBody>
+                <a:bodyPr rtlCol="0" anchor="ctr"/>
+                <a:lstStyle/>
+                <a:p>
+                  <a:pPr algn="ctr"/>
+                  <a:endParaRPr lang="en-US" dirty="0">
+                    <a:latin typeface="Times New Roman" panose="02020603050405020304" pitchFamily="18" charset="0"/>
+                    <a:cs typeface="Times New Roman" panose="02020603050405020304" pitchFamily="18" charset="0"/>
+                  </a:endParaRPr>
+                </a:p>
+              </p:txBody>
+            </p:sp>
+          </p:grpSp>
+          <p:sp>
+            <p:nvSpPr>
+              <p:cNvPr id="80" name="TextBox 79">
+                <a:extLst>
+                  <a:ext uri="{FF2B5EF4-FFF2-40B4-BE49-F238E27FC236}">
+                    <a16:creationId xmlns:a16="http://schemas.microsoft.com/office/drawing/2014/main" id="{F1059630-8383-0B66-68A0-1B624EC69700}"/>
+                  </a:ext>
+                </a:extLst>
+              </p:cNvPr>
+              <p:cNvSpPr txBox="1"/>
+              <p:nvPr/>
+            </p:nvSpPr>
+            <p:spPr>
+              <a:xfrm>
+                <a:off x="1026488" y="2928594"/>
+                <a:ext cx="2241153" cy="307777"/>
+              </a:xfrm>
+              <a:prstGeom prst="rect">
+                <a:avLst/>
+              </a:prstGeom>
+              <a:noFill/>
+            </p:spPr>
+            <p:txBody>
+              <a:bodyPr wrap="square">
+                <a:spAutoFit/>
+              </a:bodyPr>
+              <a:lstStyle/>
+              <a:p>
+                <a:pPr algn="ctr"/>
+                <a:r>
+                  <a:rPr lang="en-US" sz="1400" dirty="0">
+                    <a:solidFill>
+                      <a:schemeClr val="bg1"/>
+                    </a:solidFill>
+                    <a:latin typeface="Times New Roman" panose="02020603050405020304" pitchFamily="18" charset="0"/>
+                    <a:cs typeface="Times New Roman" panose="02020603050405020304" pitchFamily="18" charset="0"/>
+                  </a:rPr>
+                  <a:t>Mosaic5G : FlexRIC</a:t>
+                </a:r>
+              </a:p>
+            </p:txBody>
+          </p:sp>
+          <p:sp>
+            <p:nvSpPr>
+              <p:cNvPr id="81" name="TextBox 80">
+                <a:extLst>
+                  <a:ext uri="{FF2B5EF4-FFF2-40B4-BE49-F238E27FC236}">
+                    <a16:creationId xmlns:a16="http://schemas.microsoft.com/office/drawing/2014/main" id="{7FE2B9E7-212A-DA2F-8016-28CC6B67159F}"/>
+                  </a:ext>
+                </a:extLst>
+              </p:cNvPr>
+              <p:cNvSpPr txBox="1"/>
+              <p:nvPr/>
+            </p:nvSpPr>
+            <p:spPr>
+              <a:xfrm>
+                <a:off x="1026488" y="2629568"/>
+                <a:ext cx="2241153" cy="307777"/>
+              </a:xfrm>
+              <a:prstGeom prst="rect">
+                <a:avLst/>
+              </a:prstGeom>
+              <a:noFill/>
+            </p:spPr>
+            <p:txBody>
+              <a:bodyPr wrap="square">
+                <a:spAutoFit/>
+              </a:bodyPr>
+              <a:lstStyle/>
+              <a:p>
+                <a:pPr algn="ctr"/>
+                <a:r>
+                  <a:rPr lang="en-US" sz="1400" dirty="0">
+                    <a:solidFill>
+                      <a:schemeClr val="bg1"/>
+                    </a:solidFill>
+                    <a:latin typeface="Times New Roman" panose="02020603050405020304" pitchFamily="18" charset="0"/>
+                    <a:cs typeface="Times New Roman" panose="02020603050405020304" pitchFamily="18" charset="0"/>
+                  </a:rPr>
+                  <a:t>O-RAN SC : Near-RT RIC</a:t>
+                </a:r>
+              </a:p>
+            </p:txBody>
+          </p:sp>
+          <p:sp>
+            <p:nvSpPr>
+              <p:cNvPr id="82" name="TextBox 81">
+                <a:extLst>
+                  <a:ext uri="{FF2B5EF4-FFF2-40B4-BE49-F238E27FC236}">
+                    <a16:creationId xmlns:a16="http://schemas.microsoft.com/office/drawing/2014/main" id="{467B0EE3-8C81-7DF0-9524-0DB7433CFFAF}"/>
+                  </a:ext>
+                </a:extLst>
+              </p:cNvPr>
+              <p:cNvSpPr txBox="1"/>
+              <p:nvPr/>
+            </p:nvSpPr>
+            <p:spPr>
+              <a:xfrm>
+                <a:off x="1026488" y="2330542"/>
+                <a:ext cx="2241153" cy="307777"/>
+              </a:xfrm>
+              <a:prstGeom prst="rect">
+                <a:avLst/>
+              </a:prstGeom>
+              <a:noFill/>
+            </p:spPr>
+            <p:txBody>
+              <a:bodyPr wrap="square">
+                <a:spAutoFit/>
+              </a:bodyPr>
+              <a:lstStyle/>
+              <a:p>
+                <a:pPr algn="ctr"/>
+                <a:r>
+                  <a:rPr lang="en-US" sz="1400" dirty="0">
+                    <a:solidFill>
+                      <a:schemeClr val="bg1"/>
+                    </a:solidFill>
+                    <a:latin typeface="Times New Roman" panose="02020603050405020304" pitchFamily="18" charset="0"/>
+                    <a:cs typeface="Times New Roman" panose="02020603050405020304" pitchFamily="18" charset="0"/>
+                  </a:rPr>
+                  <a:t>O-RAN SC : A1 Simulator</a:t>
+                </a:r>
+              </a:p>
+            </p:txBody>
+          </p:sp>
+        </p:grpSp>
+        <p:cxnSp>
+          <p:nvCxnSpPr>
+            <p:cNvPr id="86" name="Straight Connector 85">
+              <a:extLst>
+                <a:ext uri="{FF2B5EF4-FFF2-40B4-BE49-F238E27FC236}">
+                  <a16:creationId xmlns:a16="http://schemas.microsoft.com/office/drawing/2014/main" id="{8716AD2C-5E04-6500-20A3-966FF14ADD37}"/>
+                </a:ext>
+              </a:extLst>
+            </p:cNvPr>
+            <p:cNvCxnSpPr>
+              <a:cxnSpLocks/>
+              <a:stCxn id="82" idx="3"/>
+              <a:endCxn id="30" idx="1"/>
+            </p:cNvCxnSpPr>
+            <p:nvPr/>
+          </p:nvCxnSpPr>
+          <p:spPr>
+            <a:xfrm>
+              <a:off x="8737207" y="2947324"/>
+              <a:ext cx="639703" cy="589820"/>
+            </a:xfrm>
+            <a:prstGeom prst="line">
+              <a:avLst/>
+            </a:prstGeom>
+            <a:ln w="12700">
+              <a:solidFill>
+                <a:schemeClr val="bg1"/>
+              </a:solidFill>
+            </a:ln>
+          </p:spPr>
+          <p:style>
+            <a:lnRef idx="2">
+              <a:schemeClr val="accent1"/>
+            </a:lnRef>
+            <a:fillRef idx="0">
+              <a:schemeClr val="accent1"/>
+            </a:fillRef>
+            <a:effectRef idx="1">
+              <a:schemeClr val="accent1"/>
+            </a:effectRef>
+            <a:fontRef idx="minor">
+              <a:schemeClr val="tx1"/>
+            </a:fontRef>
+          </p:style>
+        </p:cxnSp>
+        <p:sp>
+          <p:nvSpPr>
+            <p:cNvPr id="89" name="TextBox 88">
+              <a:extLst>
+                <a:ext uri="{FF2B5EF4-FFF2-40B4-BE49-F238E27FC236}">
+                  <a16:creationId xmlns:a16="http://schemas.microsoft.com/office/drawing/2014/main" id="{E4ED17CE-4528-0EEC-AB9C-36F0BCB17D7E}"/>
+                </a:ext>
+              </a:extLst>
+            </p:cNvPr>
+            <p:cNvSpPr txBox="1"/>
+            <p:nvPr/>
+          </p:nvSpPr>
+          <p:spPr>
+            <a:xfrm>
+              <a:off x="6561688" y="2473676"/>
+              <a:ext cx="2239249" cy="307777"/>
+            </a:xfrm>
+            <a:prstGeom prst="rect">
+              <a:avLst/>
+            </a:prstGeom>
+            <a:noFill/>
+          </p:spPr>
+          <p:txBody>
+            <a:bodyPr wrap="square">
+              <a:spAutoFit/>
+            </a:bodyPr>
+            <a:lstStyle/>
+            <a:p>
+              <a:pPr algn="ctr"/>
+              <a:r>
+                <a:rPr lang="en-US" sz="1400" b="1" dirty="0">
+                  <a:solidFill>
+                    <a:schemeClr val="bg1"/>
+                  </a:solidFill>
+                  <a:latin typeface="Times New Roman" panose="02020603050405020304" pitchFamily="18" charset="0"/>
+                  <a:cs typeface="Times New Roman" panose="02020603050405020304" pitchFamily="18" charset="0"/>
+                </a:rPr>
+                <a:t>5G Core Network</a:t>
+              </a:r>
+            </a:p>
+          </p:txBody>
+        </p:sp>
       </p:grpSp>
     </p:spTree>
     <p:extLst>
@@ -18331,7 +18416,7 @@
                 </a:avLst>
               </a:prstGeom>
               <a:noFill/>
-              <a:ln w="28575">
+              <a:ln w="12700">
                 <a:solidFill>
                   <a:schemeClr val="tx1"/>
                 </a:solidFill>

</xml_diff>

<commit_message>
Synchronize with USNISTGOV v1.4.1
</commit_message>
<xml_diff>
--- a/RAN_Intelligent_Controllers/research/Diagrams.pptx
+++ b/RAN_Intelligent_Controllers/research/Diagrams.pptx
@@ -263,7 +263,7 @@
           <a:p>
             <a:fld id="{2D1DF383-F48D-4C35-882C-8A26F25E24F6}" type="datetimeFigureOut">
               <a:rPr lang="en-US" smtClean="0"/>
-              <a:t>4/29/2025</a:t>
+              <a:t>5/22/2025</a:t>
             </a:fld>
             <a:endParaRPr lang="en-US"/>
           </a:p>
@@ -461,7 +461,7 @@
           <a:p>
             <a:fld id="{2D1DF383-F48D-4C35-882C-8A26F25E24F6}" type="datetimeFigureOut">
               <a:rPr lang="en-US" smtClean="0"/>
-              <a:t>4/29/2025</a:t>
+              <a:t>5/22/2025</a:t>
             </a:fld>
             <a:endParaRPr lang="en-US"/>
           </a:p>
@@ -669,7 +669,7 @@
           <a:p>
             <a:fld id="{2D1DF383-F48D-4C35-882C-8A26F25E24F6}" type="datetimeFigureOut">
               <a:rPr lang="en-US" smtClean="0"/>
-              <a:t>4/29/2025</a:t>
+              <a:t>5/22/2025</a:t>
             </a:fld>
             <a:endParaRPr lang="en-US"/>
           </a:p>
@@ -867,7 +867,7 @@
           <a:p>
             <a:fld id="{2D1DF383-F48D-4C35-882C-8A26F25E24F6}" type="datetimeFigureOut">
               <a:rPr lang="en-US" smtClean="0"/>
-              <a:t>4/29/2025</a:t>
+              <a:t>5/22/2025</a:t>
             </a:fld>
             <a:endParaRPr lang="en-US"/>
           </a:p>
@@ -1142,7 +1142,7 @@
           <a:p>
             <a:fld id="{2D1DF383-F48D-4C35-882C-8A26F25E24F6}" type="datetimeFigureOut">
               <a:rPr lang="en-US" smtClean="0"/>
-              <a:t>4/29/2025</a:t>
+              <a:t>5/22/2025</a:t>
             </a:fld>
             <a:endParaRPr lang="en-US"/>
           </a:p>
@@ -1407,7 +1407,7 @@
           <a:p>
             <a:fld id="{2D1DF383-F48D-4C35-882C-8A26F25E24F6}" type="datetimeFigureOut">
               <a:rPr lang="en-US" smtClean="0"/>
-              <a:t>4/29/2025</a:t>
+              <a:t>5/22/2025</a:t>
             </a:fld>
             <a:endParaRPr lang="en-US"/>
           </a:p>
@@ -1819,7 +1819,7 @@
           <a:p>
             <a:fld id="{2D1DF383-F48D-4C35-882C-8A26F25E24F6}" type="datetimeFigureOut">
               <a:rPr lang="en-US" smtClean="0"/>
-              <a:t>4/29/2025</a:t>
+              <a:t>5/22/2025</a:t>
             </a:fld>
             <a:endParaRPr lang="en-US"/>
           </a:p>
@@ -1960,7 +1960,7 @@
           <a:p>
             <a:fld id="{2D1DF383-F48D-4C35-882C-8A26F25E24F6}" type="datetimeFigureOut">
               <a:rPr lang="en-US" smtClean="0"/>
-              <a:t>4/29/2025</a:t>
+              <a:t>5/22/2025</a:t>
             </a:fld>
             <a:endParaRPr lang="en-US"/>
           </a:p>
@@ -2073,7 +2073,7 @@
           <a:p>
             <a:fld id="{2D1DF383-F48D-4C35-882C-8A26F25E24F6}" type="datetimeFigureOut">
               <a:rPr lang="en-US" smtClean="0"/>
-              <a:t>4/29/2025</a:t>
+              <a:t>5/22/2025</a:t>
             </a:fld>
             <a:endParaRPr lang="en-US"/>
           </a:p>
@@ -2384,7 +2384,7 @@
           <a:p>
             <a:fld id="{2D1DF383-F48D-4C35-882C-8A26F25E24F6}" type="datetimeFigureOut">
               <a:rPr lang="en-US" smtClean="0"/>
-              <a:t>4/29/2025</a:t>
+              <a:t>5/22/2025</a:t>
             </a:fld>
             <a:endParaRPr lang="en-US"/>
           </a:p>
@@ -2672,7 +2672,7 @@
           <a:p>
             <a:fld id="{2D1DF383-F48D-4C35-882C-8A26F25E24F6}" type="datetimeFigureOut">
               <a:rPr lang="en-US" smtClean="0"/>
-              <a:t>4/29/2025</a:t>
+              <a:t>5/22/2025</a:t>
             </a:fld>
             <a:endParaRPr lang="en-US"/>
           </a:p>
@@ -2913,7 +2913,7 @@
           <a:p>
             <a:fld id="{2D1DF383-F48D-4C35-882C-8A26F25E24F6}" type="datetimeFigureOut">
               <a:rPr lang="en-US" smtClean="0"/>
-              <a:t>4/29/2025</a:t>
+              <a:t>5/22/2025</a:t>
             </a:fld>
             <a:endParaRPr lang="en-US"/>
           </a:p>
@@ -4233,7 +4233,7 @@
                               <a:latin typeface="Times New Roman" panose="02020603050405020304" pitchFamily="18" charset="0"/>
                               <a:cs typeface="Times New Roman" panose="02020603050405020304" pitchFamily="18" charset="0"/>
                             </a:rPr>
-                            <a:t>Mobile Phone</a:t>
+                            <a:t>5G Mobile Phone</a:t>
                           </a:r>
                           <a:endParaRPr lang="en-US" sz="1400" dirty="0">
                             <a:latin typeface="Times New Roman" panose="02020603050405020304" pitchFamily="18" charset="0"/>
@@ -8537,7 +8537,7 @@
                               <a:latin typeface="Times New Roman" panose="02020603050405020304" pitchFamily="18" charset="0"/>
                               <a:cs typeface="Times New Roman" panose="02020603050405020304" pitchFamily="18" charset="0"/>
                             </a:rPr>
-                            <a:t>Mobile Phone</a:t>
+                            <a:t>5G Mobile Phone</a:t>
                           </a:r>
                         </a:p>
                       </p:txBody>
@@ -13828,7 +13828,7 @@
                     <a:latin typeface="Times New Roman" panose="02020603050405020304" pitchFamily="18" charset="0"/>
                     <a:cs typeface="Times New Roman" panose="02020603050405020304" pitchFamily="18" charset="0"/>
                   </a:rPr>
-                  <a:t>Mobile Phone</a:t>
+                  <a:t>5G Mobile Phone</a:t>
                 </a:r>
               </a:p>
             </p:txBody>
@@ -17157,7 +17157,7 @@
                     <a:latin typeface="Times New Roman" panose="02020603050405020304" pitchFamily="18" charset="0"/>
                     <a:cs typeface="Times New Roman" panose="02020603050405020304" pitchFamily="18" charset="0"/>
                   </a:rPr>
-                  <a:t>Mobile Phone</a:t>
+                  <a:t>5G Mobile Phone</a:t>
                 </a:r>
               </a:p>
             </p:txBody>

</xml_diff>

<commit_message>
Commit and push revisions made on 7/01/2025
Still trying to get the 5gdeploy Docker networking correct for Free5GC, and still trying to get Phoenix working (although, it now compiles), the AMF and AUSF crash upon startup. Documentation and diagrams have been updated. Phoenix has much better documentation about it.
</commit_message>
<xml_diff>
--- a/RAN_Intelligent_Controllers/research/Diagrams.pptx
+++ b/RAN_Intelligent_Controllers/research/Diagrams.pptx
@@ -265,7 +265,7 @@
           <a:p>
             <a:fld id="{2D1DF383-F48D-4C35-882C-8A26F25E24F6}" type="datetimeFigureOut">
               <a:rPr lang="en-US" smtClean="0"/>
-              <a:t>6/5/2025</a:t>
+              <a:t>6/30/2025</a:t>
             </a:fld>
             <a:endParaRPr lang="en-US"/>
           </a:p>
@@ -463,7 +463,7 @@
           <a:p>
             <a:fld id="{2D1DF383-F48D-4C35-882C-8A26F25E24F6}" type="datetimeFigureOut">
               <a:rPr lang="en-US" smtClean="0"/>
-              <a:t>6/5/2025</a:t>
+              <a:t>6/30/2025</a:t>
             </a:fld>
             <a:endParaRPr lang="en-US"/>
           </a:p>
@@ -671,7 +671,7 @@
           <a:p>
             <a:fld id="{2D1DF383-F48D-4C35-882C-8A26F25E24F6}" type="datetimeFigureOut">
               <a:rPr lang="en-US" smtClean="0"/>
-              <a:t>6/5/2025</a:t>
+              <a:t>6/30/2025</a:t>
             </a:fld>
             <a:endParaRPr lang="en-US"/>
           </a:p>
@@ -869,7 +869,7 @@
           <a:p>
             <a:fld id="{2D1DF383-F48D-4C35-882C-8A26F25E24F6}" type="datetimeFigureOut">
               <a:rPr lang="en-US" smtClean="0"/>
-              <a:t>6/5/2025</a:t>
+              <a:t>6/30/2025</a:t>
             </a:fld>
             <a:endParaRPr lang="en-US"/>
           </a:p>
@@ -1144,7 +1144,7 @@
           <a:p>
             <a:fld id="{2D1DF383-F48D-4C35-882C-8A26F25E24F6}" type="datetimeFigureOut">
               <a:rPr lang="en-US" smtClean="0"/>
-              <a:t>6/5/2025</a:t>
+              <a:t>6/30/2025</a:t>
             </a:fld>
             <a:endParaRPr lang="en-US"/>
           </a:p>
@@ -1409,7 +1409,7 @@
           <a:p>
             <a:fld id="{2D1DF383-F48D-4C35-882C-8A26F25E24F6}" type="datetimeFigureOut">
               <a:rPr lang="en-US" smtClean="0"/>
-              <a:t>6/5/2025</a:t>
+              <a:t>6/30/2025</a:t>
             </a:fld>
             <a:endParaRPr lang="en-US"/>
           </a:p>
@@ -1821,7 +1821,7 @@
           <a:p>
             <a:fld id="{2D1DF383-F48D-4C35-882C-8A26F25E24F6}" type="datetimeFigureOut">
               <a:rPr lang="en-US" smtClean="0"/>
-              <a:t>6/5/2025</a:t>
+              <a:t>6/30/2025</a:t>
             </a:fld>
             <a:endParaRPr lang="en-US"/>
           </a:p>
@@ -1962,7 +1962,7 @@
           <a:p>
             <a:fld id="{2D1DF383-F48D-4C35-882C-8A26F25E24F6}" type="datetimeFigureOut">
               <a:rPr lang="en-US" smtClean="0"/>
-              <a:t>6/5/2025</a:t>
+              <a:t>6/30/2025</a:t>
             </a:fld>
             <a:endParaRPr lang="en-US"/>
           </a:p>
@@ -2075,7 +2075,7 @@
           <a:p>
             <a:fld id="{2D1DF383-F48D-4C35-882C-8A26F25E24F6}" type="datetimeFigureOut">
               <a:rPr lang="en-US" smtClean="0"/>
-              <a:t>6/5/2025</a:t>
+              <a:t>6/30/2025</a:t>
             </a:fld>
             <a:endParaRPr lang="en-US"/>
           </a:p>
@@ -2386,7 +2386,7 @@
           <a:p>
             <a:fld id="{2D1DF383-F48D-4C35-882C-8A26F25E24F6}" type="datetimeFigureOut">
               <a:rPr lang="en-US" smtClean="0"/>
-              <a:t>6/5/2025</a:t>
+              <a:t>6/30/2025</a:t>
             </a:fld>
             <a:endParaRPr lang="en-US"/>
           </a:p>
@@ -2674,7 +2674,7 @@
           <a:p>
             <a:fld id="{2D1DF383-F48D-4C35-882C-8A26F25E24F6}" type="datetimeFigureOut">
               <a:rPr lang="en-US" smtClean="0"/>
-              <a:t>6/5/2025</a:t>
+              <a:t>6/30/2025</a:t>
             </a:fld>
             <a:endParaRPr lang="en-US"/>
           </a:p>
@@ -2915,7 +2915,7 @@
           <a:p>
             <a:fld id="{2D1DF383-F48D-4C35-882C-8A26F25E24F6}" type="datetimeFigureOut">
               <a:rPr lang="en-US" smtClean="0"/>
-              <a:t>6/5/2025</a:t>
+              <a:t>6/30/2025</a:t>
             </a:fld>
             <a:endParaRPr lang="en-US"/>
           </a:p>

</xml_diff>

<commit_message>
Update diagrams (sync with CCNC pub, and include A1-ML)
</commit_message>
<xml_diff>
--- a/RAN_Intelligent_Controllers/research/Diagrams.pptx
+++ b/RAN_Intelligent_Controllers/research/Diagrams.pptx
@@ -265,7 +265,7 @@
           <a:p>
             <a:fld id="{2D1DF383-F48D-4C35-882C-8A26F25E24F6}" type="datetimeFigureOut">
               <a:rPr lang="en-US" smtClean="0"/>
-              <a:t>11/13/2025</a:t>
+              <a:t>2/6/2026</a:t>
             </a:fld>
             <a:endParaRPr lang="en-US"/>
           </a:p>
@@ -463,7 +463,7 @@
           <a:p>
             <a:fld id="{2D1DF383-F48D-4C35-882C-8A26F25E24F6}" type="datetimeFigureOut">
               <a:rPr lang="en-US" smtClean="0"/>
-              <a:t>11/13/2025</a:t>
+              <a:t>2/6/2026</a:t>
             </a:fld>
             <a:endParaRPr lang="en-US"/>
           </a:p>
@@ -671,7 +671,7 @@
           <a:p>
             <a:fld id="{2D1DF383-F48D-4C35-882C-8A26F25E24F6}" type="datetimeFigureOut">
               <a:rPr lang="en-US" smtClean="0"/>
-              <a:t>11/13/2025</a:t>
+              <a:t>2/6/2026</a:t>
             </a:fld>
             <a:endParaRPr lang="en-US"/>
           </a:p>
@@ -869,7 +869,7 @@
           <a:p>
             <a:fld id="{2D1DF383-F48D-4C35-882C-8A26F25E24F6}" type="datetimeFigureOut">
               <a:rPr lang="en-US" smtClean="0"/>
-              <a:t>11/13/2025</a:t>
+              <a:t>2/6/2026</a:t>
             </a:fld>
             <a:endParaRPr lang="en-US"/>
           </a:p>
@@ -1144,7 +1144,7 @@
           <a:p>
             <a:fld id="{2D1DF383-F48D-4C35-882C-8A26F25E24F6}" type="datetimeFigureOut">
               <a:rPr lang="en-US" smtClean="0"/>
-              <a:t>11/13/2025</a:t>
+              <a:t>2/6/2026</a:t>
             </a:fld>
             <a:endParaRPr lang="en-US"/>
           </a:p>
@@ -1409,7 +1409,7 @@
           <a:p>
             <a:fld id="{2D1DF383-F48D-4C35-882C-8A26F25E24F6}" type="datetimeFigureOut">
               <a:rPr lang="en-US" smtClean="0"/>
-              <a:t>11/13/2025</a:t>
+              <a:t>2/6/2026</a:t>
             </a:fld>
             <a:endParaRPr lang="en-US"/>
           </a:p>
@@ -1821,7 +1821,7 @@
           <a:p>
             <a:fld id="{2D1DF383-F48D-4C35-882C-8A26F25E24F6}" type="datetimeFigureOut">
               <a:rPr lang="en-US" smtClean="0"/>
-              <a:t>11/13/2025</a:t>
+              <a:t>2/6/2026</a:t>
             </a:fld>
             <a:endParaRPr lang="en-US"/>
           </a:p>
@@ -1962,7 +1962,7 @@
           <a:p>
             <a:fld id="{2D1DF383-F48D-4C35-882C-8A26F25E24F6}" type="datetimeFigureOut">
               <a:rPr lang="en-US" smtClean="0"/>
-              <a:t>11/13/2025</a:t>
+              <a:t>2/6/2026</a:t>
             </a:fld>
             <a:endParaRPr lang="en-US"/>
           </a:p>
@@ -2075,7 +2075,7 @@
           <a:p>
             <a:fld id="{2D1DF383-F48D-4C35-882C-8A26F25E24F6}" type="datetimeFigureOut">
               <a:rPr lang="en-US" smtClean="0"/>
-              <a:t>11/13/2025</a:t>
+              <a:t>2/6/2026</a:t>
             </a:fld>
             <a:endParaRPr lang="en-US"/>
           </a:p>
@@ -2386,7 +2386,7 @@
           <a:p>
             <a:fld id="{2D1DF383-F48D-4C35-882C-8A26F25E24F6}" type="datetimeFigureOut">
               <a:rPr lang="en-US" smtClean="0"/>
-              <a:t>11/13/2025</a:t>
+              <a:t>2/6/2026</a:t>
             </a:fld>
             <a:endParaRPr lang="en-US"/>
           </a:p>
@@ -2674,7 +2674,7 @@
           <a:p>
             <a:fld id="{2D1DF383-F48D-4C35-882C-8A26F25E24F6}" type="datetimeFigureOut">
               <a:rPr lang="en-US" smtClean="0"/>
-              <a:t>11/13/2025</a:t>
+              <a:t>2/6/2026</a:t>
             </a:fld>
             <a:endParaRPr lang="en-US"/>
           </a:p>
@@ -2915,7 +2915,7 @@
           <a:p>
             <a:fld id="{2D1DF383-F48D-4C35-882C-8A26F25E24F6}" type="datetimeFigureOut">
               <a:rPr lang="en-US" smtClean="0"/>
-              <a:t>11/13/2025</a:t>
+              <a:t>2/6/2026</a:t>
             </a:fld>
             <a:endParaRPr lang="en-US"/>
           </a:p>
@@ -7282,7 +7282,7 @@
           <p:spPr>
             <a:xfrm>
               <a:off x="6417137" y="1764477"/>
-              <a:ext cx="971328" cy="276999"/>
+              <a:ext cx="971328" cy="461665"/>
             </a:xfrm>
             <a:prstGeom prst="rect">
               <a:avLst/>
@@ -7295,7 +7295,6 @@
             </a:bodyPr>
             <a:lstStyle/>
             <a:p>
-              <a:pPr algn="ctr"/>
               <a:r>
                 <a:rPr lang="en-US" sz="1200" dirty="0">
                   <a:solidFill>
@@ -7305,6 +7304,25 @@
                   <a:cs typeface="Times New Roman" panose="02020603050405020304" pitchFamily="18" charset="0"/>
                 </a:rPr>
                 <a:t>A1-P, A1-EI</a:t>
+              </a:r>
+              <a:br>
+                <a:rPr lang="en-US" sz="1200" dirty="0">
+                  <a:solidFill>
+                    <a:schemeClr val="tx1"/>
+                  </a:solidFill>
+                  <a:latin typeface="Times New Roman" panose="02020603050405020304" pitchFamily="18" charset="0"/>
+                  <a:cs typeface="Times New Roman" panose="02020603050405020304" pitchFamily="18" charset="0"/>
+                </a:rPr>
+              </a:br>
+              <a:r>
+                <a:rPr lang="en-US" sz="1200" dirty="0">
+                  <a:solidFill>
+                    <a:schemeClr val="tx1"/>
+                  </a:solidFill>
+                  <a:latin typeface="Times New Roman" panose="02020603050405020304" pitchFamily="18" charset="0"/>
+                  <a:cs typeface="Times New Roman" panose="02020603050405020304" pitchFamily="18" charset="0"/>
+                </a:rPr>
+                <a:t>A1-ML</a:t>
               </a:r>
               <a:endParaRPr lang="en-US" sz="1200" dirty="0">
                 <a:latin typeface="Times New Roman" panose="02020603050405020304" pitchFamily="18" charset="0"/>
@@ -11031,7 +11049,7 @@
           <p:spPr>
             <a:xfrm>
               <a:off x="6417137" y="1764477"/>
-              <a:ext cx="971328" cy="276999"/>
+              <a:ext cx="971328" cy="461665"/>
             </a:xfrm>
             <a:prstGeom prst="rect">
               <a:avLst/>
@@ -11044,7 +11062,6 @@
             </a:bodyPr>
             <a:lstStyle/>
             <a:p>
-              <a:pPr algn="ctr"/>
               <a:r>
                 <a:rPr lang="en-US" sz="1200" dirty="0">
                   <a:solidFill>
@@ -11054,6 +11071,25 @@
                   <a:cs typeface="Times New Roman" panose="02020603050405020304" pitchFamily="18" charset="0"/>
                 </a:rPr>
                 <a:t>A1-P, A1-EI</a:t>
+              </a:r>
+              <a:br>
+                <a:rPr lang="en-US" sz="1200" dirty="0">
+                  <a:solidFill>
+                    <a:schemeClr val="bg1"/>
+                  </a:solidFill>
+                  <a:latin typeface="Times New Roman" panose="02020603050405020304" pitchFamily="18" charset="0"/>
+                  <a:cs typeface="Times New Roman" panose="02020603050405020304" pitchFamily="18" charset="0"/>
+                </a:rPr>
+              </a:br>
+              <a:r>
+                <a:rPr lang="en-US" sz="1200" dirty="0">
+                  <a:solidFill>
+                    <a:schemeClr val="bg1"/>
+                  </a:solidFill>
+                  <a:latin typeface="Times New Roman" panose="02020603050405020304" pitchFamily="18" charset="0"/>
+                  <a:cs typeface="Times New Roman" panose="02020603050405020304" pitchFamily="18" charset="0"/>
+                </a:rPr>
+                <a:t>A1-ML</a:t>
               </a:r>
             </a:p>
           </p:txBody>

</xml_diff>

<commit_message>
Update diagrams to Duranta
</commit_message>
<xml_diff>
--- a/RAN_Intelligent_Controllers/research/Diagrams.pptx
+++ b/RAN_Intelligent_Controllers/research/Diagrams.pptx
@@ -262,7 +262,7 @@
           <a:p>
             <a:fld id="{2D1DF383-F48D-4C35-882C-8A26F25E24F6}" type="datetimeFigureOut">
               <a:rPr lang="en-US" smtClean="0"/>
-              <a:t>5/15/2026</a:t>
+              <a:t>6/9/2026</a:t>
             </a:fld>
             <a:endParaRPr lang="en-US"/>
           </a:p>
@@ -460,7 +460,7 @@
           <a:p>
             <a:fld id="{2D1DF383-F48D-4C35-882C-8A26F25E24F6}" type="datetimeFigureOut">
               <a:rPr lang="en-US" smtClean="0"/>
-              <a:t>5/15/2026</a:t>
+              <a:t>6/9/2026</a:t>
             </a:fld>
             <a:endParaRPr lang="en-US"/>
           </a:p>
@@ -668,7 +668,7 @@
           <a:p>
             <a:fld id="{2D1DF383-F48D-4C35-882C-8A26F25E24F6}" type="datetimeFigureOut">
               <a:rPr lang="en-US" smtClean="0"/>
-              <a:t>5/15/2026</a:t>
+              <a:t>6/9/2026</a:t>
             </a:fld>
             <a:endParaRPr lang="en-US"/>
           </a:p>
@@ -866,7 +866,7 @@
           <a:p>
             <a:fld id="{2D1DF383-F48D-4C35-882C-8A26F25E24F6}" type="datetimeFigureOut">
               <a:rPr lang="en-US" smtClean="0"/>
-              <a:t>5/15/2026</a:t>
+              <a:t>6/9/2026</a:t>
             </a:fld>
             <a:endParaRPr lang="en-US"/>
           </a:p>
@@ -1141,7 +1141,7 @@
           <a:p>
             <a:fld id="{2D1DF383-F48D-4C35-882C-8A26F25E24F6}" type="datetimeFigureOut">
               <a:rPr lang="en-US" smtClean="0"/>
-              <a:t>5/15/2026</a:t>
+              <a:t>6/9/2026</a:t>
             </a:fld>
             <a:endParaRPr lang="en-US"/>
           </a:p>
@@ -1406,7 +1406,7 @@
           <a:p>
             <a:fld id="{2D1DF383-F48D-4C35-882C-8A26F25E24F6}" type="datetimeFigureOut">
               <a:rPr lang="en-US" smtClean="0"/>
-              <a:t>5/15/2026</a:t>
+              <a:t>6/9/2026</a:t>
             </a:fld>
             <a:endParaRPr lang="en-US"/>
           </a:p>
@@ -1818,7 +1818,7 @@
           <a:p>
             <a:fld id="{2D1DF383-F48D-4C35-882C-8A26F25E24F6}" type="datetimeFigureOut">
               <a:rPr lang="en-US" smtClean="0"/>
-              <a:t>5/15/2026</a:t>
+              <a:t>6/9/2026</a:t>
             </a:fld>
             <a:endParaRPr lang="en-US"/>
           </a:p>
@@ -1959,7 +1959,7 @@
           <a:p>
             <a:fld id="{2D1DF383-F48D-4C35-882C-8A26F25E24F6}" type="datetimeFigureOut">
               <a:rPr lang="en-US" smtClean="0"/>
-              <a:t>5/15/2026</a:t>
+              <a:t>6/9/2026</a:t>
             </a:fld>
             <a:endParaRPr lang="en-US"/>
           </a:p>
@@ -2072,7 +2072,7 @@
           <a:p>
             <a:fld id="{2D1DF383-F48D-4C35-882C-8A26F25E24F6}" type="datetimeFigureOut">
               <a:rPr lang="en-US" smtClean="0"/>
-              <a:t>5/15/2026</a:t>
+              <a:t>6/9/2026</a:t>
             </a:fld>
             <a:endParaRPr lang="en-US"/>
           </a:p>
@@ -2383,7 +2383,7 @@
           <a:p>
             <a:fld id="{2D1DF383-F48D-4C35-882C-8A26F25E24F6}" type="datetimeFigureOut">
               <a:rPr lang="en-US" smtClean="0"/>
-              <a:t>5/15/2026</a:t>
+              <a:t>6/9/2026</a:t>
             </a:fld>
             <a:endParaRPr lang="en-US"/>
           </a:p>
@@ -2671,7 +2671,7 @@
           <a:p>
             <a:fld id="{2D1DF383-F48D-4C35-882C-8A26F25E24F6}" type="datetimeFigureOut">
               <a:rPr lang="en-US" smtClean="0"/>
-              <a:t>5/15/2026</a:t>
+              <a:t>6/9/2026</a:t>
             </a:fld>
             <a:endParaRPr lang="en-US"/>
           </a:p>
@@ -2912,7 +2912,7 @@
           <a:p>
             <a:fld id="{2D1DF383-F48D-4C35-882C-8A26F25E24F6}" type="datetimeFigureOut">
               <a:rPr lang="en-US" smtClean="0"/>
-              <a:t>5/15/2026</a:t>
+              <a:t>6/9/2026</a:t>
             </a:fld>
             <a:endParaRPr lang="en-US"/>
           </a:p>
@@ -3337,10 +3337,10 @@
       </p:grpSpPr>
       <p:grpSp>
         <p:nvGrpSpPr>
-          <p:cNvPr id="20" name="Group 19">
+          <p:cNvPr id="28" name="Group 27">
             <a:extLst>
               <a:ext uri="{FF2B5EF4-FFF2-40B4-BE49-F238E27FC236}">
-                <a16:creationId xmlns:a16="http://schemas.microsoft.com/office/drawing/2014/main" id="{ACE60489-66B9-A95C-9A12-954E4073475D}"/>
+                <a16:creationId xmlns:a16="http://schemas.microsoft.com/office/drawing/2014/main" id="{2637F0BA-D326-931D-5858-7771587A6EC4}"/>
               </a:ext>
             </a:extLst>
           </p:cNvPr>
@@ -4348,12 +4348,16 @@
                   <a:buChar char="•"/>
                 </a:pPr>
                 <a:r>
-                  <a:rPr lang="en-US" sz="1200" dirty="0">
+                  <a:rPr lang="en-US" sz="1200" dirty="0" err="1">
                     <a:latin typeface="Times New Roman" panose="02020603050405020304" pitchFamily="18" charset="0"/>
                     <a:cs typeface="Times New Roman" panose="02020603050405020304" pitchFamily="18" charset="0"/>
                   </a:rPr>
-                  <a:t>srsRAN_4G</a:t>
+                  <a:t>Duranta</a:t>
                 </a:r>
+                <a:endParaRPr lang="en-US" sz="1200" dirty="0">
+                  <a:latin typeface="Times New Roman" panose="02020603050405020304" pitchFamily="18" charset="0"/>
+                  <a:cs typeface="Times New Roman" panose="02020603050405020304" pitchFamily="18" charset="0"/>
+                </a:endParaRPr>
               </a:p>
               <a:p>
                 <a:pPr marL="285750" indent="-285750">
@@ -4365,7 +4369,7 @@
                     <a:latin typeface="Times New Roman" panose="02020603050405020304" pitchFamily="18" charset="0"/>
                     <a:cs typeface="Times New Roman" panose="02020603050405020304" pitchFamily="18" charset="0"/>
                   </a:rPr>
-                  <a:t>OpenAirInterface5G</a:t>
+                  <a:t>srsRAN_4G</a:t>
                 </a:r>
               </a:p>
             </p:txBody>
@@ -4946,12 +4950,16 @@
                   <a:buChar char="•"/>
                 </a:pPr>
                 <a:r>
-                  <a:rPr lang="en-US" sz="1200" dirty="0">
+                  <a:rPr lang="en-US" sz="1200" dirty="0" err="1">
                     <a:latin typeface="Times New Roman" panose="02020603050405020304" pitchFamily="18" charset="0"/>
                     <a:cs typeface="Times New Roman" panose="02020603050405020304" pitchFamily="18" charset="0"/>
                   </a:rPr>
-                  <a:t>OpenAirInterface5G</a:t>
+                  <a:t>Duranta</a:t>
                 </a:r>
+                <a:endParaRPr lang="en-US" sz="1200" dirty="0">
+                  <a:latin typeface="Times New Roman" panose="02020603050405020304" pitchFamily="18" charset="0"/>
+                  <a:cs typeface="Times New Roman" panose="02020603050405020304" pitchFamily="18" charset="0"/>
+                </a:endParaRPr>
               </a:p>
               <a:p>
                 <a:pPr marL="285750" indent="-285750">
@@ -7338,8 +7346,98 @@
           </p:nvSpPr>
           <p:spPr>
             <a:xfrm>
-              <a:off x="6506434" y="3236557"/>
-              <a:ext cx="2184599" cy="276999"/>
+              <a:off x="5462495" y="3236557"/>
+              <a:ext cx="1070390" cy="276999"/>
+            </a:xfrm>
+            <a:prstGeom prst="rect">
+              <a:avLst/>
+            </a:prstGeom>
+            <a:noFill/>
+          </p:spPr>
+          <p:txBody>
+            <a:bodyPr wrap="square">
+              <a:spAutoFit/>
+            </a:bodyPr>
+            <a:lstStyle/>
+            <a:p>
+              <a:pPr algn="r"/>
+              <a:r>
+                <a:rPr lang="en-US" sz="1200" dirty="0">
+                  <a:solidFill>
+                    <a:schemeClr val="tx1"/>
+                  </a:solidFill>
+                  <a:latin typeface="Times New Roman" panose="02020603050405020304" pitchFamily="18" charset="0"/>
+                  <a:cs typeface="Times New Roman" panose="02020603050405020304" pitchFamily="18" charset="0"/>
+                </a:rPr>
+                <a:t>E2AP, E2SM</a:t>
+              </a:r>
+              <a:endParaRPr lang="en-US" sz="1200" dirty="0">
+                <a:latin typeface="Times New Roman" panose="02020603050405020304" pitchFamily="18" charset="0"/>
+                <a:cs typeface="Times New Roman" panose="02020603050405020304" pitchFamily="18" charset="0"/>
+              </a:endParaRPr>
+            </a:p>
+          </p:txBody>
+        </p:sp>
+        <p:cxnSp>
+          <p:nvCxnSpPr>
+            <p:cNvPr id="11" name="Connector: Elbow 10">
+              <a:extLst>
+                <a:ext uri="{FF2B5EF4-FFF2-40B4-BE49-F238E27FC236}">
+                  <a16:creationId xmlns:a16="http://schemas.microsoft.com/office/drawing/2014/main" id="{4D82E7A1-98F3-FD79-1066-4E1CF0E43B97}"/>
+                </a:ext>
+              </a:extLst>
+            </p:cNvPr>
+            <p:cNvCxnSpPr>
+              <a:cxnSpLocks/>
+            </p:cNvCxnSpPr>
+            <p:nvPr/>
+          </p:nvCxnSpPr>
+          <p:spPr>
+            <a:xfrm rot="5400000" flipH="1" flipV="1">
+              <a:off x="6469218" y="2587933"/>
+              <a:ext cx="1106924" cy="737758"/>
+            </a:xfrm>
+            <a:prstGeom prst="bentConnector2">
+              <a:avLst/>
+            </a:prstGeom>
+            <a:ln w="12700">
+              <a:solidFill>
+                <a:schemeClr val="tx1"/>
+              </a:solidFill>
+              <a:round/>
+            </a:ln>
+          </p:spPr>
+          <p:style>
+            <a:lnRef idx="2">
+              <a:schemeClr val="accent1"/>
+            </a:lnRef>
+            <a:fillRef idx="0">
+              <a:schemeClr val="accent1"/>
+            </a:fillRef>
+            <a:effectRef idx="1">
+              <a:schemeClr val="accent1"/>
+            </a:effectRef>
+            <a:fontRef idx="minor">
+              <a:schemeClr val="tx1"/>
+            </a:fontRef>
+          </p:style>
+        </p:cxnSp>
+        <p:sp>
+          <p:nvSpPr>
+            <p:cNvPr id="26" name="TextBox 25">
+              <a:extLst>
+                <a:ext uri="{FF2B5EF4-FFF2-40B4-BE49-F238E27FC236}">
+                  <a16:creationId xmlns:a16="http://schemas.microsoft.com/office/drawing/2014/main" id="{1569B6B9-3D7C-49AE-5735-FC1B9B121F65}"/>
+                </a:ext>
+              </a:extLst>
+            </p:cNvPr>
+            <p:cNvSpPr txBox="1"/>
+            <p:nvPr/>
+          </p:nvSpPr>
+          <p:spPr>
+            <a:xfrm>
+              <a:off x="6661420" y="3236557"/>
+              <a:ext cx="1070390" cy="276999"/>
             </a:xfrm>
             <a:prstGeom prst="rect">
               <a:avLst/>
@@ -7360,7 +7458,7 @@
                   <a:latin typeface="Times New Roman" panose="02020603050405020304" pitchFamily="18" charset="0"/>
                   <a:cs typeface="Times New Roman" panose="02020603050405020304" pitchFamily="18" charset="0"/>
                 </a:rPr>
-                <a:t>E2AP, E2SM</a:t>
+                <a:t>O1</a:t>
               </a:r>
               <a:endParaRPr lang="en-US" sz="1200" dirty="0">
                 <a:latin typeface="Times New Roman" panose="02020603050405020304" pitchFamily="18" charset="0"/>
@@ -7457,10 +7555,10 @@
       </p:sp>
       <p:grpSp>
         <p:nvGrpSpPr>
-          <p:cNvPr id="30" name="Group 29">
+          <p:cNvPr id="31" name="Group 30">
             <a:extLst>
               <a:ext uri="{FF2B5EF4-FFF2-40B4-BE49-F238E27FC236}">
-                <a16:creationId xmlns:a16="http://schemas.microsoft.com/office/drawing/2014/main" id="{419FEC76-5159-39F9-23D6-C5BF2417B8D7}"/>
+                <a16:creationId xmlns:a16="http://schemas.microsoft.com/office/drawing/2014/main" id="{CE21605F-CF72-F7F3-96D5-39FFD8641779}"/>
               </a:ext>
             </a:extLst>
           </p:cNvPr>
@@ -8345,15 +8443,22 @@
                   <a:buChar char="•"/>
                 </a:pPr>
                 <a:r>
-                  <a:rPr lang="en-US" sz="1200" dirty="0">
+                  <a:rPr lang="en-US" sz="1200" dirty="0" err="1">
                     <a:solidFill>
                       <a:schemeClr val="bg1"/>
                     </a:solidFill>
                     <a:latin typeface="Times New Roman" panose="02020603050405020304" pitchFamily="18" charset="0"/>
                     <a:cs typeface="Times New Roman" panose="02020603050405020304" pitchFamily="18" charset="0"/>
                   </a:rPr>
-                  <a:t>srsRAN_4G</a:t>
+                  <a:t>Duranta</a:t>
                 </a:r>
+                <a:endParaRPr lang="en-US" sz="1200" dirty="0">
+                  <a:solidFill>
+                    <a:schemeClr val="bg1"/>
+                  </a:solidFill>
+                  <a:latin typeface="Times New Roman" panose="02020603050405020304" pitchFamily="18" charset="0"/>
+                  <a:cs typeface="Times New Roman" panose="02020603050405020304" pitchFamily="18" charset="0"/>
+                </a:endParaRPr>
               </a:p>
               <a:p>
                 <a:pPr marL="285750" indent="-285750">
@@ -8368,7 +8473,7 @@
                     <a:latin typeface="Times New Roman" panose="02020603050405020304" pitchFamily="18" charset="0"/>
                     <a:cs typeface="Times New Roman" panose="02020603050405020304" pitchFamily="18" charset="0"/>
                   </a:rPr>
-                  <a:t>OpenAirInterface5G</a:t>
+                  <a:t>srsRAN_4G</a:t>
                 </a:r>
               </a:p>
             </p:txBody>
@@ -11089,47 +11194,6 @@
         </p:sp>
         <p:sp>
           <p:nvSpPr>
-            <p:cNvPr id="26" name="TextBox 25">
-              <a:extLst>
-                <a:ext uri="{FF2B5EF4-FFF2-40B4-BE49-F238E27FC236}">
-                  <a16:creationId xmlns:a16="http://schemas.microsoft.com/office/drawing/2014/main" id="{ECE108E2-A257-1689-DEB3-58EACB4F7465}"/>
-                </a:ext>
-              </a:extLst>
-            </p:cNvPr>
-            <p:cNvSpPr txBox="1"/>
-            <p:nvPr/>
-          </p:nvSpPr>
-          <p:spPr>
-            <a:xfrm>
-              <a:off x="6506434" y="3236557"/>
-              <a:ext cx="2184599" cy="276999"/>
-            </a:xfrm>
-            <a:prstGeom prst="rect">
-              <a:avLst/>
-            </a:prstGeom>
-            <a:noFill/>
-          </p:spPr>
-          <p:txBody>
-            <a:bodyPr wrap="square">
-              <a:spAutoFit/>
-            </a:bodyPr>
-            <a:lstStyle/>
-            <a:p>
-              <a:r>
-                <a:rPr lang="en-US" sz="1200" dirty="0">
-                  <a:solidFill>
-                    <a:schemeClr val="bg1"/>
-                  </a:solidFill>
-                  <a:latin typeface="Times New Roman" panose="02020603050405020304" pitchFamily="18" charset="0"/>
-                  <a:cs typeface="Times New Roman" panose="02020603050405020304" pitchFamily="18" charset="0"/>
-                </a:rPr>
-                <a:t>E2AP, E2SM</a:t>
-              </a:r>
-            </a:p>
-          </p:txBody>
-        </p:sp>
-        <p:sp>
-          <p:nvSpPr>
             <p:cNvPr id="2" name="TextBox 1">
               <a:extLst>
                 <a:ext uri="{FF2B5EF4-FFF2-40B4-BE49-F238E27FC236}">
@@ -11306,15 +11370,22 @@
                 <a:buChar char="•"/>
               </a:pPr>
               <a:r>
-                <a:rPr lang="en-US" sz="1200" dirty="0">
+                <a:rPr lang="en-US" sz="1200" dirty="0" err="1">
                   <a:solidFill>
                     <a:schemeClr val="bg1"/>
                   </a:solidFill>
                   <a:latin typeface="Times New Roman" panose="02020603050405020304" pitchFamily="18" charset="0"/>
                   <a:cs typeface="Times New Roman" panose="02020603050405020304" pitchFamily="18" charset="0"/>
                 </a:rPr>
-                <a:t>OpenAirInterface5G</a:t>
+                <a:t>Duranta</a:t>
               </a:r>
+              <a:endParaRPr lang="en-US" sz="1200" dirty="0">
+                <a:solidFill>
+                  <a:schemeClr val="bg1"/>
+                </a:solidFill>
+                <a:latin typeface="Times New Roman" panose="02020603050405020304" pitchFamily="18" charset="0"/>
+                <a:cs typeface="Times New Roman" panose="02020603050405020304" pitchFamily="18" charset="0"/>
+              </a:endParaRPr>
             </a:p>
             <a:p>
               <a:pPr marL="285750" indent="-285750">
@@ -11465,6 +11536,133 @@
                   <a:cs typeface="Times New Roman" panose="02020603050405020304" pitchFamily="18" charset="0"/>
                 </a:rPr>
                 <a:t>5G Core Network</a:t>
+              </a:r>
+            </a:p>
+          </p:txBody>
+        </p:sp>
+        <p:sp>
+          <p:nvSpPr>
+            <p:cNvPr id="9" name="TextBox 8">
+              <a:extLst>
+                <a:ext uri="{FF2B5EF4-FFF2-40B4-BE49-F238E27FC236}">
+                  <a16:creationId xmlns:a16="http://schemas.microsoft.com/office/drawing/2014/main" id="{E461C25D-5DF1-0254-6065-28426EC65A82}"/>
+                </a:ext>
+              </a:extLst>
+            </p:cNvPr>
+            <p:cNvSpPr txBox="1"/>
+            <p:nvPr/>
+          </p:nvSpPr>
+          <p:spPr>
+            <a:xfrm>
+              <a:off x="5462495" y="3236557"/>
+              <a:ext cx="1070390" cy="276999"/>
+            </a:xfrm>
+            <a:prstGeom prst="rect">
+              <a:avLst/>
+            </a:prstGeom>
+            <a:noFill/>
+          </p:spPr>
+          <p:txBody>
+            <a:bodyPr wrap="square">
+              <a:spAutoFit/>
+            </a:bodyPr>
+            <a:lstStyle/>
+            <a:p>
+              <a:pPr algn="r"/>
+              <a:r>
+                <a:rPr lang="en-US" sz="1200" dirty="0">
+                  <a:solidFill>
+                    <a:schemeClr val="bg1"/>
+                  </a:solidFill>
+                  <a:latin typeface="Times New Roman" panose="02020603050405020304" pitchFamily="18" charset="0"/>
+                  <a:cs typeface="Times New Roman" panose="02020603050405020304" pitchFamily="18" charset="0"/>
+                </a:rPr>
+                <a:t>E2AP, E2SM</a:t>
+              </a:r>
+            </a:p>
+          </p:txBody>
+        </p:sp>
+        <p:cxnSp>
+          <p:nvCxnSpPr>
+            <p:cNvPr id="10" name="Connector: Elbow 9">
+              <a:extLst>
+                <a:ext uri="{FF2B5EF4-FFF2-40B4-BE49-F238E27FC236}">
+                  <a16:creationId xmlns:a16="http://schemas.microsoft.com/office/drawing/2014/main" id="{2774704E-F7FB-EFBC-F30A-384C7C47641C}"/>
+                </a:ext>
+              </a:extLst>
+            </p:cNvPr>
+            <p:cNvCxnSpPr>
+              <a:cxnSpLocks/>
+            </p:cNvCxnSpPr>
+            <p:nvPr/>
+          </p:nvCxnSpPr>
+          <p:spPr>
+            <a:xfrm rot="5400000" flipH="1" flipV="1">
+              <a:off x="6469218" y="2587933"/>
+              <a:ext cx="1106924" cy="737758"/>
+            </a:xfrm>
+            <a:prstGeom prst="bentConnector2">
+              <a:avLst/>
+            </a:prstGeom>
+            <a:ln w="12700">
+              <a:solidFill>
+                <a:schemeClr val="bg1"/>
+              </a:solidFill>
+              <a:round/>
+            </a:ln>
+          </p:spPr>
+          <p:style>
+            <a:lnRef idx="2">
+              <a:schemeClr val="accent1"/>
+            </a:lnRef>
+            <a:fillRef idx="0">
+              <a:schemeClr val="accent1"/>
+            </a:fillRef>
+            <a:effectRef idx="1">
+              <a:schemeClr val="accent1"/>
+            </a:effectRef>
+            <a:fontRef idx="minor">
+              <a:schemeClr val="tx1"/>
+            </a:fontRef>
+          </p:style>
+        </p:cxnSp>
+        <p:sp>
+          <p:nvSpPr>
+            <p:cNvPr id="27" name="TextBox 26">
+              <a:extLst>
+                <a:ext uri="{FF2B5EF4-FFF2-40B4-BE49-F238E27FC236}">
+                  <a16:creationId xmlns:a16="http://schemas.microsoft.com/office/drawing/2014/main" id="{46894DD9-5176-305F-492B-7B079E65CE06}"/>
+                </a:ext>
+              </a:extLst>
+            </p:cNvPr>
+            <p:cNvSpPr txBox="1"/>
+            <p:nvPr/>
+          </p:nvSpPr>
+          <p:spPr>
+            <a:xfrm>
+              <a:off x="6661420" y="3236557"/>
+              <a:ext cx="1070390" cy="276999"/>
+            </a:xfrm>
+            <a:prstGeom prst="rect">
+              <a:avLst/>
+            </a:prstGeom>
+            <a:noFill/>
+          </p:spPr>
+          <p:txBody>
+            <a:bodyPr wrap="square">
+              <a:spAutoFit/>
+            </a:bodyPr>
+            <a:lstStyle/>
+            <a:p>
+              <a:r>
+                <a:rPr lang="en-US" sz="1200" dirty="0">
+                  <a:solidFill>
+                    <a:schemeClr val="bg1"/>
+                  </a:solidFill>
+                  <a:latin typeface="Times New Roman" panose="02020603050405020304" pitchFamily="18" charset="0"/>
+                  <a:cs typeface="Times New Roman" panose="02020603050405020304" pitchFamily="18" charset="0"/>
+                </a:rPr>
+                <a:t>O1</a:t>
               </a:r>
             </a:p>
           </p:txBody>
@@ -11803,11 +12001,18 @@
               <a:p>
                 <a:pPr algn="ctr"/>
                 <a:r>
+                  <a:rPr lang="en-US" sz="1400" dirty="0" err="1">
+                    <a:latin typeface="Times New Roman" panose="02020603050405020304" pitchFamily="18" charset="0"/>
+                    <a:cs typeface="Times New Roman" panose="02020603050405020304" pitchFamily="18" charset="0"/>
+                  </a:rPr>
+                  <a:t>Duranta</a:t>
+                </a:r>
+                <a:r>
                   <a:rPr lang="en-US" sz="1400" dirty="0">
                     <a:latin typeface="Times New Roman" panose="02020603050405020304" pitchFamily="18" charset="0"/>
                     <a:cs typeface="Times New Roman" panose="02020603050405020304" pitchFamily="18" charset="0"/>
                   </a:rPr>
-                  <a:t>OAI : USRP</a:t>
+                  <a:t> : USRP</a:t>
                 </a:r>
               </a:p>
             </p:txBody>
@@ -11931,11 +12136,18 @@
               <a:p>
                 <a:pPr algn="ctr"/>
                 <a:r>
+                  <a:rPr lang="en-US" sz="1400" dirty="0" err="1">
+                    <a:latin typeface="Times New Roman" panose="02020603050405020304" pitchFamily="18" charset="0"/>
+                    <a:cs typeface="Times New Roman" panose="02020603050405020304" pitchFamily="18" charset="0"/>
+                  </a:rPr>
+                  <a:t>Duranta</a:t>
+                </a:r>
+                <a:r>
                   <a:rPr lang="en-US" sz="1400" dirty="0">
                     <a:latin typeface="Times New Roman" panose="02020603050405020304" pitchFamily="18" charset="0"/>
                     <a:cs typeface="Times New Roman" panose="02020603050405020304" pitchFamily="18" charset="0"/>
                   </a:rPr>
-                  <a:t>OAI : </a:t>
+                  <a:t> : </a:t>
                 </a:r>
                 <a:r>
                   <a:rPr lang="en-US" sz="1400" dirty="0" err="1">
@@ -12035,11 +12247,18 @@
               <a:p>
                 <a:pPr algn="ctr"/>
                 <a:r>
+                  <a:rPr lang="en-US" sz="1400" dirty="0" err="1">
+                    <a:latin typeface="Times New Roman" panose="02020603050405020304" pitchFamily="18" charset="0"/>
+                    <a:cs typeface="Times New Roman" panose="02020603050405020304" pitchFamily="18" charset="0"/>
+                  </a:rPr>
+                  <a:t>Duranta</a:t>
+                </a:r>
+                <a:r>
                   <a:rPr lang="en-US" sz="1400" dirty="0">
                     <a:latin typeface="Times New Roman" panose="02020603050405020304" pitchFamily="18" charset="0"/>
                     <a:cs typeface="Times New Roman" panose="02020603050405020304" pitchFamily="18" charset="0"/>
                   </a:rPr>
-                  <a:t>OAI : RF Simulator</a:t>
+                  <a:t> : RF Simulator</a:t>
                 </a:r>
               </a:p>
             </p:txBody>
@@ -12460,11 +12679,18 @@
               <a:p>
                 <a:pPr algn="ctr"/>
                 <a:r>
+                  <a:rPr lang="en-US" sz="1400" dirty="0" err="1">
+                    <a:latin typeface="Times New Roman" panose="02020603050405020304" pitchFamily="18" charset="0"/>
+                    <a:cs typeface="Times New Roman" panose="02020603050405020304" pitchFamily="18" charset="0"/>
+                  </a:rPr>
+                  <a:t>Duranta</a:t>
+                </a:r>
+                <a:r>
                   <a:rPr lang="en-US" sz="1400" dirty="0">
                     <a:latin typeface="Times New Roman" panose="02020603050405020304" pitchFamily="18" charset="0"/>
                     <a:cs typeface="Times New Roman" panose="02020603050405020304" pitchFamily="18" charset="0"/>
                   </a:rPr>
-                  <a:t>OAI : USRP</a:t>
+                  <a:t> : USRP</a:t>
                 </a:r>
               </a:p>
             </p:txBody>
@@ -12588,11 +12814,18 @@
               <a:p>
                 <a:pPr algn="ctr"/>
                 <a:r>
+                  <a:rPr lang="en-US" sz="1400" dirty="0" err="1">
+                    <a:latin typeface="Times New Roman" panose="02020603050405020304" pitchFamily="18" charset="0"/>
+                    <a:cs typeface="Times New Roman" panose="02020603050405020304" pitchFamily="18" charset="0"/>
+                  </a:rPr>
+                  <a:t>Duranta</a:t>
+                </a:r>
+                <a:r>
                   <a:rPr lang="en-US" sz="1400" dirty="0">
                     <a:latin typeface="Times New Roman" panose="02020603050405020304" pitchFamily="18" charset="0"/>
                     <a:cs typeface="Times New Roman" panose="02020603050405020304" pitchFamily="18" charset="0"/>
                   </a:rPr>
-                  <a:t>OAI : </a:t>
+                  <a:t> : </a:t>
                 </a:r>
                 <a:r>
                   <a:rPr lang="en-US" sz="1400" dirty="0" err="1">
@@ -12692,11 +12925,18 @@
               <a:p>
                 <a:pPr algn="ctr"/>
                 <a:r>
+                  <a:rPr lang="en-US" sz="1400" dirty="0" err="1">
+                    <a:latin typeface="Times New Roman" panose="02020603050405020304" pitchFamily="18" charset="0"/>
+                    <a:cs typeface="Times New Roman" panose="02020603050405020304" pitchFamily="18" charset="0"/>
+                  </a:rPr>
+                  <a:t>Duranta</a:t>
+                </a:r>
+                <a:r>
                   <a:rPr lang="en-US" sz="1400" dirty="0">
                     <a:latin typeface="Times New Roman" panose="02020603050405020304" pitchFamily="18" charset="0"/>
                     <a:cs typeface="Times New Roman" panose="02020603050405020304" pitchFamily="18" charset="0"/>
                   </a:rPr>
-                  <a:t>OAI : RF Simulator</a:t>
+                  <a:t> : RF Simulator</a:t>
                 </a:r>
               </a:p>
             </p:txBody>
@@ -16811,6 +17051,16 @@
               <a:p>
                 <a:pPr algn="ctr"/>
                 <a:r>
+                  <a:rPr lang="en-US" sz="1400" dirty="0" err="1">
+                    <a:solidFill>
+                      <a:schemeClr val="bg1"/>
+                    </a:solidFill>
+                    <a:latin typeface="Times New Roman" panose="02020603050405020304" pitchFamily="18" charset="0"/>
+                    <a:cs typeface="Times New Roman" panose="02020603050405020304" pitchFamily="18" charset="0"/>
+                  </a:rPr>
+                  <a:t>Duranta</a:t>
+                </a:r>
+                <a:r>
                   <a:rPr lang="en-US" sz="1400" dirty="0">
                     <a:solidFill>
                       <a:schemeClr val="bg1"/>
@@ -16818,7 +17068,7 @@
                     <a:latin typeface="Times New Roman" panose="02020603050405020304" pitchFamily="18" charset="0"/>
                     <a:cs typeface="Times New Roman" panose="02020603050405020304" pitchFamily="18" charset="0"/>
                   </a:rPr>
-                  <a:t>OAI : USRP</a:t>
+                  <a:t> : USRP</a:t>
                 </a:r>
               </a:p>
             </p:txBody>
@@ -16954,6 +17204,16 @@
               <a:p>
                 <a:pPr algn="ctr"/>
                 <a:r>
+                  <a:rPr lang="en-US" sz="1400" dirty="0" err="1">
+                    <a:solidFill>
+                      <a:schemeClr val="bg1"/>
+                    </a:solidFill>
+                    <a:latin typeface="Times New Roman" panose="02020603050405020304" pitchFamily="18" charset="0"/>
+                    <a:cs typeface="Times New Roman" panose="02020603050405020304" pitchFamily="18" charset="0"/>
+                  </a:rPr>
+                  <a:t>Duranta</a:t>
+                </a:r>
+                <a:r>
                   <a:rPr lang="en-US" sz="1400" dirty="0">
                     <a:solidFill>
                       <a:schemeClr val="bg1"/>
@@ -16961,7 +17221,7 @@
                     <a:latin typeface="Times New Roman" panose="02020603050405020304" pitchFamily="18" charset="0"/>
                     <a:cs typeface="Times New Roman" panose="02020603050405020304" pitchFamily="18" charset="0"/>
                   </a:rPr>
-                  <a:t>OAI : </a:t>
+                  <a:t> : </a:t>
                 </a:r>
                 <a:r>
                   <a:rPr lang="en-US" sz="1400" dirty="0" err="1">
@@ -17065,6 +17325,16 @@
               <a:p>
                 <a:pPr algn="ctr"/>
                 <a:r>
+                  <a:rPr lang="en-US" sz="1400" dirty="0" err="1">
+                    <a:solidFill>
+                      <a:schemeClr val="bg1"/>
+                    </a:solidFill>
+                    <a:latin typeface="Times New Roman" panose="02020603050405020304" pitchFamily="18" charset="0"/>
+                    <a:cs typeface="Times New Roman" panose="02020603050405020304" pitchFamily="18" charset="0"/>
+                  </a:rPr>
+                  <a:t>Duranta</a:t>
+                </a:r>
+                <a:r>
                   <a:rPr lang="en-US" sz="1400" dirty="0">
                     <a:solidFill>
                       <a:schemeClr val="bg1"/>
@@ -17072,7 +17342,7 @@
                     <a:latin typeface="Times New Roman" panose="02020603050405020304" pitchFamily="18" charset="0"/>
                     <a:cs typeface="Times New Roman" panose="02020603050405020304" pitchFamily="18" charset="0"/>
                   </a:rPr>
-                  <a:t>OAI : RF Simulator</a:t>
+                  <a:t> : RF Simulator</a:t>
                 </a:r>
               </a:p>
             </p:txBody>
@@ -17488,6 +17758,16 @@
               <a:p>
                 <a:pPr algn="ctr"/>
                 <a:r>
+                  <a:rPr lang="en-US" sz="1400" dirty="0" err="1">
+                    <a:solidFill>
+                      <a:schemeClr val="bg1"/>
+                    </a:solidFill>
+                    <a:latin typeface="Times New Roman" panose="02020603050405020304" pitchFamily="18" charset="0"/>
+                    <a:cs typeface="Times New Roman" panose="02020603050405020304" pitchFamily="18" charset="0"/>
+                  </a:rPr>
+                  <a:t>Duranta</a:t>
+                </a:r>
+                <a:r>
                   <a:rPr lang="en-US" sz="1400" dirty="0">
                     <a:solidFill>
                       <a:schemeClr val="bg1"/>
@@ -17495,7 +17775,7 @@
                     <a:latin typeface="Times New Roman" panose="02020603050405020304" pitchFamily="18" charset="0"/>
                     <a:cs typeface="Times New Roman" panose="02020603050405020304" pitchFamily="18" charset="0"/>
                   </a:rPr>
-                  <a:t>OAI : USRP</a:t>
+                  <a:t> : USRP</a:t>
                 </a:r>
               </a:p>
             </p:txBody>
@@ -17631,6 +17911,16 @@
               <a:p>
                 <a:pPr algn="ctr"/>
                 <a:r>
+                  <a:rPr lang="en-US" sz="1400" dirty="0" err="1">
+                    <a:solidFill>
+                      <a:schemeClr val="bg1"/>
+                    </a:solidFill>
+                    <a:latin typeface="Times New Roman" panose="02020603050405020304" pitchFamily="18" charset="0"/>
+                    <a:cs typeface="Times New Roman" panose="02020603050405020304" pitchFamily="18" charset="0"/>
+                  </a:rPr>
+                  <a:t>Duranta</a:t>
+                </a:r>
+                <a:r>
                   <a:rPr lang="en-US" sz="1400" dirty="0">
                     <a:solidFill>
                       <a:schemeClr val="bg1"/>
@@ -17638,7 +17928,7 @@
                     <a:latin typeface="Times New Roman" panose="02020603050405020304" pitchFamily="18" charset="0"/>
                     <a:cs typeface="Times New Roman" panose="02020603050405020304" pitchFamily="18" charset="0"/>
                   </a:rPr>
-                  <a:t>OAI : </a:t>
+                  <a:t> : </a:t>
                 </a:r>
                 <a:r>
                   <a:rPr lang="en-US" sz="1400" dirty="0" err="1">
@@ -17742,6 +18032,16 @@
               <a:p>
                 <a:pPr algn="ctr"/>
                 <a:r>
+                  <a:rPr lang="en-US" sz="1400" dirty="0" err="1">
+                    <a:solidFill>
+                      <a:schemeClr val="bg1"/>
+                    </a:solidFill>
+                    <a:latin typeface="Times New Roman" panose="02020603050405020304" pitchFamily="18" charset="0"/>
+                    <a:cs typeface="Times New Roman" panose="02020603050405020304" pitchFamily="18" charset="0"/>
+                  </a:rPr>
+                  <a:t>Duranta</a:t>
+                </a:r>
+                <a:r>
                   <a:rPr lang="en-US" sz="1400" dirty="0">
                     <a:solidFill>
                       <a:schemeClr val="bg1"/>
@@ -17749,7 +18049,7 @@
                     <a:latin typeface="Times New Roman" panose="02020603050405020304" pitchFamily="18" charset="0"/>
                     <a:cs typeface="Times New Roman" panose="02020603050405020304" pitchFamily="18" charset="0"/>
                   </a:rPr>
-                  <a:t>OAI : RF Simulator</a:t>
+                  <a:t> : RF Simulator</a:t>
                 </a:r>
               </a:p>
             </p:txBody>

</xml_diff>

<commit_message>
Update diagrams and initial references of "Duranta" to "Duranta (OAI)"
</commit_message>
<xml_diff>
--- a/RAN_Intelligent_Controllers/research/Diagrams.pptx
+++ b/RAN_Intelligent_Controllers/research/Diagrams.pptx
@@ -4354,10 +4354,13 @@
                   </a:rPr>
                   <a:t>Duranta</a:t>
                 </a:r>
-                <a:endParaRPr lang="en-US" sz="1200" dirty="0">
-                  <a:latin typeface="Times New Roman" panose="02020603050405020304" pitchFamily="18" charset="0"/>
-                  <a:cs typeface="Times New Roman" panose="02020603050405020304" pitchFamily="18" charset="0"/>
-                </a:endParaRPr>
+                <a:r>
+                  <a:rPr lang="en-US" sz="1200" dirty="0">
+                    <a:latin typeface="Times New Roman" panose="02020603050405020304" pitchFamily="18" charset="0"/>
+                    <a:cs typeface="Times New Roman" panose="02020603050405020304" pitchFamily="18" charset="0"/>
+                  </a:rPr>
+                  <a:t> (OAI)</a:t>
+                </a:r>
               </a:p>
               <a:p>
                 <a:pPr marL="285750" indent="-285750">
@@ -4956,10 +4959,13 @@
                   </a:rPr>
                   <a:t>Duranta</a:t>
                 </a:r>
-                <a:endParaRPr lang="en-US" sz="1200" dirty="0">
-                  <a:latin typeface="Times New Roman" panose="02020603050405020304" pitchFamily="18" charset="0"/>
-                  <a:cs typeface="Times New Roman" panose="02020603050405020304" pitchFamily="18" charset="0"/>
-                </a:endParaRPr>
+                <a:r>
+                  <a:rPr lang="en-US" sz="1200" dirty="0">
+                    <a:latin typeface="Times New Roman" panose="02020603050405020304" pitchFamily="18" charset="0"/>
+                    <a:cs typeface="Times New Roman" panose="02020603050405020304" pitchFamily="18" charset="0"/>
+                  </a:rPr>
+                  <a:t> (OAI)</a:t>
+                </a:r>
               </a:p>
               <a:p>
                 <a:pPr marL="285750" indent="-285750">
@@ -8452,13 +8458,16 @@
                   </a:rPr>
                   <a:t>Duranta</a:t>
                 </a:r>
-                <a:endParaRPr lang="en-US" sz="1200" dirty="0">
-                  <a:solidFill>
-                    <a:schemeClr val="bg1"/>
-                  </a:solidFill>
-                  <a:latin typeface="Times New Roman" panose="02020603050405020304" pitchFamily="18" charset="0"/>
-                  <a:cs typeface="Times New Roman" panose="02020603050405020304" pitchFamily="18" charset="0"/>
-                </a:endParaRPr>
+                <a:r>
+                  <a:rPr lang="en-US" sz="1200" dirty="0">
+                    <a:solidFill>
+                      <a:schemeClr val="bg1"/>
+                    </a:solidFill>
+                    <a:latin typeface="Times New Roman" panose="02020603050405020304" pitchFamily="18" charset="0"/>
+                    <a:cs typeface="Times New Roman" panose="02020603050405020304" pitchFamily="18" charset="0"/>
+                  </a:rPr>
+                  <a:t> (OAI)</a:t>
+                </a:r>
               </a:p>
               <a:p>
                 <a:pPr marL="285750" indent="-285750">
@@ -11379,13 +11388,16 @@
                 </a:rPr>
                 <a:t>Duranta</a:t>
               </a:r>
-              <a:endParaRPr lang="en-US" sz="1200" dirty="0">
-                <a:solidFill>
-                  <a:schemeClr val="bg1"/>
-                </a:solidFill>
-                <a:latin typeface="Times New Roman" panose="02020603050405020304" pitchFamily="18" charset="0"/>
-                <a:cs typeface="Times New Roman" panose="02020603050405020304" pitchFamily="18" charset="0"/>
-              </a:endParaRPr>
+              <a:r>
+                <a:rPr lang="en-US" sz="1200" dirty="0">
+                  <a:solidFill>
+                    <a:schemeClr val="bg1"/>
+                  </a:solidFill>
+                  <a:latin typeface="Times New Roman" panose="02020603050405020304" pitchFamily="18" charset="0"/>
+                  <a:cs typeface="Times New Roman" panose="02020603050405020304" pitchFamily="18" charset="0"/>
+                </a:rPr>
+                <a:t> (OAI)</a:t>
+              </a:r>
             </a:p>
             <a:p>
               <a:pPr marL="285750" indent="-285750">

</xml_diff>

<commit_message>
Restore non-Tutorial files from main to resolve most merge conflicts
</commit_message>
<xml_diff>
--- a/RAN_Intelligent_Controllers/research/Diagrams.pptx
+++ b/RAN_Intelligent_Controllers/research/Diagrams.pptx
@@ -262,7 +262,7 @@
           <a:p>
             <a:fld id="{2D1DF383-F48D-4C35-882C-8A26F25E24F6}" type="datetimeFigureOut">
               <a:rPr lang="en-US" smtClean="0"/>
-              <a:t>5/15/2026</a:t>
+              <a:t>6/9/2026</a:t>
             </a:fld>
             <a:endParaRPr lang="en-US"/>
           </a:p>
@@ -460,7 +460,7 @@
           <a:p>
             <a:fld id="{2D1DF383-F48D-4C35-882C-8A26F25E24F6}" type="datetimeFigureOut">
               <a:rPr lang="en-US" smtClean="0"/>
-              <a:t>5/15/2026</a:t>
+              <a:t>6/9/2026</a:t>
             </a:fld>
             <a:endParaRPr lang="en-US"/>
           </a:p>
@@ -668,7 +668,7 @@
           <a:p>
             <a:fld id="{2D1DF383-F48D-4C35-882C-8A26F25E24F6}" type="datetimeFigureOut">
               <a:rPr lang="en-US" smtClean="0"/>
-              <a:t>5/15/2026</a:t>
+              <a:t>6/9/2026</a:t>
             </a:fld>
             <a:endParaRPr lang="en-US"/>
           </a:p>
@@ -866,7 +866,7 @@
           <a:p>
             <a:fld id="{2D1DF383-F48D-4C35-882C-8A26F25E24F6}" type="datetimeFigureOut">
               <a:rPr lang="en-US" smtClean="0"/>
-              <a:t>5/15/2026</a:t>
+              <a:t>6/9/2026</a:t>
             </a:fld>
             <a:endParaRPr lang="en-US"/>
           </a:p>
@@ -1141,7 +1141,7 @@
           <a:p>
             <a:fld id="{2D1DF383-F48D-4C35-882C-8A26F25E24F6}" type="datetimeFigureOut">
               <a:rPr lang="en-US" smtClean="0"/>
-              <a:t>5/15/2026</a:t>
+              <a:t>6/9/2026</a:t>
             </a:fld>
             <a:endParaRPr lang="en-US"/>
           </a:p>
@@ -1406,7 +1406,7 @@
           <a:p>
             <a:fld id="{2D1DF383-F48D-4C35-882C-8A26F25E24F6}" type="datetimeFigureOut">
               <a:rPr lang="en-US" smtClean="0"/>
-              <a:t>5/15/2026</a:t>
+              <a:t>6/9/2026</a:t>
             </a:fld>
             <a:endParaRPr lang="en-US"/>
           </a:p>
@@ -1818,7 +1818,7 @@
           <a:p>
             <a:fld id="{2D1DF383-F48D-4C35-882C-8A26F25E24F6}" type="datetimeFigureOut">
               <a:rPr lang="en-US" smtClean="0"/>
-              <a:t>5/15/2026</a:t>
+              <a:t>6/9/2026</a:t>
             </a:fld>
             <a:endParaRPr lang="en-US"/>
           </a:p>
@@ -1959,7 +1959,7 @@
           <a:p>
             <a:fld id="{2D1DF383-F48D-4C35-882C-8A26F25E24F6}" type="datetimeFigureOut">
               <a:rPr lang="en-US" smtClean="0"/>
-              <a:t>5/15/2026</a:t>
+              <a:t>6/9/2026</a:t>
             </a:fld>
             <a:endParaRPr lang="en-US"/>
           </a:p>
@@ -2072,7 +2072,7 @@
           <a:p>
             <a:fld id="{2D1DF383-F48D-4C35-882C-8A26F25E24F6}" type="datetimeFigureOut">
               <a:rPr lang="en-US" smtClean="0"/>
-              <a:t>5/15/2026</a:t>
+              <a:t>6/9/2026</a:t>
             </a:fld>
             <a:endParaRPr lang="en-US"/>
           </a:p>
@@ -2383,7 +2383,7 @@
           <a:p>
             <a:fld id="{2D1DF383-F48D-4C35-882C-8A26F25E24F6}" type="datetimeFigureOut">
               <a:rPr lang="en-US" smtClean="0"/>
-              <a:t>5/15/2026</a:t>
+              <a:t>6/9/2026</a:t>
             </a:fld>
             <a:endParaRPr lang="en-US"/>
           </a:p>
@@ -2671,7 +2671,7 @@
           <a:p>
             <a:fld id="{2D1DF383-F48D-4C35-882C-8A26F25E24F6}" type="datetimeFigureOut">
               <a:rPr lang="en-US" smtClean="0"/>
-              <a:t>5/15/2026</a:t>
+              <a:t>6/9/2026</a:t>
             </a:fld>
             <a:endParaRPr lang="en-US"/>
           </a:p>
@@ -2912,7 +2912,7 @@
           <a:p>
             <a:fld id="{2D1DF383-F48D-4C35-882C-8A26F25E24F6}" type="datetimeFigureOut">
               <a:rPr lang="en-US" smtClean="0"/>
-              <a:t>5/15/2026</a:t>
+              <a:t>6/9/2026</a:t>
             </a:fld>
             <a:endParaRPr lang="en-US"/>
           </a:p>
@@ -3337,10 +3337,10 @@
       </p:grpSpPr>
       <p:grpSp>
         <p:nvGrpSpPr>
-          <p:cNvPr id="20" name="Group 19">
+          <p:cNvPr id="28" name="Group 27">
             <a:extLst>
               <a:ext uri="{FF2B5EF4-FFF2-40B4-BE49-F238E27FC236}">
-                <a16:creationId xmlns:a16="http://schemas.microsoft.com/office/drawing/2014/main" id="{ACE60489-66B9-A95C-9A12-954E4073475D}"/>
+                <a16:creationId xmlns:a16="http://schemas.microsoft.com/office/drawing/2014/main" id="{2637F0BA-D326-931D-5858-7771587A6EC4}"/>
               </a:ext>
             </a:extLst>
           </p:cNvPr>
@@ -4348,11 +4348,18 @@
                   <a:buChar char="•"/>
                 </a:pPr>
                 <a:r>
+                  <a:rPr lang="en-US" sz="1200" dirty="0" err="1">
+                    <a:latin typeface="Times New Roman" panose="02020603050405020304" pitchFamily="18" charset="0"/>
+                    <a:cs typeface="Times New Roman" panose="02020603050405020304" pitchFamily="18" charset="0"/>
+                  </a:rPr>
+                  <a:t>Duranta</a:t>
+                </a:r>
+                <a:r>
                   <a:rPr lang="en-US" sz="1200" dirty="0">
                     <a:latin typeface="Times New Roman" panose="02020603050405020304" pitchFamily="18" charset="0"/>
                     <a:cs typeface="Times New Roman" panose="02020603050405020304" pitchFamily="18" charset="0"/>
                   </a:rPr>
-                  <a:t>srsRAN_4G</a:t>
+                  <a:t> (OAI)</a:t>
                 </a:r>
               </a:p>
               <a:p>
@@ -4365,7 +4372,7 @@
                     <a:latin typeface="Times New Roman" panose="02020603050405020304" pitchFamily="18" charset="0"/>
                     <a:cs typeface="Times New Roman" panose="02020603050405020304" pitchFamily="18" charset="0"/>
                   </a:rPr>
-                  <a:t>OpenAirInterface5G</a:t>
+                  <a:t>srsRAN_4G</a:t>
                 </a:r>
               </a:p>
             </p:txBody>
@@ -4946,11 +4953,18 @@
                   <a:buChar char="•"/>
                 </a:pPr>
                 <a:r>
+                  <a:rPr lang="en-US" sz="1200" dirty="0" err="1">
+                    <a:latin typeface="Times New Roman" panose="02020603050405020304" pitchFamily="18" charset="0"/>
+                    <a:cs typeface="Times New Roman" panose="02020603050405020304" pitchFamily="18" charset="0"/>
+                  </a:rPr>
+                  <a:t>Duranta</a:t>
+                </a:r>
+                <a:r>
                   <a:rPr lang="en-US" sz="1200" dirty="0">
                     <a:latin typeface="Times New Roman" panose="02020603050405020304" pitchFamily="18" charset="0"/>
                     <a:cs typeface="Times New Roman" panose="02020603050405020304" pitchFamily="18" charset="0"/>
                   </a:rPr>
-                  <a:t>OpenAirInterface5G</a:t>
+                  <a:t> (OAI)</a:t>
                 </a:r>
               </a:p>
               <a:p>
@@ -7338,8 +7352,98 @@
           </p:nvSpPr>
           <p:spPr>
             <a:xfrm>
-              <a:off x="6506434" y="3236557"/>
-              <a:ext cx="2184599" cy="276999"/>
+              <a:off x="5462495" y="3236557"/>
+              <a:ext cx="1070390" cy="276999"/>
+            </a:xfrm>
+            <a:prstGeom prst="rect">
+              <a:avLst/>
+            </a:prstGeom>
+            <a:noFill/>
+          </p:spPr>
+          <p:txBody>
+            <a:bodyPr wrap="square">
+              <a:spAutoFit/>
+            </a:bodyPr>
+            <a:lstStyle/>
+            <a:p>
+              <a:pPr algn="r"/>
+              <a:r>
+                <a:rPr lang="en-US" sz="1200" dirty="0">
+                  <a:solidFill>
+                    <a:schemeClr val="tx1"/>
+                  </a:solidFill>
+                  <a:latin typeface="Times New Roman" panose="02020603050405020304" pitchFamily="18" charset="0"/>
+                  <a:cs typeface="Times New Roman" panose="02020603050405020304" pitchFamily="18" charset="0"/>
+                </a:rPr>
+                <a:t>E2AP, E2SM</a:t>
+              </a:r>
+              <a:endParaRPr lang="en-US" sz="1200" dirty="0">
+                <a:latin typeface="Times New Roman" panose="02020603050405020304" pitchFamily="18" charset="0"/>
+                <a:cs typeface="Times New Roman" panose="02020603050405020304" pitchFamily="18" charset="0"/>
+              </a:endParaRPr>
+            </a:p>
+          </p:txBody>
+        </p:sp>
+        <p:cxnSp>
+          <p:nvCxnSpPr>
+            <p:cNvPr id="11" name="Connector: Elbow 10">
+              <a:extLst>
+                <a:ext uri="{FF2B5EF4-FFF2-40B4-BE49-F238E27FC236}">
+                  <a16:creationId xmlns:a16="http://schemas.microsoft.com/office/drawing/2014/main" id="{4D82E7A1-98F3-FD79-1066-4E1CF0E43B97}"/>
+                </a:ext>
+              </a:extLst>
+            </p:cNvPr>
+            <p:cNvCxnSpPr>
+              <a:cxnSpLocks/>
+            </p:cNvCxnSpPr>
+            <p:nvPr/>
+          </p:nvCxnSpPr>
+          <p:spPr>
+            <a:xfrm rot="5400000" flipH="1" flipV="1">
+              <a:off x="6469218" y="2587933"/>
+              <a:ext cx="1106924" cy="737758"/>
+            </a:xfrm>
+            <a:prstGeom prst="bentConnector2">
+              <a:avLst/>
+            </a:prstGeom>
+            <a:ln w="12700">
+              <a:solidFill>
+                <a:schemeClr val="tx1"/>
+              </a:solidFill>
+              <a:round/>
+            </a:ln>
+          </p:spPr>
+          <p:style>
+            <a:lnRef idx="2">
+              <a:schemeClr val="accent1"/>
+            </a:lnRef>
+            <a:fillRef idx="0">
+              <a:schemeClr val="accent1"/>
+            </a:fillRef>
+            <a:effectRef idx="1">
+              <a:schemeClr val="accent1"/>
+            </a:effectRef>
+            <a:fontRef idx="minor">
+              <a:schemeClr val="tx1"/>
+            </a:fontRef>
+          </p:style>
+        </p:cxnSp>
+        <p:sp>
+          <p:nvSpPr>
+            <p:cNvPr id="26" name="TextBox 25">
+              <a:extLst>
+                <a:ext uri="{FF2B5EF4-FFF2-40B4-BE49-F238E27FC236}">
+                  <a16:creationId xmlns:a16="http://schemas.microsoft.com/office/drawing/2014/main" id="{1569B6B9-3D7C-49AE-5735-FC1B9B121F65}"/>
+                </a:ext>
+              </a:extLst>
+            </p:cNvPr>
+            <p:cNvSpPr txBox="1"/>
+            <p:nvPr/>
+          </p:nvSpPr>
+          <p:spPr>
+            <a:xfrm>
+              <a:off x="6661420" y="3236557"/>
+              <a:ext cx="1070390" cy="276999"/>
             </a:xfrm>
             <a:prstGeom prst="rect">
               <a:avLst/>
@@ -7360,7 +7464,7 @@
                   <a:latin typeface="Times New Roman" panose="02020603050405020304" pitchFamily="18" charset="0"/>
                   <a:cs typeface="Times New Roman" panose="02020603050405020304" pitchFamily="18" charset="0"/>
                 </a:rPr>
-                <a:t>E2AP, E2SM</a:t>
+                <a:t>O1</a:t>
               </a:r>
               <a:endParaRPr lang="en-US" sz="1200" dirty="0">
                 <a:latin typeface="Times New Roman" panose="02020603050405020304" pitchFamily="18" charset="0"/>
@@ -7457,10 +7561,10 @@
       </p:sp>
       <p:grpSp>
         <p:nvGrpSpPr>
-          <p:cNvPr id="30" name="Group 29">
+          <p:cNvPr id="31" name="Group 30">
             <a:extLst>
               <a:ext uri="{FF2B5EF4-FFF2-40B4-BE49-F238E27FC236}">
-                <a16:creationId xmlns:a16="http://schemas.microsoft.com/office/drawing/2014/main" id="{419FEC76-5159-39F9-23D6-C5BF2417B8D7}"/>
+                <a16:creationId xmlns:a16="http://schemas.microsoft.com/office/drawing/2014/main" id="{CE21605F-CF72-F7F3-96D5-39FFD8641779}"/>
               </a:ext>
             </a:extLst>
           </p:cNvPr>
@@ -8345,6 +8449,16 @@
                   <a:buChar char="•"/>
                 </a:pPr>
                 <a:r>
+                  <a:rPr lang="en-US" sz="1200" dirty="0" err="1">
+                    <a:solidFill>
+                      <a:schemeClr val="bg1"/>
+                    </a:solidFill>
+                    <a:latin typeface="Times New Roman" panose="02020603050405020304" pitchFamily="18" charset="0"/>
+                    <a:cs typeface="Times New Roman" panose="02020603050405020304" pitchFamily="18" charset="0"/>
+                  </a:rPr>
+                  <a:t>Duranta</a:t>
+                </a:r>
+                <a:r>
                   <a:rPr lang="en-US" sz="1200" dirty="0">
                     <a:solidFill>
                       <a:schemeClr val="bg1"/>
@@ -8352,7 +8466,7 @@
                     <a:latin typeface="Times New Roman" panose="02020603050405020304" pitchFamily="18" charset="0"/>
                     <a:cs typeface="Times New Roman" panose="02020603050405020304" pitchFamily="18" charset="0"/>
                   </a:rPr>
-                  <a:t>srsRAN_4G</a:t>
+                  <a:t> (OAI)</a:t>
                 </a:r>
               </a:p>
               <a:p>
@@ -8368,7 +8482,7 @@
                     <a:latin typeface="Times New Roman" panose="02020603050405020304" pitchFamily="18" charset="0"/>
                     <a:cs typeface="Times New Roman" panose="02020603050405020304" pitchFamily="18" charset="0"/>
                   </a:rPr>
-                  <a:t>OpenAirInterface5G</a:t>
+                  <a:t>srsRAN_4G</a:t>
                 </a:r>
               </a:p>
             </p:txBody>
@@ -11089,47 +11203,6 @@
         </p:sp>
         <p:sp>
           <p:nvSpPr>
-            <p:cNvPr id="26" name="TextBox 25">
-              <a:extLst>
-                <a:ext uri="{FF2B5EF4-FFF2-40B4-BE49-F238E27FC236}">
-                  <a16:creationId xmlns:a16="http://schemas.microsoft.com/office/drawing/2014/main" id="{ECE108E2-A257-1689-DEB3-58EACB4F7465}"/>
-                </a:ext>
-              </a:extLst>
-            </p:cNvPr>
-            <p:cNvSpPr txBox="1"/>
-            <p:nvPr/>
-          </p:nvSpPr>
-          <p:spPr>
-            <a:xfrm>
-              <a:off x="6506434" y="3236557"/>
-              <a:ext cx="2184599" cy="276999"/>
-            </a:xfrm>
-            <a:prstGeom prst="rect">
-              <a:avLst/>
-            </a:prstGeom>
-            <a:noFill/>
-          </p:spPr>
-          <p:txBody>
-            <a:bodyPr wrap="square">
-              <a:spAutoFit/>
-            </a:bodyPr>
-            <a:lstStyle/>
-            <a:p>
-              <a:r>
-                <a:rPr lang="en-US" sz="1200" dirty="0">
-                  <a:solidFill>
-                    <a:schemeClr val="bg1"/>
-                  </a:solidFill>
-                  <a:latin typeface="Times New Roman" panose="02020603050405020304" pitchFamily="18" charset="0"/>
-                  <a:cs typeface="Times New Roman" panose="02020603050405020304" pitchFamily="18" charset="0"/>
-                </a:rPr>
-                <a:t>E2AP, E2SM</a:t>
-              </a:r>
-            </a:p>
-          </p:txBody>
-        </p:sp>
-        <p:sp>
-          <p:nvSpPr>
             <p:cNvPr id="2" name="TextBox 1">
               <a:extLst>
                 <a:ext uri="{FF2B5EF4-FFF2-40B4-BE49-F238E27FC236}">
@@ -11306,6 +11379,16 @@
                 <a:buChar char="•"/>
               </a:pPr>
               <a:r>
+                <a:rPr lang="en-US" sz="1200" dirty="0" err="1">
+                  <a:solidFill>
+                    <a:schemeClr val="bg1"/>
+                  </a:solidFill>
+                  <a:latin typeface="Times New Roman" panose="02020603050405020304" pitchFamily="18" charset="0"/>
+                  <a:cs typeface="Times New Roman" panose="02020603050405020304" pitchFamily="18" charset="0"/>
+                </a:rPr>
+                <a:t>Duranta</a:t>
+              </a:r>
+              <a:r>
                 <a:rPr lang="en-US" sz="1200" dirty="0">
                   <a:solidFill>
                     <a:schemeClr val="bg1"/>
@@ -11313,7 +11396,7 @@
                   <a:latin typeface="Times New Roman" panose="02020603050405020304" pitchFamily="18" charset="0"/>
                   <a:cs typeface="Times New Roman" panose="02020603050405020304" pitchFamily="18" charset="0"/>
                 </a:rPr>
-                <a:t>OpenAirInterface5G</a:t>
+                <a:t> (OAI)</a:t>
               </a:r>
             </a:p>
             <a:p>
@@ -11465,6 +11548,133 @@
                   <a:cs typeface="Times New Roman" panose="02020603050405020304" pitchFamily="18" charset="0"/>
                 </a:rPr>
                 <a:t>5G Core Network</a:t>
+              </a:r>
+            </a:p>
+          </p:txBody>
+        </p:sp>
+        <p:sp>
+          <p:nvSpPr>
+            <p:cNvPr id="9" name="TextBox 8">
+              <a:extLst>
+                <a:ext uri="{FF2B5EF4-FFF2-40B4-BE49-F238E27FC236}">
+                  <a16:creationId xmlns:a16="http://schemas.microsoft.com/office/drawing/2014/main" id="{E461C25D-5DF1-0254-6065-28426EC65A82}"/>
+                </a:ext>
+              </a:extLst>
+            </p:cNvPr>
+            <p:cNvSpPr txBox="1"/>
+            <p:nvPr/>
+          </p:nvSpPr>
+          <p:spPr>
+            <a:xfrm>
+              <a:off x="5462495" y="3236557"/>
+              <a:ext cx="1070390" cy="276999"/>
+            </a:xfrm>
+            <a:prstGeom prst="rect">
+              <a:avLst/>
+            </a:prstGeom>
+            <a:noFill/>
+          </p:spPr>
+          <p:txBody>
+            <a:bodyPr wrap="square">
+              <a:spAutoFit/>
+            </a:bodyPr>
+            <a:lstStyle/>
+            <a:p>
+              <a:pPr algn="r"/>
+              <a:r>
+                <a:rPr lang="en-US" sz="1200" dirty="0">
+                  <a:solidFill>
+                    <a:schemeClr val="bg1"/>
+                  </a:solidFill>
+                  <a:latin typeface="Times New Roman" panose="02020603050405020304" pitchFamily="18" charset="0"/>
+                  <a:cs typeface="Times New Roman" panose="02020603050405020304" pitchFamily="18" charset="0"/>
+                </a:rPr>
+                <a:t>E2AP, E2SM</a:t>
+              </a:r>
+            </a:p>
+          </p:txBody>
+        </p:sp>
+        <p:cxnSp>
+          <p:nvCxnSpPr>
+            <p:cNvPr id="10" name="Connector: Elbow 9">
+              <a:extLst>
+                <a:ext uri="{FF2B5EF4-FFF2-40B4-BE49-F238E27FC236}">
+                  <a16:creationId xmlns:a16="http://schemas.microsoft.com/office/drawing/2014/main" id="{2774704E-F7FB-EFBC-F30A-384C7C47641C}"/>
+                </a:ext>
+              </a:extLst>
+            </p:cNvPr>
+            <p:cNvCxnSpPr>
+              <a:cxnSpLocks/>
+            </p:cNvCxnSpPr>
+            <p:nvPr/>
+          </p:nvCxnSpPr>
+          <p:spPr>
+            <a:xfrm rot="5400000" flipH="1" flipV="1">
+              <a:off x="6469218" y="2587933"/>
+              <a:ext cx="1106924" cy="737758"/>
+            </a:xfrm>
+            <a:prstGeom prst="bentConnector2">
+              <a:avLst/>
+            </a:prstGeom>
+            <a:ln w="12700">
+              <a:solidFill>
+                <a:schemeClr val="bg1"/>
+              </a:solidFill>
+              <a:round/>
+            </a:ln>
+          </p:spPr>
+          <p:style>
+            <a:lnRef idx="2">
+              <a:schemeClr val="accent1"/>
+            </a:lnRef>
+            <a:fillRef idx="0">
+              <a:schemeClr val="accent1"/>
+            </a:fillRef>
+            <a:effectRef idx="1">
+              <a:schemeClr val="accent1"/>
+            </a:effectRef>
+            <a:fontRef idx="minor">
+              <a:schemeClr val="tx1"/>
+            </a:fontRef>
+          </p:style>
+        </p:cxnSp>
+        <p:sp>
+          <p:nvSpPr>
+            <p:cNvPr id="27" name="TextBox 26">
+              <a:extLst>
+                <a:ext uri="{FF2B5EF4-FFF2-40B4-BE49-F238E27FC236}">
+                  <a16:creationId xmlns:a16="http://schemas.microsoft.com/office/drawing/2014/main" id="{46894DD9-5176-305F-492B-7B079E65CE06}"/>
+                </a:ext>
+              </a:extLst>
+            </p:cNvPr>
+            <p:cNvSpPr txBox="1"/>
+            <p:nvPr/>
+          </p:nvSpPr>
+          <p:spPr>
+            <a:xfrm>
+              <a:off x="6661420" y="3236557"/>
+              <a:ext cx="1070390" cy="276999"/>
+            </a:xfrm>
+            <a:prstGeom prst="rect">
+              <a:avLst/>
+            </a:prstGeom>
+            <a:noFill/>
+          </p:spPr>
+          <p:txBody>
+            <a:bodyPr wrap="square">
+              <a:spAutoFit/>
+            </a:bodyPr>
+            <a:lstStyle/>
+            <a:p>
+              <a:r>
+                <a:rPr lang="en-US" sz="1200" dirty="0">
+                  <a:solidFill>
+                    <a:schemeClr val="bg1"/>
+                  </a:solidFill>
+                  <a:latin typeface="Times New Roman" panose="02020603050405020304" pitchFamily="18" charset="0"/>
+                  <a:cs typeface="Times New Roman" panose="02020603050405020304" pitchFamily="18" charset="0"/>
+                </a:rPr>
+                <a:t>O1</a:t>
               </a:r>
             </a:p>
           </p:txBody>
@@ -11803,11 +12013,18 @@
               <a:p>
                 <a:pPr algn="ctr"/>
                 <a:r>
+                  <a:rPr lang="en-US" sz="1400" dirty="0" err="1">
+                    <a:latin typeface="Times New Roman" panose="02020603050405020304" pitchFamily="18" charset="0"/>
+                    <a:cs typeface="Times New Roman" panose="02020603050405020304" pitchFamily="18" charset="0"/>
+                  </a:rPr>
+                  <a:t>Duranta</a:t>
+                </a:r>
+                <a:r>
                   <a:rPr lang="en-US" sz="1400" dirty="0">
                     <a:latin typeface="Times New Roman" panose="02020603050405020304" pitchFamily="18" charset="0"/>
                     <a:cs typeface="Times New Roman" panose="02020603050405020304" pitchFamily="18" charset="0"/>
                   </a:rPr>
-                  <a:t>OAI : USRP</a:t>
+                  <a:t> : USRP</a:t>
                 </a:r>
               </a:p>
             </p:txBody>
@@ -11931,11 +12148,18 @@
               <a:p>
                 <a:pPr algn="ctr"/>
                 <a:r>
+                  <a:rPr lang="en-US" sz="1400" dirty="0" err="1">
+                    <a:latin typeface="Times New Roman" panose="02020603050405020304" pitchFamily="18" charset="0"/>
+                    <a:cs typeface="Times New Roman" panose="02020603050405020304" pitchFamily="18" charset="0"/>
+                  </a:rPr>
+                  <a:t>Duranta</a:t>
+                </a:r>
+                <a:r>
                   <a:rPr lang="en-US" sz="1400" dirty="0">
                     <a:latin typeface="Times New Roman" panose="02020603050405020304" pitchFamily="18" charset="0"/>
                     <a:cs typeface="Times New Roman" panose="02020603050405020304" pitchFamily="18" charset="0"/>
                   </a:rPr>
-                  <a:t>OAI : </a:t>
+                  <a:t> : </a:t>
                 </a:r>
                 <a:r>
                   <a:rPr lang="en-US" sz="1400" dirty="0" err="1">
@@ -12035,11 +12259,18 @@
               <a:p>
                 <a:pPr algn="ctr"/>
                 <a:r>
+                  <a:rPr lang="en-US" sz="1400" dirty="0" err="1">
+                    <a:latin typeface="Times New Roman" panose="02020603050405020304" pitchFamily="18" charset="0"/>
+                    <a:cs typeface="Times New Roman" panose="02020603050405020304" pitchFamily="18" charset="0"/>
+                  </a:rPr>
+                  <a:t>Duranta</a:t>
+                </a:r>
+                <a:r>
                   <a:rPr lang="en-US" sz="1400" dirty="0">
                     <a:latin typeface="Times New Roman" panose="02020603050405020304" pitchFamily="18" charset="0"/>
                     <a:cs typeface="Times New Roman" panose="02020603050405020304" pitchFamily="18" charset="0"/>
                   </a:rPr>
-                  <a:t>OAI : RF Simulator</a:t>
+                  <a:t> : RF Simulator</a:t>
                 </a:r>
               </a:p>
             </p:txBody>
@@ -12460,11 +12691,18 @@
               <a:p>
                 <a:pPr algn="ctr"/>
                 <a:r>
+                  <a:rPr lang="en-US" sz="1400" dirty="0" err="1">
+                    <a:latin typeface="Times New Roman" panose="02020603050405020304" pitchFamily="18" charset="0"/>
+                    <a:cs typeface="Times New Roman" panose="02020603050405020304" pitchFamily="18" charset="0"/>
+                  </a:rPr>
+                  <a:t>Duranta</a:t>
+                </a:r>
+                <a:r>
                   <a:rPr lang="en-US" sz="1400" dirty="0">
                     <a:latin typeface="Times New Roman" panose="02020603050405020304" pitchFamily="18" charset="0"/>
                     <a:cs typeface="Times New Roman" panose="02020603050405020304" pitchFamily="18" charset="0"/>
                   </a:rPr>
-                  <a:t>OAI : USRP</a:t>
+                  <a:t> : USRP</a:t>
                 </a:r>
               </a:p>
             </p:txBody>
@@ -12588,11 +12826,18 @@
               <a:p>
                 <a:pPr algn="ctr"/>
                 <a:r>
+                  <a:rPr lang="en-US" sz="1400" dirty="0" err="1">
+                    <a:latin typeface="Times New Roman" panose="02020603050405020304" pitchFamily="18" charset="0"/>
+                    <a:cs typeface="Times New Roman" panose="02020603050405020304" pitchFamily="18" charset="0"/>
+                  </a:rPr>
+                  <a:t>Duranta</a:t>
+                </a:r>
+                <a:r>
                   <a:rPr lang="en-US" sz="1400" dirty="0">
                     <a:latin typeface="Times New Roman" panose="02020603050405020304" pitchFamily="18" charset="0"/>
                     <a:cs typeface="Times New Roman" panose="02020603050405020304" pitchFamily="18" charset="0"/>
                   </a:rPr>
-                  <a:t>OAI : </a:t>
+                  <a:t> : </a:t>
                 </a:r>
                 <a:r>
                   <a:rPr lang="en-US" sz="1400" dirty="0" err="1">
@@ -12692,11 +12937,18 @@
               <a:p>
                 <a:pPr algn="ctr"/>
                 <a:r>
+                  <a:rPr lang="en-US" sz="1400" dirty="0" err="1">
+                    <a:latin typeface="Times New Roman" panose="02020603050405020304" pitchFamily="18" charset="0"/>
+                    <a:cs typeface="Times New Roman" panose="02020603050405020304" pitchFamily="18" charset="0"/>
+                  </a:rPr>
+                  <a:t>Duranta</a:t>
+                </a:r>
+                <a:r>
                   <a:rPr lang="en-US" sz="1400" dirty="0">
                     <a:latin typeface="Times New Roman" panose="02020603050405020304" pitchFamily="18" charset="0"/>
                     <a:cs typeface="Times New Roman" panose="02020603050405020304" pitchFamily="18" charset="0"/>
                   </a:rPr>
-                  <a:t>OAI : RF Simulator</a:t>
+                  <a:t> : RF Simulator</a:t>
                 </a:r>
               </a:p>
             </p:txBody>
@@ -16811,6 +17063,16 @@
               <a:p>
                 <a:pPr algn="ctr"/>
                 <a:r>
+                  <a:rPr lang="en-US" sz="1400" dirty="0" err="1">
+                    <a:solidFill>
+                      <a:schemeClr val="bg1"/>
+                    </a:solidFill>
+                    <a:latin typeface="Times New Roman" panose="02020603050405020304" pitchFamily="18" charset="0"/>
+                    <a:cs typeface="Times New Roman" panose="02020603050405020304" pitchFamily="18" charset="0"/>
+                  </a:rPr>
+                  <a:t>Duranta</a:t>
+                </a:r>
+                <a:r>
                   <a:rPr lang="en-US" sz="1400" dirty="0">
                     <a:solidFill>
                       <a:schemeClr val="bg1"/>
@@ -16818,7 +17080,7 @@
                     <a:latin typeface="Times New Roman" panose="02020603050405020304" pitchFamily="18" charset="0"/>
                     <a:cs typeface="Times New Roman" panose="02020603050405020304" pitchFamily="18" charset="0"/>
                   </a:rPr>
-                  <a:t>OAI : USRP</a:t>
+                  <a:t> : USRP</a:t>
                 </a:r>
               </a:p>
             </p:txBody>
@@ -16954,6 +17216,16 @@
               <a:p>
                 <a:pPr algn="ctr"/>
                 <a:r>
+                  <a:rPr lang="en-US" sz="1400" dirty="0" err="1">
+                    <a:solidFill>
+                      <a:schemeClr val="bg1"/>
+                    </a:solidFill>
+                    <a:latin typeface="Times New Roman" panose="02020603050405020304" pitchFamily="18" charset="0"/>
+                    <a:cs typeface="Times New Roman" panose="02020603050405020304" pitchFamily="18" charset="0"/>
+                  </a:rPr>
+                  <a:t>Duranta</a:t>
+                </a:r>
+                <a:r>
                   <a:rPr lang="en-US" sz="1400" dirty="0">
                     <a:solidFill>
                       <a:schemeClr val="bg1"/>
@@ -16961,7 +17233,7 @@
                     <a:latin typeface="Times New Roman" panose="02020603050405020304" pitchFamily="18" charset="0"/>
                     <a:cs typeface="Times New Roman" panose="02020603050405020304" pitchFamily="18" charset="0"/>
                   </a:rPr>
-                  <a:t>OAI : </a:t>
+                  <a:t> : </a:t>
                 </a:r>
                 <a:r>
                   <a:rPr lang="en-US" sz="1400" dirty="0" err="1">
@@ -17065,6 +17337,16 @@
               <a:p>
                 <a:pPr algn="ctr"/>
                 <a:r>
+                  <a:rPr lang="en-US" sz="1400" dirty="0" err="1">
+                    <a:solidFill>
+                      <a:schemeClr val="bg1"/>
+                    </a:solidFill>
+                    <a:latin typeface="Times New Roman" panose="02020603050405020304" pitchFamily="18" charset="0"/>
+                    <a:cs typeface="Times New Roman" panose="02020603050405020304" pitchFamily="18" charset="0"/>
+                  </a:rPr>
+                  <a:t>Duranta</a:t>
+                </a:r>
+                <a:r>
                   <a:rPr lang="en-US" sz="1400" dirty="0">
                     <a:solidFill>
                       <a:schemeClr val="bg1"/>
@@ -17072,7 +17354,7 @@
                     <a:latin typeface="Times New Roman" panose="02020603050405020304" pitchFamily="18" charset="0"/>
                     <a:cs typeface="Times New Roman" panose="02020603050405020304" pitchFamily="18" charset="0"/>
                   </a:rPr>
-                  <a:t>OAI : RF Simulator</a:t>
+                  <a:t> : RF Simulator</a:t>
                 </a:r>
               </a:p>
             </p:txBody>
@@ -17488,6 +17770,16 @@
               <a:p>
                 <a:pPr algn="ctr"/>
                 <a:r>
+                  <a:rPr lang="en-US" sz="1400" dirty="0" err="1">
+                    <a:solidFill>
+                      <a:schemeClr val="bg1"/>
+                    </a:solidFill>
+                    <a:latin typeface="Times New Roman" panose="02020603050405020304" pitchFamily="18" charset="0"/>
+                    <a:cs typeface="Times New Roman" panose="02020603050405020304" pitchFamily="18" charset="0"/>
+                  </a:rPr>
+                  <a:t>Duranta</a:t>
+                </a:r>
+                <a:r>
                   <a:rPr lang="en-US" sz="1400" dirty="0">
                     <a:solidFill>
                       <a:schemeClr val="bg1"/>
@@ -17495,7 +17787,7 @@
                     <a:latin typeface="Times New Roman" panose="02020603050405020304" pitchFamily="18" charset="0"/>
                     <a:cs typeface="Times New Roman" panose="02020603050405020304" pitchFamily="18" charset="0"/>
                   </a:rPr>
-                  <a:t>OAI : USRP</a:t>
+                  <a:t> : USRP</a:t>
                 </a:r>
               </a:p>
             </p:txBody>
@@ -17631,6 +17923,16 @@
               <a:p>
                 <a:pPr algn="ctr"/>
                 <a:r>
+                  <a:rPr lang="en-US" sz="1400" dirty="0" err="1">
+                    <a:solidFill>
+                      <a:schemeClr val="bg1"/>
+                    </a:solidFill>
+                    <a:latin typeface="Times New Roman" panose="02020603050405020304" pitchFamily="18" charset="0"/>
+                    <a:cs typeface="Times New Roman" panose="02020603050405020304" pitchFamily="18" charset="0"/>
+                  </a:rPr>
+                  <a:t>Duranta</a:t>
+                </a:r>
+                <a:r>
                   <a:rPr lang="en-US" sz="1400" dirty="0">
                     <a:solidFill>
                       <a:schemeClr val="bg1"/>
@@ -17638,7 +17940,7 @@
                     <a:latin typeface="Times New Roman" panose="02020603050405020304" pitchFamily="18" charset="0"/>
                     <a:cs typeface="Times New Roman" panose="02020603050405020304" pitchFamily="18" charset="0"/>
                   </a:rPr>
-                  <a:t>OAI : </a:t>
+                  <a:t> : </a:t>
                 </a:r>
                 <a:r>
                   <a:rPr lang="en-US" sz="1400" dirty="0" err="1">
@@ -17742,6 +18044,16 @@
               <a:p>
                 <a:pPr algn="ctr"/>
                 <a:r>
+                  <a:rPr lang="en-US" sz="1400" dirty="0" err="1">
+                    <a:solidFill>
+                      <a:schemeClr val="bg1"/>
+                    </a:solidFill>
+                    <a:latin typeface="Times New Roman" panose="02020603050405020304" pitchFamily="18" charset="0"/>
+                    <a:cs typeface="Times New Roman" panose="02020603050405020304" pitchFamily="18" charset="0"/>
+                  </a:rPr>
+                  <a:t>Duranta</a:t>
+                </a:r>
+                <a:r>
                   <a:rPr lang="en-US" sz="1400" dirty="0">
                     <a:solidFill>
                       <a:schemeClr val="bg1"/>
@@ -17749,7 +18061,7 @@
                     <a:latin typeface="Times New Roman" panose="02020603050405020304" pitchFamily="18" charset="0"/>
                     <a:cs typeface="Times New Roman" panose="02020603050405020304" pitchFamily="18" charset="0"/>
                   </a:rPr>
-                  <a:t>OAI : RF Simulator</a:t>
+                  <a:t> : RF Simulator</a:t>
                 </a:r>
               </a:p>
             </p:txBody>

</xml_diff>